<commit_message>
docs: persona value deck + enrich the tiers deck (graphics)
New: adr-033-persona-value-deck.pptx (+ .md companion) — how four personas
(doctor, med student, screenwriter, security architect) get value via the
learn → author → carry loop; 6 slides with role-badge glyphs, per-persona
library tags, colour-coded loop steps, and a payoff line each.

Enriched: adr-033-tiers-presentation.pptx now 6 slides — added drawn icons to
every callout, a device motif on the title slide, and a new 'one day, three
devices' journey slide (phone draft → private library → tablet → laptop).

Pointers updated from ADR-033 and the .md companions. Interactive web artifacts
published separately. Both decks rendered + visually verified via LibreOffice.

Co-Authored-By: Claude Opus 4.8 (1M context) <noreply@anthropic.com>
</commit_message>
<xml_diff>
--- a/docs/adr-033-tiers-presentation.pptx
+++ b/docs/adr-033-tiers-presentation.pptx
@@ -10,6 +10,7 @@
     <p:sldId id="258" r:id="rId9"/>
     <p:sldId id="259" r:id="rId11"/>
     <p:sldId id="260" r:id="rId12"/>
+    <p:sldId id="261" r:id="rId13"/>
   </p:sldIdLst>
   <p:sldSz cx="12191695" cy="6858000" type="screen4x3"/>
   <p:notesSz cx="6858000" cy="9144000"/>
@@ -4028,7 +4029,416 @@
       </p:sp>
       <p:sp>
         <p:nvSpPr>
-          <p:cNvPr id="14" name="TextBox 13"/>
+          <p:cNvPr id="14" name="Rounded Rectangle 13"/>
+          <p:cNvSpPr/>
+          <p:nvPr/>
+        </p:nvSpPr>
+        <p:spPr>
+          <a:xfrm>
+            <a:off x="7936992" y="4315968"/>
+            <a:ext cx="950976" cy="950976"/>
+          </a:xfrm>
+          <a:prstGeom prst="roundRect">
+            <a:avLst>
+              <a:gd name="adj" fmla="val 14000"/>
+            </a:avLst>
+          </a:prstGeom>
+          <a:solidFill>
+            <a:srgbClr val="FFFFFF"/>
+          </a:solidFill>
+          <a:ln w="12700">
+            <a:solidFill>
+              <a:srgbClr val="E1DDD2"/>
+            </a:solidFill>
+          </a:ln>
+          <a:effectLst/>
+        </p:spPr>
+        <p:style>
+          <a:lnRef idx="1">
+            <a:schemeClr val="accent1"/>
+          </a:lnRef>
+          <a:fillRef idx="3">
+            <a:schemeClr val="accent1"/>
+          </a:fillRef>
+          <a:effectRef idx="2">
+            <a:schemeClr val="accent1"/>
+          </a:effectRef>
+          <a:fontRef idx="minor">
+            <a:schemeClr val="lt1"/>
+          </a:fontRef>
+        </p:style>
+        <p:txBody>
+          <a:bodyPr rtlCol="0" anchor="ctr"/>
+          <a:lstStyle/>
+          <a:p>
+            <a:pPr algn="ctr"/>
+          </a:p>
+        </p:txBody>
+      </p:sp>
+      <p:sp>
+        <p:nvSpPr>
+          <p:cNvPr id="15" name="Rounded Rectangle 14"/>
+          <p:cNvSpPr/>
+          <p:nvPr/>
+        </p:nvSpPr>
+        <p:spPr>
+          <a:xfrm>
+            <a:off x="8293607" y="4608576"/>
+            <a:ext cx="237744" cy="365760"/>
+          </a:xfrm>
+          <a:prstGeom prst="roundRect">
+            <a:avLst>
+              <a:gd name="adj" fmla="val 20000"/>
+            </a:avLst>
+          </a:prstGeom>
+          <a:noFill/>
+          <a:ln w="25400">
+            <a:solidFill>
+              <a:srgbClr val="2E4A6B"/>
+            </a:solidFill>
+          </a:ln>
+          <a:effectLst/>
+        </p:spPr>
+        <p:style>
+          <a:lnRef idx="1">
+            <a:schemeClr val="accent1"/>
+          </a:lnRef>
+          <a:fillRef idx="3">
+            <a:schemeClr val="accent1"/>
+          </a:fillRef>
+          <a:effectRef idx="2">
+            <a:schemeClr val="accent1"/>
+          </a:effectRef>
+          <a:fontRef idx="minor">
+            <a:schemeClr val="lt1"/>
+          </a:fontRef>
+        </p:style>
+        <p:txBody>
+          <a:bodyPr rtlCol="0" anchor="ctr"/>
+          <a:lstStyle/>
+          <a:p>
+            <a:pPr algn="ctr"/>
+          </a:p>
+        </p:txBody>
+      </p:sp>
+      <p:sp>
+        <p:nvSpPr>
+          <p:cNvPr id="16" name="Rectangle 15"/>
+          <p:cNvSpPr/>
+          <p:nvPr/>
+        </p:nvSpPr>
+        <p:spPr>
+          <a:xfrm>
+            <a:off x="8371331" y="4892040"/>
+            <a:ext cx="82296" cy="22860"/>
+          </a:xfrm>
+          <a:prstGeom prst="rect">
+            <a:avLst/>
+          </a:prstGeom>
+          <a:solidFill>
+            <a:srgbClr val="2E4A6B"/>
+          </a:solidFill>
+          <a:ln>
+            <a:noFill/>
+          </a:ln>
+          <a:effectLst/>
+        </p:spPr>
+        <p:style>
+          <a:lnRef idx="1">
+            <a:schemeClr val="accent1"/>
+          </a:lnRef>
+          <a:fillRef idx="3">
+            <a:schemeClr val="accent1"/>
+          </a:fillRef>
+          <a:effectRef idx="2">
+            <a:schemeClr val="accent1"/>
+          </a:effectRef>
+          <a:fontRef idx="minor">
+            <a:schemeClr val="lt1"/>
+          </a:fontRef>
+        </p:style>
+        <p:txBody>
+          <a:bodyPr rtlCol="0" anchor="ctr"/>
+          <a:lstStyle/>
+          <a:p>
+            <a:pPr algn="ctr"/>
+          </a:p>
+        </p:txBody>
+      </p:sp>
+      <p:sp>
+        <p:nvSpPr>
+          <p:cNvPr id="17" name="Rounded Rectangle 16"/>
+          <p:cNvSpPr/>
+          <p:nvPr/>
+        </p:nvSpPr>
+        <p:spPr>
+          <a:xfrm>
+            <a:off x="9015984" y="4315968"/>
+            <a:ext cx="950976" cy="950976"/>
+          </a:xfrm>
+          <a:prstGeom prst="roundRect">
+            <a:avLst>
+              <a:gd name="adj" fmla="val 14000"/>
+            </a:avLst>
+          </a:prstGeom>
+          <a:solidFill>
+            <a:srgbClr val="FFFFFF"/>
+          </a:solidFill>
+          <a:ln w="12700">
+            <a:solidFill>
+              <a:srgbClr val="E1DDD2"/>
+            </a:solidFill>
+          </a:ln>
+          <a:effectLst/>
+        </p:spPr>
+        <p:style>
+          <a:lnRef idx="1">
+            <a:schemeClr val="accent1"/>
+          </a:lnRef>
+          <a:fillRef idx="3">
+            <a:schemeClr val="accent1"/>
+          </a:fillRef>
+          <a:effectRef idx="2">
+            <a:schemeClr val="accent1"/>
+          </a:effectRef>
+          <a:fontRef idx="minor">
+            <a:schemeClr val="lt1"/>
+          </a:fontRef>
+        </p:style>
+        <p:txBody>
+          <a:bodyPr rtlCol="0" anchor="ctr"/>
+          <a:lstStyle/>
+          <a:p>
+            <a:pPr algn="ctr"/>
+          </a:p>
+        </p:txBody>
+      </p:sp>
+      <p:sp>
+        <p:nvSpPr>
+          <p:cNvPr id="18" name="Rounded Rectangle 17"/>
+          <p:cNvSpPr/>
+          <p:nvPr/>
+        </p:nvSpPr>
+        <p:spPr>
+          <a:xfrm>
+            <a:off x="9308592" y="4645152"/>
+            <a:ext cx="365760" cy="292608"/>
+          </a:xfrm>
+          <a:prstGeom prst="roundRect">
+            <a:avLst>
+              <a:gd name="adj" fmla="val 12000"/>
+            </a:avLst>
+          </a:prstGeom>
+          <a:noFill/>
+          <a:ln w="25400">
+            <a:solidFill>
+              <a:srgbClr val="2E4A6B"/>
+            </a:solidFill>
+          </a:ln>
+          <a:effectLst/>
+        </p:spPr>
+        <p:style>
+          <a:lnRef idx="1">
+            <a:schemeClr val="accent1"/>
+          </a:lnRef>
+          <a:fillRef idx="3">
+            <a:schemeClr val="accent1"/>
+          </a:fillRef>
+          <a:effectRef idx="2">
+            <a:schemeClr val="accent1"/>
+          </a:effectRef>
+          <a:fontRef idx="minor">
+            <a:schemeClr val="lt1"/>
+          </a:fontRef>
+        </p:style>
+        <p:txBody>
+          <a:bodyPr rtlCol="0" anchor="ctr"/>
+          <a:lstStyle/>
+          <a:p>
+            <a:pPr algn="ctr"/>
+          </a:p>
+        </p:txBody>
+      </p:sp>
+      <p:sp>
+        <p:nvSpPr>
+          <p:cNvPr id="19" name="Rounded Rectangle 18"/>
+          <p:cNvSpPr/>
+          <p:nvPr/>
+        </p:nvSpPr>
+        <p:spPr>
+          <a:xfrm>
+            <a:off x="10094976" y="4315968"/>
+            <a:ext cx="950976" cy="950976"/>
+          </a:xfrm>
+          <a:prstGeom prst="roundRect">
+            <a:avLst>
+              <a:gd name="adj" fmla="val 14000"/>
+            </a:avLst>
+          </a:prstGeom>
+          <a:solidFill>
+            <a:srgbClr val="FFFFFF"/>
+          </a:solidFill>
+          <a:ln w="12700">
+            <a:solidFill>
+              <a:srgbClr val="E1DDD2"/>
+            </a:solidFill>
+          </a:ln>
+          <a:effectLst/>
+        </p:spPr>
+        <p:style>
+          <a:lnRef idx="1">
+            <a:schemeClr val="accent1"/>
+          </a:lnRef>
+          <a:fillRef idx="3">
+            <a:schemeClr val="accent1"/>
+          </a:fillRef>
+          <a:effectRef idx="2">
+            <a:schemeClr val="accent1"/>
+          </a:effectRef>
+          <a:fontRef idx="minor">
+            <a:schemeClr val="lt1"/>
+          </a:fontRef>
+        </p:style>
+        <p:txBody>
+          <a:bodyPr rtlCol="0" anchor="ctr"/>
+          <a:lstStyle/>
+          <a:p>
+            <a:pPr algn="ctr"/>
+          </a:p>
+        </p:txBody>
+      </p:sp>
+      <p:sp>
+        <p:nvSpPr>
+          <p:cNvPr id="20" name="Rounded Rectangle 19"/>
+          <p:cNvSpPr/>
+          <p:nvPr/>
+        </p:nvSpPr>
+        <p:spPr>
+          <a:xfrm>
+            <a:off x="10387584" y="4608576"/>
+            <a:ext cx="365760" cy="274320"/>
+          </a:xfrm>
+          <a:prstGeom prst="roundRect">
+            <a:avLst>
+              <a:gd name="adj" fmla="val 10000"/>
+            </a:avLst>
+          </a:prstGeom>
+          <a:noFill/>
+          <a:ln w="25400">
+            <a:solidFill>
+              <a:srgbClr val="2E4A6B"/>
+            </a:solidFill>
+          </a:ln>
+          <a:effectLst/>
+        </p:spPr>
+        <p:style>
+          <a:lnRef idx="1">
+            <a:schemeClr val="accent1"/>
+          </a:lnRef>
+          <a:fillRef idx="3">
+            <a:schemeClr val="accent1"/>
+          </a:fillRef>
+          <a:effectRef idx="2">
+            <a:schemeClr val="accent1"/>
+          </a:effectRef>
+          <a:fontRef idx="minor">
+            <a:schemeClr val="lt1"/>
+          </a:fontRef>
+        </p:style>
+        <p:txBody>
+          <a:bodyPr rtlCol="0" anchor="ctr"/>
+          <a:lstStyle/>
+          <a:p>
+            <a:pPr algn="ctr"/>
+          </a:p>
+        </p:txBody>
+      </p:sp>
+      <p:sp>
+        <p:nvSpPr>
+          <p:cNvPr id="21" name="Rectangle 20"/>
+          <p:cNvSpPr/>
+          <p:nvPr/>
+        </p:nvSpPr>
+        <p:spPr>
+          <a:xfrm>
+            <a:off x="10323576" y="4882896"/>
+            <a:ext cx="493776" cy="45720"/>
+          </a:xfrm>
+          <a:prstGeom prst="rect">
+            <a:avLst/>
+          </a:prstGeom>
+          <a:solidFill>
+            <a:srgbClr val="2E4A6B"/>
+          </a:solidFill>
+          <a:ln>
+            <a:noFill/>
+          </a:ln>
+          <a:effectLst/>
+        </p:spPr>
+        <p:style>
+          <a:lnRef idx="1">
+            <a:schemeClr val="accent1"/>
+          </a:lnRef>
+          <a:fillRef idx="3">
+            <a:schemeClr val="accent1"/>
+          </a:fillRef>
+          <a:effectRef idx="2">
+            <a:schemeClr val="accent1"/>
+          </a:effectRef>
+          <a:fontRef idx="minor">
+            <a:schemeClr val="lt1"/>
+          </a:fontRef>
+        </p:style>
+        <p:txBody>
+          <a:bodyPr rtlCol="0" anchor="ctr"/>
+          <a:lstStyle/>
+          <a:p>
+            <a:pPr algn="ctr"/>
+          </a:p>
+        </p:txBody>
+      </p:sp>
+      <p:sp>
+        <p:nvSpPr>
+          <p:cNvPr id="22" name="TextBox 21"/>
+          <p:cNvSpPr txBox="1"/>
+          <p:nvPr/>
+        </p:nvSpPr>
+        <p:spPr>
+          <a:xfrm>
+            <a:off x="7863840" y="5413248"/>
+            <a:ext cx="3566160" cy="320040"/>
+          </a:xfrm>
+          <a:prstGeom prst="rect">
+            <a:avLst/>
+          </a:prstGeom>
+          <a:noFill/>
+        </p:spPr>
+        <p:txBody>
+          <a:bodyPr wrap="square" anchor="t" lIns="0" rIns="0" tIns="0" bIns="0">
+            <a:spAutoFit/>
+          </a:bodyPr>
+          <a:lstStyle/>
+          <a:p>
+            <a:pPr algn="ctr">
+              <a:spcAft>
+                <a:spcPts val="0"/>
+              </a:spcAft>
+            </a:pPr>
+            <a:r>
+              <a:rPr sz="1050" b="0" i="1">
+                <a:solidFill>
+                  <a:srgbClr val="5B6470"/>
+                </a:solidFill>
+                <a:latin typeface="Calibri"/>
+              </a:rPr>
+              <a:t>your library, on every device</a:t>
+            </a:r>
+          </a:p>
+        </p:txBody>
+      </p:sp>
+      <p:sp>
+        <p:nvSpPr>
+          <p:cNvPr id="23" name="TextBox 22"/>
           <p:cNvSpPr txBox="1"/>
           <p:nvPr/>
         </p:nvSpPr>
@@ -4877,16 +5287,62 @@
       </p:sp>
       <p:sp>
         <p:nvSpPr>
-          <p:cNvPr id="20" name="Oval 19"/>
+          <p:cNvPr id="20" name="Rounded Rectangle 19"/>
           <p:cNvSpPr/>
           <p:nvPr/>
         </p:nvSpPr>
         <p:spPr>
           <a:xfrm>
-            <a:off x="4178808" y="2761488"/>
-            <a:ext cx="146304" cy="146304"/>
-          </a:xfrm>
-          <a:prstGeom prst="ellipse">
+            <a:off x="4133088" y="2651760"/>
+            <a:ext cx="237744" cy="365760"/>
+          </a:xfrm>
+          <a:prstGeom prst="roundRect">
+            <a:avLst>
+              <a:gd name="adj" fmla="val 20000"/>
+            </a:avLst>
+          </a:prstGeom>
+          <a:noFill/>
+          <a:ln w="25400">
+            <a:solidFill>
+              <a:srgbClr val="2F8F83"/>
+            </a:solidFill>
+          </a:ln>
+          <a:effectLst/>
+        </p:spPr>
+        <p:style>
+          <a:lnRef idx="1">
+            <a:schemeClr val="accent1"/>
+          </a:lnRef>
+          <a:fillRef idx="3">
+            <a:schemeClr val="accent1"/>
+          </a:fillRef>
+          <a:effectRef idx="2">
+            <a:schemeClr val="accent1"/>
+          </a:effectRef>
+          <a:fontRef idx="minor">
+            <a:schemeClr val="lt1"/>
+          </a:fontRef>
+        </p:style>
+        <p:txBody>
+          <a:bodyPr rtlCol="0" anchor="ctr"/>
+          <a:lstStyle/>
+          <a:p>
+            <a:pPr algn="ctr"/>
+          </a:p>
+        </p:txBody>
+      </p:sp>
+      <p:sp>
+        <p:nvSpPr>
+          <p:cNvPr id="21" name="Rectangle 20"/>
+          <p:cNvSpPr/>
+          <p:nvPr/>
+        </p:nvSpPr>
+        <p:spPr>
+          <a:xfrm>
+            <a:off x="4210812" y="2935224"/>
+            <a:ext cx="82296" cy="22860"/>
+          </a:xfrm>
+          <a:prstGeom prst="rect">
             <a:avLst/>
           </a:prstGeom>
           <a:solidFill>
@@ -4921,7 +5377,7 @@
       </p:sp>
       <p:sp>
         <p:nvSpPr>
-          <p:cNvPr id="21" name="TextBox 20"/>
+          <p:cNvPr id="22" name="TextBox 21"/>
           <p:cNvSpPr txBox="1"/>
           <p:nvPr/>
         </p:nvSpPr>
@@ -4979,7 +5435,7 @@
       </p:sp>
       <p:sp>
         <p:nvSpPr>
-          <p:cNvPr id="22" name="Rounded Rectangle 21"/>
+          <p:cNvPr id="23" name="Rounded Rectangle 22"/>
           <p:cNvSpPr/>
           <p:nvPr/>
         </p:nvSpPr>
@@ -5027,16 +5483,16 @@
       </p:sp>
       <p:sp>
         <p:nvSpPr>
-          <p:cNvPr id="23" name="Oval 22"/>
+          <p:cNvPr id="24" name="Block Arc 23"/>
           <p:cNvSpPr/>
           <p:nvPr/>
         </p:nvSpPr>
         <p:spPr>
           <a:xfrm>
-            <a:off x="4178808" y="3749040"/>
-            <a:ext cx="146304" cy="146304"/>
-          </a:xfrm>
-          <a:prstGeom prst="ellipse">
+            <a:off x="4069080" y="3675887"/>
+            <a:ext cx="365760" cy="365760"/>
+          </a:xfrm>
+          <a:prstGeom prst="blockArc">
             <a:avLst/>
           </a:prstGeom>
           <a:solidFill>
@@ -5071,7 +5527,97 @@
       </p:sp>
       <p:sp>
         <p:nvSpPr>
-          <p:cNvPr id="24" name="TextBox 23"/>
+          <p:cNvPr id="25" name="Oval 24"/>
+          <p:cNvSpPr/>
+          <p:nvPr/>
+        </p:nvSpPr>
+        <p:spPr>
+          <a:xfrm>
+            <a:off x="4206240" y="3895344"/>
+            <a:ext cx="91440" cy="91440"/>
+          </a:xfrm>
+          <a:prstGeom prst="ellipse">
+            <a:avLst/>
+          </a:prstGeom>
+          <a:solidFill>
+            <a:srgbClr val="2F8F83"/>
+          </a:solidFill>
+          <a:ln>
+            <a:noFill/>
+          </a:ln>
+          <a:effectLst/>
+        </p:spPr>
+        <p:style>
+          <a:lnRef idx="1">
+            <a:schemeClr val="accent1"/>
+          </a:lnRef>
+          <a:fillRef idx="3">
+            <a:schemeClr val="accent1"/>
+          </a:fillRef>
+          <a:effectRef idx="2">
+            <a:schemeClr val="accent1"/>
+          </a:effectRef>
+          <a:fontRef idx="minor">
+            <a:schemeClr val="lt1"/>
+          </a:fontRef>
+        </p:style>
+        <p:txBody>
+          <a:bodyPr rtlCol="0" anchor="ctr"/>
+          <a:lstStyle/>
+          <a:p>
+            <a:pPr algn="ctr"/>
+          </a:p>
+        </p:txBody>
+      </p:sp>
+      <p:sp>
+        <p:nvSpPr>
+          <p:cNvPr id="26" name="Rectangle 25"/>
+          <p:cNvSpPr/>
+          <p:nvPr/>
+        </p:nvSpPr>
+        <p:spPr>
+          <a:xfrm rot="2700000">
+            <a:off x="4233672" y="3584448"/>
+            <a:ext cx="41148" cy="457200"/>
+          </a:xfrm>
+          <a:prstGeom prst="rect">
+            <a:avLst/>
+          </a:prstGeom>
+          <a:solidFill>
+            <a:srgbClr val="FFFFFF"/>
+          </a:solidFill>
+          <a:ln w="9525">
+            <a:solidFill>
+              <a:srgbClr val="2F8F83"/>
+            </a:solidFill>
+          </a:ln>
+          <a:effectLst/>
+        </p:spPr>
+        <p:style>
+          <a:lnRef idx="1">
+            <a:schemeClr val="accent1"/>
+          </a:lnRef>
+          <a:fillRef idx="3">
+            <a:schemeClr val="accent1"/>
+          </a:fillRef>
+          <a:effectRef idx="2">
+            <a:schemeClr val="accent1"/>
+          </a:effectRef>
+          <a:fontRef idx="minor">
+            <a:schemeClr val="lt1"/>
+          </a:fontRef>
+        </p:style>
+        <p:txBody>
+          <a:bodyPr rtlCol="0" anchor="ctr"/>
+          <a:lstStyle/>
+          <a:p>
+            <a:pPr algn="ctr"/>
+          </a:p>
+        </p:txBody>
+      </p:sp>
+      <p:sp>
+        <p:nvSpPr>
+          <p:cNvPr id="27" name="TextBox 26"/>
           <p:cNvSpPr txBox="1"/>
           <p:nvPr/>
         </p:nvSpPr>
@@ -5129,7 +5675,7 @@
       </p:sp>
       <p:sp>
         <p:nvSpPr>
-          <p:cNvPr id="25" name="Rounded Rectangle 24"/>
+          <p:cNvPr id="28" name="Rounded Rectangle 27"/>
           <p:cNvSpPr/>
           <p:nvPr/>
         </p:nvSpPr>
@@ -5177,17 +5723,63 @@
       </p:sp>
       <p:sp>
         <p:nvSpPr>
-          <p:cNvPr id="26" name="Oval 25"/>
+          <p:cNvPr id="29" name="Oval 28"/>
           <p:cNvSpPr/>
           <p:nvPr/>
         </p:nvSpPr>
         <p:spPr>
           <a:xfrm>
-            <a:off x="4178808" y="4736592"/>
-            <a:ext cx="146304" cy="146304"/>
+            <a:off x="4142232" y="4608576"/>
+            <a:ext cx="219456" cy="219456"/>
           </a:xfrm>
           <a:prstGeom prst="ellipse">
             <a:avLst/>
+          </a:prstGeom>
+          <a:noFill/>
+          <a:ln w="25400">
+            <a:solidFill>
+              <a:srgbClr val="2F8F83"/>
+            </a:solidFill>
+          </a:ln>
+          <a:effectLst/>
+        </p:spPr>
+        <p:style>
+          <a:lnRef idx="1">
+            <a:schemeClr val="accent1"/>
+          </a:lnRef>
+          <a:fillRef idx="3">
+            <a:schemeClr val="accent1"/>
+          </a:fillRef>
+          <a:effectRef idx="2">
+            <a:schemeClr val="accent1"/>
+          </a:effectRef>
+          <a:fontRef idx="minor">
+            <a:schemeClr val="lt1"/>
+          </a:fontRef>
+        </p:style>
+        <p:txBody>
+          <a:bodyPr rtlCol="0" anchor="ctr"/>
+          <a:lstStyle/>
+          <a:p>
+            <a:pPr algn="ctr"/>
+          </a:p>
+        </p:txBody>
+      </p:sp>
+      <p:sp>
+        <p:nvSpPr>
+          <p:cNvPr id="30" name="Rounded Rectangle 29"/>
+          <p:cNvSpPr/>
+          <p:nvPr/>
+        </p:nvSpPr>
+        <p:spPr>
+          <a:xfrm>
+            <a:off x="4105656" y="4754880"/>
+            <a:ext cx="292608" cy="256032"/>
+          </a:xfrm>
+          <a:prstGeom prst="roundRect">
+            <a:avLst>
+              <a:gd name="adj" fmla="val 18000"/>
+            </a:avLst>
           </a:prstGeom>
           <a:solidFill>
             <a:srgbClr val="2F8F83"/>
@@ -5221,7 +5813,51 @@
       </p:sp>
       <p:sp>
         <p:nvSpPr>
-          <p:cNvPr id="27" name="TextBox 26"/>
+          <p:cNvPr id="31" name="Oval 30"/>
+          <p:cNvSpPr/>
+          <p:nvPr/>
+        </p:nvSpPr>
+        <p:spPr>
+          <a:xfrm>
+            <a:off x="4219956" y="4837176"/>
+            <a:ext cx="64008" cy="64008"/>
+          </a:xfrm>
+          <a:prstGeom prst="ellipse">
+            <a:avLst/>
+          </a:prstGeom>
+          <a:solidFill>
+            <a:srgbClr val="FFFFFF"/>
+          </a:solidFill>
+          <a:ln>
+            <a:noFill/>
+          </a:ln>
+          <a:effectLst/>
+        </p:spPr>
+        <p:style>
+          <a:lnRef idx="1">
+            <a:schemeClr val="accent1"/>
+          </a:lnRef>
+          <a:fillRef idx="3">
+            <a:schemeClr val="accent1"/>
+          </a:fillRef>
+          <a:effectRef idx="2">
+            <a:schemeClr val="accent1"/>
+          </a:effectRef>
+          <a:fontRef idx="minor">
+            <a:schemeClr val="lt1"/>
+          </a:fontRef>
+        </p:style>
+        <p:txBody>
+          <a:bodyPr rtlCol="0" anchor="ctr"/>
+          <a:lstStyle/>
+          <a:p>
+            <a:pPr algn="ctr"/>
+          </a:p>
+        </p:txBody>
+      </p:sp>
+      <p:sp>
+        <p:nvSpPr>
+          <p:cNvPr id="32" name="TextBox 31"/>
           <p:cNvSpPr txBox="1"/>
           <p:nvPr/>
         </p:nvSpPr>
@@ -5279,7 +5915,7 @@
       </p:sp>
       <p:sp>
         <p:nvSpPr>
-          <p:cNvPr id="28" name="Rounded Rectangle 27"/>
+          <p:cNvPr id="33" name="Rounded Rectangle 32"/>
           <p:cNvSpPr/>
           <p:nvPr/>
         </p:nvSpPr>
@@ -5327,16 +5963,16 @@
       </p:sp>
       <p:sp>
         <p:nvSpPr>
-          <p:cNvPr id="29" name="Oval 28"/>
+          <p:cNvPr id="34" name="5-Point Star 33"/>
           <p:cNvSpPr/>
           <p:nvPr/>
         </p:nvSpPr>
         <p:spPr>
           <a:xfrm>
-            <a:off x="4178808" y="5724144"/>
-            <a:ext cx="146304" cy="146304"/>
-          </a:xfrm>
-          <a:prstGeom prst="ellipse">
+            <a:off x="4069080" y="5614416"/>
+            <a:ext cx="365760" cy="365760"/>
+          </a:xfrm>
+          <a:prstGeom prst="star5">
             <a:avLst/>
           </a:prstGeom>
           <a:solidFill>
@@ -5371,7 +6007,7 @@
       </p:sp>
       <p:sp>
         <p:nvSpPr>
-          <p:cNvPr id="30" name="TextBox 29"/>
+          <p:cNvPr id="35" name="TextBox 34"/>
           <p:cNvSpPr txBox="1"/>
           <p:nvPr/>
         </p:nvSpPr>
@@ -5748,23 +6384,27 @@
       </p:sp>
       <p:sp>
         <p:nvSpPr>
-          <p:cNvPr id="9" name="Oval 8"/>
+          <p:cNvPr id="9" name="Rounded Rectangle 8"/>
           <p:cNvSpPr/>
           <p:nvPr/>
         </p:nvSpPr>
         <p:spPr>
           <a:xfrm>
-            <a:off x="978408" y="2670048"/>
-            <a:ext cx="146304" cy="146304"/>
-          </a:xfrm>
-          <a:prstGeom prst="ellipse">
-            <a:avLst/>
+            <a:off x="1033271" y="2569464"/>
+            <a:ext cx="201168" cy="329184"/>
+          </a:xfrm>
+          <a:prstGeom prst="roundRect">
+            <a:avLst>
+              <a:gd name="adj" fmla="val 15000"/>
+            </a:avLst>
           </a:prstGeom>
           <a:solidFill>
-            <a:srgbClr val="B5822E"/>
+            <a:srgbClr val="FFFFFF"/>
           </a:solidFill>
-          <a:ln>
-            <a:noFill/>
+          <a:ln w="25400">
+            <a:solidFill>
+              <a:srgbClr val="B5822E"/>
+            </a:solidFill>
           </a:ln>
           <a:effectLst/>
         </p:spPr>
@@ -5792,7 +6432,55 @@
       </p:sp>
       <p:sp>
         <p:nvSpPr>
-          <p:cNvPr id="10" name="TextBox 9"/>
+          <p:cNvPr id="10" name="Rounded Rectangle 9"/>
+          <p:cNvSpPr/>
+          <p:nvPr/>
+        </p:nvSpPr>
+        <p:spPr>
+          <a:xfrm>
+            <a:off x="868680" y="2688336"/>
+            <a:ext cx="146304" cy="237744"/>
+          </a:xfrm>
+          <a:prstGeom prst="roundRect">
+            <a:avLst>
+              <a:gd name="adj" fmla="val 18000"/>
+            </a:avLst>
+          </a:prstGeom>
+          <a:solidFill>
+            <a:srgbClr val="FFFFFF"/>
+          </a:solidFill>
+          <a:ln w="25400">
+            <a:solidFill>
+              <a:srgbClr val="B5822E"/>
+            </a:solidFill>
+          </a:ln>
+          <a:effectLst/>
+        </p:spPr>
+        <p:style>
+          <a:lnRef idx="1">
+            <a:schemeClr val="accent1"/>
+          </a:lnRef>
+          <a:fillRef idx="3">
+            <a:schemeClr val="accent1"/>
+          </a:fillRef>
+          <a:effectRef idx="2">
+            <a:schemeClr val="accent1"/>
+          </a:effectRef>
+          <a:fontRef idx="minor">
+            <a:schemeClr val="lt1"/>
+          </a:fontRef>
+        </p:style>
+        <p:txBody>
+          <a:bodyPr rtlCol="0" anchor="ctr"/>
+          <a:lstStyle/>
+          <a:p>
+            <a:pPr algn="ctr"/>
+          </a:p>
+        </p:txBody>
+      </p:sp>
+      <p:sp>
+        <p:nvSpPr>
+          <p:cNvPr id="11" name="TextBox 10"/>
           <p:cNvSpPr txBox="1"/>
           <p:nvPr/>
         </p:nvSpPr>
@@ -5850,7 +6538,7 @@
       </p:sp>
       <p:sp>
         <p:nvSpPr>
-          <p:cNvPr id="11" name="Rounded Rectangle 10"/>
+          <p:cNvPr id="12" name="Rounded Rectangle 11"/>
           <p:cNvSpPr/>
           <p:nvPr/>
         </p:nvSpPr>
@@ -5898,17 +6586,63 @@
       </p:sp>
       <p:sp>
         <p:nvSpPr>
-          <p:cNvPr id="12" name="Oval 11"/>
+          <p:cNvPr id="13" name="Oval 12"/>
           <p:cNvSpPr/>
           <p:nvPr/>
         </p:nvSpPr>
         <p:spPr>
           <a:xfrm>
-            <a:off x="978408" y="3630168"/>
-            <a:ext cx="146304" cy="146304"/>
+            <a:off x="896111" y="3529584"/>
+            <a:ext cx="256032" cy="256032"/>
           </a:xfrm>
           <a:prstGeom prst="ellipse">
             <a:avLst/>
+          </a:prstGeom>
+          <a:noFill/>
+          <a:ln w="25400">
+            <a:solidFill>
+              <a:srgbClr val="B5822E"/>
+            </a:solidFill>
+          </a:ln>
+          <a:effectLst/>
+        </p:spPr>
+        <p:style>
+          <a:lnRef idx="1">
+            <a:schemeClr val="accent1"/>
+          </a:lnRef>
+          <a:fillRef idx="3">
+            <a:schemeClr val="accent1"/>
+          </a:fillRef>
+          <a:effectRef idx="2">
+            <a:schemeClr val="accent1"/>
+          </a:effectRef>
+          <a:fontRef idx="minor">
+            <a:schemeClr val="lt1"/>
+          </a:fontRef>
+        </p:style>
+        <p:txBody>
+          <a:bodyPr rtlCol="0" anchor="ctr"/>
+          <a:lstStyle/>
+          <a:p>
+            <a:pPr algn="ctr"/>
+          </a:p>
+        </p:txBody>
+      </p:sp>
+      <p:sp>
+        <p:nvSpPr>
+          <p:cNvPr id="14" name="Rounded Rectangle 13"/>
+          <p:cNvSpPr/>
+          <p:nvPr/>
+        </p:nvSpPr>
+        <p:spPr>
+          <a:xfrm rot="18900000">
+            <a:off x="1115568" y="3767328"/>
+            <a:ext cx="36576" cy="146304"/>
+          </a:xfrm>
+          <a:prstGeom prst="roundRect">
+            <a:avLst>
+              <a:gd name="adj" fmla="val 50000"/>
+            </a:avLst>
           </a:prstGeom>
           <a:solidFill>
             <a:srgbClr val="B5822E"/>
@@ -5942,7 +6676,7 @@
       </p:sp>
       <p:sp>
         <p:nvSpPr>
-          <p:cNvPr id="13" name="TextBox 12"/>
+          <p:cNvPr id="15" name="TextBox 14"/>
           <p:cNvSpPr txBox="1"/>
           <p:nvPr/>
         </p:nvSpPr>
@@ -6000,7 +6734,7 @@
       </p:sp>
       <p:sp>
         <p:nvSpPr>
-          <p:cNvPr id="14" name="Rounded Rectangle 13"/>
+          <p:cNvPr id="16" name="Rounded Rectangle 15"/>
           <p:cNvSpPr/>
           <p:nvPr/>
         </p:nvSpPr>
@@ -6048,17 +6782,63 @@
       </p:sp>
       <p:sp>
         <p:nvSpPr>
-          <p:cNvPr id="15" name="Oval 14"/>
+          <p:cNvPr id="17" name="Oval 16"/>
           <p:cNvSpPr/>
           <p:nvPr/>
         </p:nvSpPr>
         <p:spPr>
           <a:xfrm>
-            <a:off x="978408" y="4590288"/>
-            <a:ext cx="146304" cy="146304"/>
+            <a:off x="941831" y="4462272"/>
+            <a:ext cx="219456" cy="219456"/>
           </a:xfrm>
           <a:prstGeom prst="ellipse">
             <a:avLst/>
+          </a:prstGeom>
+          <a:noFill/>
+          <a:ln w="25400">
+            <a:solidFill>
+              <a:srgbClr val="B5822E"/>
+            </a:solidFill>
+          </a:ln>
+          <a:effectLst/>
+        </p:spPr>
+        <p:style>
+          <a:lnRef idx="1">
+            <a:schemeClr val="accent1"/>
+          </a:lnRef>
+          <a:fillRef idx="3">
+            <a:schemeClr val="accent1"/>
+          </a:fillRef>
+          <a:effectRef idx="2">
+            <a:schemeClr val="accent1"/>
+          </a:effectRef>
+          <a:fontRef idx="minor">
+            <a:schemeClr val="lt1"/>
+          </a:fontRef>
+        </p:style>
+        <p:txBody>
+          <a:bodyPr rtlCol="0" anchor="ctr"/>
+          <a:lstStyle/>
+          <a:p>
+            <a:pPr algn="ctr"/>
+          </a:p>
+        </p:txBody>
+      </p:sp>
+      <p:sp>
+        <p:nvSpPr>
+          <p:cNvPr id="18" name="Rounded Rectangle 17"/>
+          <p:cNvSpPr/>
+          <p:nvPr/>
+        </p:nvSpPr>
+        <p:spPr>
+          <a:xfrm>
+            <a:off x="905255" y="4608576"/>
+            <a:ext cx="292608" cy="256032"/>
+          </a:xfrm>
+          <a:prstGeom prst="roundRect">
+            <a:avLst>
+              <a:gd name="adj" fmla="val 18000"/>
+            </a:avLst>
           </a:prstGeom>
           <a:solidFill>
             <a:srgbClr val="B5822E"/>
@@ -6092,7 +6872,51 @@
       </p:sp>
       <p:sp>
         <p:nvSpPr>
-          <p:cNvPr id="16" name="TextBox 15"/>
+          <p:cNvPr id="19" name="Oval 18"/>
+          <p:cNvSpPr/>
+          <p:nvPr/>
+        </p:nvSpPr>
+        <p:spPr>
+          <a:xfrm>
+            <a:off x="1019556" y="4690872"/>
+            <a:ext cx="64008" cy="64008"/>
+          </a:xfrm>
+          <a:prstGeom prst="ellipse">
+            <a:avLst/>
+          </a:prstGeom>
+          <a:solidFill>
+            <a:srgbClr val="FFFFFF"/>
+          </a:solidFill>
+          <a:ln>
+            <a:noFill/>
+          </a:ln>
+          <a:effectLst/>
+        </p:spPr>
+        <p:style>
+          <a:lnRef idx="1">
+            <a:schemeClr val="accent1"/>
+          </a:lnRef>
+          <a:fillRef idx="3">
+            <a:schemeClr val="accent1"/>
+          </a:fillRef>
+          <a:effectRef idx="2">
+            <a:schemeClr val="accent1"/>
+          </a:effectRef>
+          <a:fontRef idx="minor">
+            <a:schemeClr val="lt1"/>
+          </a:fontRef>
+        </p:style>
+        <p:txBody>
+          <a:bodyPr rtlCol="0" anchor="ctr"/>
+          <a:lstStyle/>
+          <a:p>
+            <a:pPr algn="ctr"/>
+          </a:p>
+        </p:txBody>
+      </p:sp>
+      <p:sp>
+        <p:nvSpPr>
+          <p:cNvPr id="20" name="TextBox 19"/>
           <p:cNvSpPr txBox="1"/>
           <p:nvPr/>
         </p:nvSpPr>
@@ -6150,7 +6974,7 @@
       </p:sp>
       <p:sp>
         <p:nvSpPr>
-          <p:cNvPr id="17" name="Rounded Rectangle 16"/>
+          <p:cNvPr id="21" name="Rounded Rectangle 20"/>
           <p:cNvSpPr/>
           <p:nvPr/>
         </p:nvSpPr>
@@ -6198,16 +7022,16 @@
       </p:sp>
       <p:sp>
         <p:nvSpPr>
-          <p:cNvPr id="18" name="Oval 17"/>
+          <p:cNvPr id="22" name="Up Arrow 21"/>
           <p:cNvSpPr/>
           <p:nvPr/>
         </p:nvSpPr>
         <p:spPr>
           <a:xfrm>
-            <a:off x="978408" y="5550408"/>
-            <a:ext cx="146304" cy="146304"/>
-          </a:xfrm>
-          <a:prstGeom prst="ellipse">
+            <a:off x="914399" y="5440680"/>
+            <a:ext cx="274320" cy="365760"/>
+          </a:xfrm>
+          <a:prstGeom prst="upArrow">
             <a:avLst/>
           </a:prstGeom>
           <a:solidFill>
@@ -6242,7 +7066,7 @@
       </p:sp>
       <p:sp>
         <p:nvSpPr>
-          <p:cNvPr id="19" name="TextBox 18"/>
+          <p:cNvPr id="23" name="TextBox 22"/>
           <p:cNvSpPr txBox="1"/>
           <p:nvPr/>
         </p:nvSpPr>
@@ -6300,7 +7124,7 @@
       </p:sp>
       <p:sp>
         <p:nvSpPr>
-          <p:cNvPr id="20" name="Rounded Rectangle 19"/>
+          <p:cNvPr id="24" name="Rounded Rectangle 23"/>
           <p:cNvSpPr/>
           <p:nvPr/>
         </p:nvSpPr>
@@ -6348,7 +7172,7 @@
       </p:sp>
       <p:sp>
         <p:nvSpPr>
-          <p:cNvPr id="21" name="TextBox 20"/>
+          <p:cNvPr id="25" name="TextBox 24"/>
           <p:cNvSpPr txBox="1"/>
           <p:nvPr/>
         </p:nvSpPr>
@@ -6403,7 +7227,7 @@
       </p:sp>
       <p:sp>
         <p:nvSpPr>
-          <p:cNvPr id="22" name="Rounded Rectangle 21"/>
+          <p:cNvPr id="26" name="Rounded Rectangle 25"/>
           <p:cNvSpPr/>
           <p:nvPr/>
         </p:nvSpPr>
@@ -6449,7 +7273,7 @@
       </p:sp>
       <p:sp>
         <p:nvSpPr>
-          <p:cNvPr id="23" name="TextBox 22"/>
+          <p:cNvPr id="27" name="TextBox 26"/>
           <p:cNvSpPr txBox="1"/>
           <p:nvPr/>
         </p:nvSpPr>
@@ -6488,7 +7312,7 @@
       </p:sp>
       <p:sp>
         <p:nvSpPr>
-          <p:cNvPr id="24" name="Rounded Rectangle 23"/>
+          <p:cNvPr id="28" name="Rounded Rectangle 27"/>
           <p:cNvSpPr/>
           <p:nvPr/>
         </p:nvSpPr>
@@ -6534,7 +7358,7 @@
       </p:sp>
       <p:sp>
         <p:nvSpPr>
-          <p:cNvPr id="25" name="TextBox 24"/>
+          <p:cNvPr id="29" name="TextBox 28"/>
           <p:cNvSpPr txBox="1"/>
           <p:nvPr/>
         </p:nvSpPr>
@@ -6573,7 +7397,7 @@
       </p:sp>
       <p:sp>
         <p:nvSpPr>
-          <p:cNvPr id="26" name="Rounded Rectangle 25"/>
+          <p:cNvPr id="30" name="Rounded Rectangle 29"/>
           <p:cNvSpPr/>
           <p:nvPr/>
         </p:nvSpPr>
@@ -6619,7 +7443,7 @@
       </p:sp>
       <p:sp>
         <p:nvSpPr>
-          <p:cNvPr id="27" name="TextBox 26"/>
+          <p:cNvPr id="31" name="TextBox 30"/>
           <p:cNvSpPr txBox="1"/>
           <p:nvPr/>
         </p:nvSpPr>
@@ -6658,7 +7482,7 @@
       </p:sp>
       <p:sp>
         <p:nvSpPr>
-          <p:cNvPr id="28" name="Rounded Rectangle 27"/>
+          <p:cNvPr id="32" name="Rounded Rectangle 31"/>
           <p:cNvSpPr/>
           <p:nvPr/>
         </p:nvSpPr>
@@ -6704,7 +7528,7 @@
       </p:sp>
       <p:sp>
         <p:nvSpPr>
-          <p:cNvPr id="29" name="TextBox 28"/>
+          <p:cNvPr id="33" name="TextBox 32"/>
           <p:cNvSpPr txBox="1"/>
           <p:nvPr/>
         </p:nvSpPr>
@@ -6743,7 +7567,7 @@
       </p:sp>
       <p:sp>
         <p:nvSpPr>
-          <p:cNvPr id="30" name="Rounded Rectangle 29"/>
+          <p:cNvPr id="34" name="Rounded Rectangle 33"/>
           <p:cNvSpPr/>
           <p:nvPr/>
         </p:nvSpPr>
@@ -6791,7 +7615,7 @@
       </p:sp>
       <p:sp>
         <p:nvSpPr>
-          <p:cNvPr id="31" name="TextBox 30"/>
+          <p:cNvPr id="35" name="TextBox 34"/>
           <p:cNvSpPr txBox="1"/>
           <p:nvPr/>
         </p:nvSpPr>
@@ -6846,7 +7670,7 @@
       </p:sp>
       <p:sp>
         <p:nvSpPr>
-          <p:cNvPr id="32" name="Rounded Rectangle 31"/>
+          <p:cNvPr id="36" name="Rounded Rectangle 35"/>
           <p:cNvSpPr/>
           <p:nvPr/>
         </p:nvSpPr>
@@ -6892,7 +7716,7 @@
       </p:sp>
       <p:sp>
         <p:nvSpPr>
-          <p:cNvPr id="33" name="TextBox 32"/>
+          <p:cNvPr id="37" name="TextBox 36"/>
           <p:cNvSpPr txBox="1"/>
           <p:nvPr/>
         </p:nvSpPr>
@@ -6931,7 +7755,7 @@
       </p:sp>
       <p:sp>
         <p:nvSpPr>
-          <p:cNvPr id="34" name="Rounded Rectangle 33"/>
+          <p:cNvPr id="38" name="Rounded Rectangle 37"/>
           <p:cNvSpPr/>
           <p:nvPr/>
         </p:nvSpPr>
@@ -6977,7 +7801,7 @@
       </p:sp>
       <p:sp>
         <p:nvSpPr>
-          <p:cNvPr id="35" name="TextBox 34"/>
+          <p:cNvPr id="39" name="TextBox 38"/>
           <p:cNvSpPr txBox="1"/>
           <p:nvPr/>
         </p:nvSpPr>
@@ -7016,7 +7840,7 @@
       </p:sp>
       <p:sp>
         <p:nvSpPr>
-          <p:cNvPr id="36" name="Rounded Rectangle 35"/>
+          <p:cNvPr id="40" name="Rounded Rectangle 39"/>
           <p:cNvSpPr/>
           <p:nvPr/>
         </p:nvSpPr>
@@ -7064,7 +7888,7 @@
       </p:sp>
       <p:sp>
         <p:nvSpPr>
-          <p:cNvPr id="37" name="TextBox 36"/>
+          <p:cNvPr id="41" name="TextBox 40"/>
           <p:cNvSpPr txBox="1"/>
           <p:nvPr/>
         </p:nvSpPr>
@@ -7119,7 +7943,7 @@
       </p:sp>
       <p:sp>
         <p:nvSpPr>
-          <p:cNvPr id="38" name="Rounded Rectangle 37"/>
+          <p:cNvPr id="42" name="Rounded Rectangle 41"/>
           <p:cNvSpPr/>
           <p:nvPr/>
         </p:nvSpPr>
@@ -7165,7 +7989,7 @@
       </p:sp>
       <p:sp>
         <p:nvSpPr>
-          <p:cNvPr id="39" name="TextBox 38"/>
+          <p:cNvPr id="43" name="TextBox 42"/>
           <p:cNvSpPr txBox="1"/>
           <p:nvPr/>
         </p:nvSpPr>
@@ -7204,7 +8028,7 @@
       </p:sp>
       <p:sp>
         <p:nvSpPr>
-          <p:cNvPr id="40" name="Rounded Rectangle 39"/>
+          <p:cNvPr id="44" name="Rounded Rectangle 43"/>
           <p:cNvSpPr/>
           <p:nvPr/>
         </p:nvSpPr>
@@ -7250,7 +8074,7 @@
       </p:sp>
       <p:sp>
         <p:nvSpPr>
-          <p:cNvPr id="41" name="TextBox 40"/>
+          <p:cNvPr id="45" name="TextBox 44"/>
           <p:cNvSpPr txBox="1"/>
           <p:nvPr/>
         </p:nvSpPr>
@@ -7351,14 +8175,62 @@
       </p:sp>
       <p:sp>
         <p:nvSpPr>
-          <p:cNvPr id="3" name="TextBox 2"/>
+          <p:cNvPr id="3" name="Rounded Rectangle 2"/>
+          <p:cNvSpPr/>
+          <p:nvPr/>
+        </p:nvSpPr>
+        <p:spPr>
+          <a:xfrm>
+            <a:off x="822960" y="548640"/>
+            <a:ext cx="2176272" cy="384048"/>
+          </a:xfrm>
+          <a:prstGeom prst="roundRect">
+            <a:avLst>
+              <a:gd name="adj" fmla="val 50000"/>
+            </a:avLst>
+          </a:prstGeom>
+          <a:solidFill>
+            <a:srgbClr val="F6EEDD"/>
+          </a:solidFill>
+          <a:ln w="12700">
+            <a:solidFill>
+              <a:srgbClr val="B5822E"/>
+            </a:solidFill>
+          </a:ln>
+          <a:effectLst/>
+        </p:spPr>
+        <p:style>
+          <a:lnRef idx="1">
+            <a:schemeClr val="accent1"/>
+          </a:lnRef>
+          <a:fillRef idx="3">
+            <a:schemeClr val="accent1"/>
+          </a:fillRef>
+          <a:effectRef idx="2">
+            <a:schemeClr val="accent1"/>
+          </a:effectRef>
+          <a:fontRef idx="minor">
+            <a:schemeClr val="lt1"/>
+          </a:fontRef>
+        </p:style>
+        <p:txBody>
+          <a:bodyPr rtlCol="0" anchor="ctr"/>
+          <a:lstStyle/>
+          <a:p>
+            <a:pPr algn="ctr"/>
+          </a:p>
+        </p:txBody>
+      </p:sp>
+      <p:sp>
+        <p:nvSpPr>
+          <p:cNvPr id="4" name="TextBox 3"/>
           <p:cNvSpPr txBox="1"/>
           <p:nvPr/>
         </p:nvSpPr>
         <p:spPr>
           <a:xfrm>
-            <a:off x="822960" y="566928"/>
-            <a:ext cx="10515600" cy="365760"/>
+            <a:off x="822960" y="548640"/>
+            <a:ext cx="2176272" cy="384048"/>
           </a:xfrm>
           <a:prstGeom prst="rect">
             <a:avLst/>
@@ -7366,38 +8238,82 @@
           <a:noFill/>
         </p:spPr>
         <p:txBody>
-          <a:bodyPr wrap="square" anchor="t" lIns="0" rIns="0" tIns="0" bIns="0">
+          <a:bodyPr wrap="square" anchor="ctr" lIns="0" rIns="0" tIns="0" bIns="0">
             <a:spAutoFit/>
           </a:bodyPr>
           <a:lstStyle/>
           <a:p>
-            <a:pPr algn="l">
+            <a:pPr algn="ctr">
               <a:spcAft>
                 <a:spcPts val="0"/>
               </a:spcAft>
             </a:pPr>
             <a:r>
-              <a:rPr sz="1100" b="0" i="0">
+              <a:rPr sz="1200" b="1" i="0">
                 <a:solidFill>
-                  <a:srgbClr val="5B6470"/>
+                  <a:srgbClr val="B5822E"/>
                 </a:solidFill>
-                <a:latin typeface="Consolas"/>
+                <a:latin typeface="Calibri"/>
               </a:rPr>
-              <a:t>THREE PICTURES TO EXPLAIN IT</a:t>
-            </a:r>
-          </a:p>
-        </p:txBody>
-      </p:sp>
-      <p:sp>
-        <p:nvSpPr>
-          <p:cNvPr id="4" name="TextBox 3"/>
+              <a:t>  PAID · IN PRACTICE</a:t>
+            </a:r>
+          </a:p>
+        </p:txBody>
+      </p:sp>
+      <p:sp>
+        <p:nvSpPr>
+          <p:cNvPr id="5" name="Oval 4"/>
+          <p:cNvSpPr/>
+          <p:nvPr/>
+        </p:nvSpPr>
+        <p:spPr>
+          <a:xfrm>
+            <a:off x="950976" y="667512"/>
+            <a:ext cx="146304" cy="146304"/>
+          </a:xfrm>
+          <a:prstGeom prst="ellipse">
+            <a:avLst/>
+          </a:prstGeom>
+          <a:solidFill>
+            <a:srgbClr val="B5822E"/>
+          </a:solidFill>
+          <a:ln>
+            <a:noFill/>
+          </a:ln>
+          <a:effectLst/>
+        </p:spPr>
+        <p:style>
+          <a:lnRef idx="1">
+            <a:schemeClr val="accent1"/>
+          </a:lnRef>
+          <a:fillRef idx="3">
+            <a:schemeClr val="accent1"/>
+          </a:fillRef>
+          <a:effectRef idx="2">
+            <a:schemeClr val="accent1"/>
+          </a:effectRef>
+          <a:fontRef idx="minor">
+            <a:schemeClr val="lt1"/>
+          </a:fontRef>
+        </p:style>
+        <p:txBody>
+          <a:bodyPr rtlCol="0" anchor="ctr"/>
+          <a:lstStyle/>
+          <a:p>
+            <a:pPr algn="ctr"/>
+          </a:p>
+        </p:txBody>
+      </p:sp>
+      <p:sp>
+        <p:nvSpPr>
+          <p:cNvPr id="6" name="TextBox 5"/>
           <p:cNvSpPr txBox="1"/>
           <p:nvPr/>
         </p:nvSpPr>
         <p:spPr>
           <a:xfrm>
-            <a:off x="822960" y="914400"/>
-            <a:ext cx="10515600" cy="822960"/>
+            <a:off x="822960" y="1051560"/>
+            <a:ext cx="10515600" cy="640080"/>
           </a:xfrm>
           <a:prstGeom prst="rect">
             <a:avLst/>
@@ -7422,20 +8338,20 @@
                 </a:solidFill>
                 <a:latin typeface="Georgia"/>
               </a:rPr>
-              <a:t>Three pictures to explain it</a:t>
-            </a:r>
-          </a:p>
-        </p:txBody>
-      </p:sp>
-      <p:sp>
-        <p:nvSpPr>
-          <p:cNvPr id="5" name="TextBox 4"/>
+              <a:t>One day, three devices</a:t>
+            </a:r>
+          </a:p>
+        </p:txBody>
+      </p:sp>
+      <p:sp>
+        <p:nvSpPr>
+          <p:cNvPr id="7" name="TextBox 6"/>
           <p:cNvSpPr txBox="1"/>
           <p:nvPr/>
         </p:nvSpPr>
         <p:spPr>
           <a:xfrm>
-            <a:off x="822960" y="1627632"/>
+            <a:off x="822960" y="1737360"/>
             <a:ext cx="10058400" cy="457200"/>
           </a:xfrm>
           <a:prstGeom prst="rect">
@@ -7455,31 +8371,31 @@
               </a:spcAft>
             </a:pPr>
             <a:r>
-              <a:rPr sz="1400" b="0" i="0">
+              <a:rPr sz="1350" b="0" i="0">
                 <a:solidFill>
                   <a:srgbClr val="5B6470"/>
                 </a:solidFill>
                 <a:latin typeface="Calibri"/>
               </a:rPr>
-              <a:t>Each is a plain-language way to describe the choice.</a:t>
-            </a:r>
-          </a:p>
-        </p:txBody>
-      </p:sp>
-      <p:sp>
-        <p:nvSpPr>
-          <p:cNvPr id="6" name="Rounded Rectangle 5"/>
+              <a:t>Start on one device, finish on another — your library is simply there.</a:t>
+            </a:r>
+          </a:p>
+        </p:txBody>
+      </p:sp>
+      <p:sp>
+        <p:nvSpPr>
+          <p:cNvPr id="8" name="Rounded Rectangle 7"/>
           <p:cNvSpPr/>
           <p:nvPr/>
         </p:nvSpPr>
         <p:spPr>
           <a:xfrm>
-            <a:off x="623163" y="2468880"/>
-            <a:ext cx="3429000" cy="3703320"/>
+            <a:off x="435711" y="2880360"/>
+            <a:ext cx="2542032" cy="2514600"/>
           </a:xfrm>
           <a:prstGeom prst="roundRect">
             <a:avLst>
-              <a:gd name="adj" fmla="val 5000"/>
+              <a:gd name="adj" fmla="val 6000"/>
             </a:avLst>
           </a:prstGeom>
           <a:solidFill>
@@ -7516,6 +8432,1424 @@
       </p:sp>
       <p:sp>
         <p:nvSpPr>
+          <p:cNvPr id="9" name="Rounded Rectangle 8"/>
+          <p:cNvSpPr/>
+          <p:nvPr/>
+        </p:nvSpPr>
+        <p:spPr>
+          <a:xfrm>
+            <a:off x="1318107" y="3172968"/>
+            <a:ext cx="777240" cy="777240"/>
+          </a:xfrm>
+          <a:prstGeom prst="roundRect">
+            <a:avLst>
+              <a:gd name="adj" fmla="val 25000"/>
+            </a:avLst>
+          </a:prstGeom>
+          <a:solidFill>
+            <a:srgbClr val="E6ECF4"/>
+          </a:solidFill>
+          <a:ln w="12700">
+            <a:solidFill>
+              <a:srgbClr val="2E4A6B"/>
+            </a:solidFill>
+          </a:ln>
+          <a:effectLst/>
+        </p:spPr>
+        <p:style>
+          <a:lnRef idx="1">
+            <a:schemeClr val="accent1"/>
+          </a:lnRef>
+          <a:fillRef idx="3">
+            <a:schemeClr val="accent1"/>
+          </a:fillRef>
+          <a:effectRef idx="2">
+            <a:schemeClr val="accent1"/>
+          </a:effectRef>
+          <a:fontRef idx="minor">
+            <a:schemeClr val="lt1"/>
+          </a:fontRef>
+        </p:style>
+        <p:txBody>
+          <a:bodyPr rtlCol="0" anchor="ctr"/>
+          <a:lstStyle/>
+          <a:p>
+            <a:pPr algn="ctr"/>
+          </a:p>
+        </p:txBody>
+      </p:sp>
+      <p:sp>
+        <p:nvSpPr>
+          <p:cNvPr id="10" name="Rounded Rectangle 9"/>
+          <p:cNvSpPr/>
+          <p:nvPr/>
+        </p:nvSpPr>
+        <p:spPr>
+          <a:xfrm>
+            <a:off x="1587855" y="3378708"/>
+            <a:ext cx="237744" cy="365760"/>
+          </a:xfrm>
+          <a:prstGeom prst="roundRect">
+            <a:avLst>
+              <a:gd name="adj" fmla="val 20000"/>
+            </a:avLst>
+          </a:prstGeom>
+          <a:noFill/>
+          <a:ln w="25400">
+            <a:solidFill>
+              <a:srgbClr val="2E4A6B"/>
+            </a:solidFill>
+          </a:ln>
+          <a:effectLst/>
+        </p:spPr>
+        <p:style>
+          <a:lnRef idx="1">
+            <a:schemeClr val="accent1"/>
+          </a:lnRef>
+          <a:fillRef idx="3">
+            <a:schemeClr val="accent1"/>
+          </a:fillRef>
+          <a:effectRef idx="2">
+            <a:schemeClr val="accent1"/>
+          </a:effectRef>
+          <a:fontRef idx="minor">
+            <a:schemeClr val="lt1"/>
+          </a:fontRef>
+        </p:style>
+        <p:txBody>
+          <a:bodyPr rtlCol="0" anchor="ctr"/>
+          <a:lstStyle/>
+          <a:p>
+            <a:pPr algn="ctr"/>
+          </a:p>
+        </p:txBody>
+      </p:sp>
+      <p:sp>
+        <p:nvSpPr>
+          <p:cNvPr id="11" name="Rectangle 10"/>
+          <p:cNvSpPr/>
+          <p:nvPr/>
+        </p:nvSpPr>
+        <p:spPr>
+          <a:xfrm>
+            <a:off x="1665579" y="3662172"/>
+            <a:ext cx="82296" cy="22860"/>
+          </a:xfrm>
+          <a:prstGeom prst="rect">
+            <a:avLst/>
+          </a:prstGeom>
+          <a:solidFill>
+            <a:srgbClr val="2E4A6B"/>
+          </a:solidFill>
+          <a:ln>
+            <a:noFill/>
+          </a:ln>
+          <a:effectLst/>
+        </p:spPr>
+        <p:style>
+          <a:lnRef idx="1">
+            <a:schemeClr val="accent1"/>
+          </a:lnRef>
+          <a:fillRef idx="3">
+            <a:schemeClr val="accent1"/>
+          </a:fillRef>
+          <a:effectRef idx="2">
+            <a:schemeClr val="accent1"/>
+          </a:effectRef>
+          <a:fontRef idx="minor">
+            <a:schemeClr val="lt1"/>
+          </a:fontRef>
+        </p:style>
+        <p:txBody>
+          <a:bodyPr rtlCol="0" anchor="ctr"/>
+          <a:lstStyle/>
+          <a:p>
+            <a:pPr algn="ctr"/>
+          </a:p>
+        </p:txBody>
+      </p:sp>
+      <p:sp>
+        <p:nvSpPr>
+          <p:cNvPr id="12" name="TextBox 11"/>
+          <p:cNvSpPr txBox="1"/>
+          <p:nvPr/>
+        </p:nvSpPr>
+        <p:spPr>
+          <a:xfrm>
+            <a:off x="618591" y="4160520"/>
+            <a:ext cx="2176272" cy="274320"/>
+          </a:xfrm>
+          <a:prstGeom prst="rect">
+            <a:avLst/>
+          </a:prstGeom>
+          <a:noFill/>
+        </p:spPr>
+        <p:txBody>
+          <a:bodyPr wrap="square" anchor="t" lIns="0" rIns="0" tIns="0" bIns="0">
+            <a:spAutoFit/>
+          </a:bodyPr>
+          <a:lstStyle/>
+          <a:p>
+            <a:pPr algn="ctr">
+              <a:spcAft>
+                <a:spcPts val="0"/>
+              </a:spcAft>
+            </a:pPr>
+            <a:r>
+              <a:rPr sz="1000" b="1" i="0">
+                <a:solidFill>
+                  <a:srgbClr val="2E4A6B"/>
+                </a:solidFill>
+                <a:latin typeface="Consolas"/>
+              </a:rPr>
+              <a:t>ON THE TRAIN</a:t>
+            </a:r>
+          </a:p>
+        </p:txBody>
+      </p:sp>
+      <p:sp>
+        <p:nvSpPr>
+          <p:cNvPr id="13" name="TextBox 12"/>
+          <p:cNvSpPr txBox="1"/>
+          <p:nvPr/>
+        </p:nvSpPr>
+        <p:spPr>
+          <a:xfrm>
+            <a:off x="691743" y="4480560"/>
+            <a:ext cx="2029967" cy="822960"/>
+          </a:xfrm>
+          <a:prstGeom prst="rect">
+            <a:avLst/>
+          </a:prstGeom>
+          <a:noFill/>
+        </p:spPr>
+        <p:txBody>
+          <a:bodyPr wrap="square" anchor="t" lIns="0" rIns="0" tIns="0" bIns="0">
+            <a:spAutoFit/>
+          </a:bodyPr>
+          <a:lstStyle/>
+          <a:p>
+            <a:pPr algn="ctr">
+              <a:lnSpc>
+                <a:spcPct val="108000"/>
+              </a:lnSpc>
+              <a:spcAft>
+                <a:spcPts val="0"/>
+              </a:spcAft>
+            </a:pPr>
+            <a:r>
+              <a:rPr sz="1200" b="0" i="0">
+                <a:solidFill>
+                  <a:srgbClr val="1B2027"/>
+                </a:solidFill>
+                <a:latin typeface="Calibri"/>
+              </a:rPr>
+              <a:t>Draft a chapter on your phone.</a:t>
+            </a:r>
+          </a:p>
+        </p:txBody>
+      </p:sp>
+      <p:sp>
+        <p:nvSpPr>
+          <p:cNvPr id="14" name="Chevron 13"/>
+          <p:cNvSpPr/>
+          <p:nvPr/>
+        </p:nvSpPr>
+        <p:spPr>
+          <a:xfrm>
+            <a:off x="3023463" y="3982212"/>
+            <a:ext cx="292608" cy="310896"/>
+          </a:xfrm>
+          <a:prstGeom prst="chevron">
+            <a:avLst/>
+          </a:prstGeom>
+          <a:solidFill>
+            <a:srgbClr val="E1DDD2"/>
+          </a:solidFill>
+          <a:ln>
+            <a:noFill/>
+          </a:ln>
+          <a:effectLst/>
+        </p:spPr>
+        <p:style>
+          <a:lnRef idx="1">
+            <a:schemeClr val="accent1"/>
+          </a:lnRef>
+          <a:fillRef idx="3">
+            <a:schemeClr val="accent1"/>
+          </a:fillRef>
+          <a:effectRef idx="2">
+            <a:schemeClr val="accent1"/>
+          </a:effectRef>
+          <a:fontRef idx="minor">
+            <a:schemeClr val="lt1"/>
+          </a:fontRef>
+        </p:style>
+        <p:txBody>
+          <a:bodyPr rtlCol="0" anchor="ctr"/>
+          <a:lstStyle/>
+          <a:p>
+            <a:pPr algn="ctr"/>
+          </a:p>
+        </p:txBody>
+      </p:sp>
+      <p:sp>
+        <p:nvSpPr>
+          <p:cNvPr id="15" name="Rounded Rectangle 14"/>
+          <p:cNvSpPr/>
+          <p:nvPr/>
+        </p:nvSpPr>
+        <p:spPr>
+          <a:xfrm>
+            <a:off x="3361791" y="2880360"/>
+            <a:ext cx="2542032" cy="2514600"/>
+          </a:xfrm>
+          <a:prstGeom prst="roundRect">
+            <a:avLst>
+              <a:gd name="adj" fmla="val 6000"/>
+            </a:avLst>
+          </a:prstGeom>
+          <a:solidFill>
+            <a:srgbClr val="FFFFFF"/>
+          </a:solidFill>
+          <a:ln w="22225">
+            <a:solidFill>
+              <a:srgbClr val="B5822E"/>
+            </a:solidFill>
+          </a:ln>
+          <a:effectLst/>
+        </p:spPr>
+        <p:style>
+          <a:lnRef idx="1">
+            <a:schemeClr val="accent1"/>
+          </a:lnRef>
+          <a:fillRef idx="3">
+            <a:schemeClr val="accent1"/>
+          </a:fillRef>
+          <a:effectRef idx="2">
+            <a:schemeClr val="accent1"/>
+          </a:effectRef>
+          <a:fontRef idx="minor">
+            <a:schemeClr val="lt1"/>
+          </a:fontRef>
+        </p:style>
+        <p:txBody>
+          <a:bodyPr rtlCol="0" anchor="ctr"/>
+          <a:lstStyle/>
+          <a:p>
+            <a:pPr algn="ctr"/>
+          </a:p>
+        </p:txBody>
+      </p:sp>
+      <p:sp>
+        <p:nvSpPr>
+          <p:cNvPr id="16" name="Rounded Rectangle 15"/>
+          <p:cNvSpPr/>
+          <p:nvPr/>
+        </p:nvSpPr>
+        <p:spPr>
+          <a:xfrm>
+            <a:off x="4244187" y="3172968"/>
+            <a:ext cx="777240" cy="777240"/>
+          </a:xfrm>
+          <a:prstGeom prst="roundRect">
+            <a:avLst>
+              <a:gd name="adj" fmla="val 25000"/>
+            </a:avLst>
+          </a:prstGeom>
+          <a:solidFill>
+            <a:srgbClr val="F6EEDD"/>
+          </a:solidFill>
+          <a:ln w="12700">
+            <a:solidFill>
+              <a:srgbClr val="B5822E"/>
+            </a:solidFill>
+          </a:ln>
+          <a:effectLst/>
+        </p:spPr>
+        <p:style>
+          <a:lnRef idx="1">
+            <a:schemeClr val="accent1"/>
+          </a:lnRef>
+          <a:fillRef idx="3">
+            <a:schemeClr val="accent1"/>
+          </a:fillRef>
+          <a:effectRef idx="2">
+            <a:schemeClr val="accent1"/>
+          </a:effectRef>
+          <a:fontRef idx="minor">
+            <a:schemeClr val="lt1"/>
+          </a:fontRef>
+        </p:style>
+        <p:txBody>
+          <a:bodyPr rtlCol="0" anchor="ctr"/>
+          <a:lstStyle/>
+          <a:p>
+            <a:pPr algn="ctr"/>
+          </a:p>
+        </p:txBody>
+      </p:sp>
+      <p:sp>
+        <p:nvSpPr>
+          <p:cNvPr id="17" name="Oval 16"/>
+          <p:cNvSpPr/>
+          <p:nvPr/>
+        </p:nvSpPr>
+        <p:spPr>
+          <a:xfrm>
+            <a:off x="4523079" y="3360420"/>
+            <a:ext cx="219456" cy="219456"/>
+          </a:xfrm>
+          <a:prstGeom prst="ellipse">
+            <a:avLst/>
+          </a:prstGeom>
+          <a:noFill/>
+          <a:ln w="25400">
+            <a:solidFill>
+              <a:srgbClr val="B5822E"/>
+            </a:solidFill>
+          </a:ln>
+          <a:effectLst/>
+        </p:spPr>
+        <p:style>
+          <a:lnRef idx="1">
+            <a:schemeClr val="accent1"/>
+          </a:lnRef>
+          <a:fillRef idx="3">
+            <a:schemeClr val="accent1"/>
+          </a:fillRef>
+          <a:effectRef idx="2">
+            <a:schemeClr val="accent1"/>
+          </a:effectRef>
+          <a:fontRef idx="minor">
+            <a:schemeClr val="lt1"/>
+          </a:fontRef>
+        </p:style>
+        <p:txBody>
+          <a:bodyPr rtlCol="0" anchor="ctr"/>
+          <a:lstStyle/>
+          <a:p>
+            <a:pPr algn="ctr"/>
+          </a:p>
+        </p:txBody>
+      </p:sp>
+      <p:sp>
+        <p:nvSpPr>
+          <p:cNvPr id="18" name="Rounded Rectangle 17"/>
+          <p:cNvSpPr/>
+          <p:nvPr/>
+        </p:nvSpPr>
+        <p:spPr>
+          <a:xfrm>
+            <a:off x="4486503" y="3506724"/>
+            <a:ext cx="292608" cy="256032"/>
+          </a:xfrm>
+          <a:prstGeom prst="roundRect">
+            <a:avLst>
+              <a:gd name="adj" fmla="val 18000"/>
+            </a:avLst>
+          </a:prstGeom>
+          <a:solidFill>
+            <a:srgbClr val="B5822E"/>
+          </a:solidFill>
+          <a:ln>
+            <a:noFill/>
+          </a:ln>
+          <a:effectLst/>
+        </p:spPr>
+        <p:style>
+          <a:lnRef idx="1">
+            <a:schemeClr val="accent1"/>
+          </a:lnRef>
+          <a:fillRef idx="3">
+            <a:schemeClr val="accent1"/>
+          </a:fillRef>
+          <a:effectRef idx="2">
+            <a:schemeClr val="accent1"/>
+          </a:effectRef>
+          <a:fontRef idx="minor">
+            <a:schemeClr val="lt1"/>
+          </a:fontRef>
+        </p:style>
+        <p:txBody>
+          <a:bodyPr rtlCol="0" anchor="ctr"/>
+          <a:lstStyle/>
+          <a:p>
+            <a:pPr algn="ctr"/>
+          </a:p>
+        </p:txBody>
+      </p:sp>
+      <p:sp>
+        <p:nvSpPr>
+          <p:cNvPr id="19" name="Oval 18"/>
+          <p:cNvSpPr/>
+          <p:nvPr/>
+        </p:nvSpPr>
+        <p:spPr>
+          <a:xfrm>
+            <a:off x="4600803" y="3589020"/>
+            <a:ext cx="64008" cy="64008"/>
+          </a:xfrm>
+          <a:prstGeom prst="ellipse">
+            <a:avLst/>
+          </a:prstGeom>
+          <a:solidFill>
+            <a:srgbClr val="FFFFFF"/>
+          </a:solidFill>
+          <a:ln>
+            <a:noFill/>
+          </a:ln>
+          <a:effectLst/>
+        </p:spPr>
+        <p:style>
+          <a:lnRef idx="1">
+            <a:schemeClr val="accent1"/>
+          </a:lnRef>
+          <a:fillRef idx="3">
+            <a:schemeClr val="accent1"/>
+          </a:fillRef>
+          <a:effectRef idx="2">
+            <a:schemeClr val="accent1"/>
+          </a:effectRef>
+          <a:fontRef idx="minor">
+            <a:schemeClr val="lt1"/>
+          </a:fontRef>
+        </p:style>
+        <p:txBody>
+          <a:bodyPr rtlCol="0" anchor="ctr"/>
+          <a:lstStyle/>
+          <a:p>
+            <a:pPr algn="ctr"/>
+          </a:p>
+        </p:txBody>
+      </p:sp>
+      <p:sp>
+        <p:nvSpPr>
+          <p:cNvPr id="20" name="TextBox 19"/>
+          <p:cNvSpPr txBox="1"/>
+          <p:nvPr/>
+        </p:nvSpPr>
+        <p:spPr>
+          <a:xfrm>
+            <a:off x="3544671" y="4160520"/>
+            <a:ext cx="2176272" cy="274320"/>
+          </a:xfrm>
+          <a:prstGeom prst="rect">
+            <a:avLst/>
+          </a:prstGeom>
+          <a:noFill/>
+        </p:spPr>
+        <p:txBody>
+          <a:bodyPr wrap="square" anchor="t" lIns="0" rIns="0" tIns="0" bIns="0">
+            <a:spAutoFit/>
+          </a:bodyPr>
+          <a:lstStyle/>
+          <a:p>
+            <a:pPr algn="ctr">
+              <a:spcAft>
+                <a:spcPts val="0"/>
+              </a:spcAft>
+            </a:pPr>
+            <a:r>
+              <a:rPr sz="1000" b="1" i="0">
+                <a:solidFill>
+                  <a:srgbClr val="B5822E"/>
+                </a:solidFill>
+                <a:latin typeface="Consolas"/>
+              </a:rPr>
+              <a:t>INSTANTLY</a:t>
+            </a:r>
+          </a:p>
+        </p:txBody>
+      </p:sp>
+      <p:sp>
+        <p:nvSpPr>
+          <p:cNvPr id="21" name="TextBox 20"/>
+          <p:cNvSpPr txBox="1"/>
+          <p:nvPr/>
+        </p:nvSpPr>
+        <p:spPr>
+          <a:xfrm>
+            <a:off x="3617823" y="4480560"/>
+            <a:ext cx="2029967" cy="822960"/>
+          </a:xfrm>
+          <a:prstGeom prst="rect">
+            <a:avLst/>
+          </a:prstGeom>
+          <a:noFill/>
+        </p:spPr>
+        <p:txBody>
+          <a:bodyPr wrap="square" anchor="t" lIns="0" rIns="0" tIns="0" bIns="0">
+            <a:spAutoFit/>
+          </a:bodyPr>
+          <a:lstStyle/>
+          <a:p>
+            <a:pPr algn="ctr">
+              <a:lnSpc>
+                <a:spcPct val="108000"/>
+              </a:lnSpc>
+              <a:spcAft>
+                <a:spcPts val="0"/>
+              </a:spcAft>
+            </a:pPr>
+            <a:r>
+              <a:rPr sz="1200" b="0" i="0">
+                <a:solidFill>
+                  <a:srgbClr val="1B2027"/>
+                </a:solidFill>
+                <a:latin typeface="Calibri"/>
+              </a:rPr>
+              <a:t>Saved to your private library — encrypted.</a:t>
+            </a:r>
+          </a:p>
+        </p:txBody>
+      </p:sp>
+      <p:sp>
+        <p:nvSpPr>
+          <p:cNvPr id="22" name="Chevron 21"/>
+          <p:cNvSpPr/>
+          <p:nvPr/>
+        </p:nvSpPr>
+        <p:spPr>
+          <a:xfrm>
+            <a:off x="5949543" y="3982212"/>
+            <a:ext cx="292608" cy="310896"/>
+          </a:xfrm>
+          <a:prstGeom prst="chevron">
+            <a:avLst/>
+          </a:prstGeom>
+          <a:solidFill>
+            <a:srgbClr val="E1DDD2"/>
+          </a:solidFill>
+          <a:ln>
+            <a:noFill/>
+          </a:ln>
+          <a:effectLst/>
+        </p:spPr>
+        <p:style>
+          <a:lnRef idx="1">
+            <a:schemeClr val="accent1"/>
+          </a:lnRef>
+          <a:fillRef idx="3">
+            <a:schemeClr val="accent1"/>
+          </a:fillRef>
+          <a:effectRef idx="2">
+            <a:schemeClr val="accent1"/>
+          </a:effectRef>
+          <a:fontRef idx="minor">
+            <a:schemeClr val="lt1"/>
+          </a:fontRef>
+        </p:style>
+        <p:txBody>
+          <a:bodyPr rtlCol="0" anchor="ctr"/>
+          <a:lstStyle/>
+          <a:p>
+            <a:pPr algn="ctr"/>
+          </a:p>
+        </p:txBody>
+      </p:sp>
+      <p:sp>
+        <p:nvSpPr>
+          <p:cNvPr id="23" name="Rounded Rectangle 22"/>
+          <p:cNvSpPr/>
+          <p:nvPr/>
+        </p:nvSpPr>
+        <p:spPr>
+          <a:xfrm>
+            <a:off x="6287871" y="2880360"/>
+            <a:ext cx="2542032" cy="2514600"/>
+          </a:xfrm>
+          <a:prstGeom prst="roundRect">
+            <a:avLst>
+              <a:gd name="adj" fmla="val 6000"/>
+            </a:avLst>
+          </a:prstGeom>
+          <a:solidFill>
+            <a:srgbClr val="FFFFFF"/>
+          </a:solidFill>
+          <a:ln w="12700">
+            <a:solidFill>
+              <a:srgbClr val="E1DDD2"/>
+            </a:solidFill>
+          </a:ln>
+          <a:effectLst/>
+        </p:spPr>
+        <p:style>
+          <a:lnRef idx="1">
+            <a:schemeClr val="accent1"/>
+          </a:lnRef>
+          <a:fillRef idx="3">
+            <a:schemeClr val="accent1"/>
+          </a:fillRef>
+          <a:effectRef idx="2">
+            <a:schemeClr val="accent1"/>
+          </a:effectRef>
+          <a:fontRef idx="minor">
+            <a:schemeClr val="lt1"/>
+          </a:fontRef>
+        </p:style>
+        <p:txBody>
+          <a:bodyPr rtlCol="0" anchor="ctr"/>
+          <a:lstStyle/>
+          <a:p>
+            <a:pPr algn="ctr"/>
+          </a:p>
+        </p:txBody>
+      </p:sp>
+      <p:sp>
+        <p:nvSpPr>
+          <p:cNvPr id="24" name="Rounded Rectangle 23"/>
+          <p:cNvSpPr/>
+          <p:nvPr/>
+        </p:nvSpPr>
+        <p:spPr>
+          <a:xfrm>
+            <a:off x="7170267" y="3172968"/>
+            <a:ext cx="777240" cy="777240"/>
+          </a:xfrm>
+          <a:prstGeom prst="roundRect">
+            <a:avLst>
+              <a:gd name="adj" fmla="val 25000"/>
+            </a:avLst>
+          </a:prstGeom>
+          <a:solidFill>
+            <a:srgbClr val="E6ECF4"/>
+          </a:solidFill>
+          <a:ln w="12700">
+            <a:solidFill>
+              <a:srgbClr val="2E4A6B"/>
+            </a:solidFill>
+          </a:ln>
+          <a:effectLst/>
+        </p:spPr>
+        <p:style>
+          <a:lnRef idx="1">
+            <a:schemeClr val="accent1"/>
+          </a:lnRef>
+          <a:fillRef idx="3">
+            <a:schemeClr val="accent1"/>
+          </a:fillRef>
+          <a:effectRef idx="2">
+            <a:schemeClr val="accent1"/>
+          </a:effectRef>
+          <a:fontRef idx="minor">
+            <a:schemeClr val="lt1"/>
+          </a:fontRef>
+        </p:style>
+        <p:txBody>
+          <a:bodyPr rtlCol="0" anchor="ctr"/>
+          <a:lstStyle/>
+          <a:p>
+            <a:pPr algn="ctr"/>
+          </a:p>
+        </p:txBody>
+      </p:sp>
+      <p:sp>
+        <p:nvSpPr>
+          <p:cNvPr id="25" name="Rounded Rectangle 24"/>
+          <p:cNvSpPr/>
+          <p:nvPr/>
+        </p:nvSpPr>
+        <p:spPr>
+          <a:xfrm>
+            <a:off x="7376007" y="3415284"/>
+            <a:ext cx="365760" cy="292608"/>
+          </a:xfrm>
+          <a:prstGeom prst="roundRect">
+            <a:avLst>
+              <a:gd name="adj" fmla="val 12000"/>
+            </a:avLst>
+          </a:prstGeom>
+          <a:noFill/>
+          <a:ln w="25400">
+            <a:solidFill>
+              <a:srgbClr val="2E4A6B"/>
+            </a:solidFill>
+          </a:ln>
+          <a:effectLst/>
+        </p:spPr>
+        <p:style>
+          <a:lnRef idx="1">
+            <a:schemeClr val="accent1"/>
+          </a:lnRef>
+          <a:fillRef idx="3">
+            <a:schemeClr val="accent1"/>
+          </a:fillRef>
+          <a:effectRef idx="2">
+            <a:schemeClr val="accent1"/>
+          </a:effectRef>
+          <a:fontRef idx="minor">
+            <a:schemeClr val="lt1"/>
+          </a:fontRef>
+        </p:style>
+        <p:txBody>
+          <a:bodyPr rtlCol="0" anchor="ctr"/>
+          <a:lstStyle/>
+          <a:p>
+            <a:pPr algn="ctr"/>
+          </a:p>
+        </p:txBody>
+      </p:sp>
+      <p:sp>
+        <p:nvSpPr>
+          <p:cNvPr id="26" name="TextBox 25"/>
+          <p:cNvSpPr txBox="1"/>
+          <p:nvPr/>
+        </p:nvSpPr>
+        <p:spPr>
+          <a:xfrm>
+            <a:off x="6470751" y="4160520"/>
+            <a:ext cx="2176272" cy="274320"/>
+          </a:xfrm>
+          <a:prstGeom prst="rect">
+            <a:avLst/>
+          </a:prstGeom>
+          <a:noFill/>
+        </p:spPr>
+        <p:txBody>
+          <a:bodyPr wrap="square" anchor="t" lIns="0" rIns="0" tIns="0" bIns="0">
+            <a:spAutoFit/>
+          </a:bodyPr>
+          <a:lstStyle/>
+          <a:p>
+            <a:pPr algn="ctr">
+              <a:spcAft>
+                <a:spcPts val="0"/>
+              </a:spcAft>
+            </a:pPr>
+            <a:r>
+              <a:rPr sz="1000" b="1" i="0">
+                <a:solidFill>
+                  <a:srgbClr val="2E4A6B"/>
+                </a:solidFill>
+                <a:latin typeface="Consolas"/>
+              </a:rPr>
+              <a:t>AT HOME</a:t>
+            </a:r>
+          </a:p>
+        </p:txBody>
+      </p:sp>
+      <p:sp>
+        <p:nvSpPr>
+          <p:cNvPr id="27" name="TextBox 26"/>
+          <p:cNvSpPr txBox="1"/>
+          <p:nvPr/>
+        </p:nvSpPr>
+        <p:spPr>
+          <a:xfrm>
+            <a:off x="6543903" y="4480560"/>
+            <a:ext cx="2029967" cy="822960"/>
+          </a:xfrm>
+          <a:prstGeom prst="rect">
+            <a:avLst/>
+          </a:prstGeom>
+          <a:noFill/>
+        </p:spPr>
+        <p:txBody>
+          <a:bodyPr wrap="square" anchor="t" lIns="0" rIns="0" tIns="0" bIns="0">
+            <a:spAutoFit/>
+          </a:bodyPr>
+          <a:lstStyle/>
+          <a:p>
+            <a:pPr algn="ctr">
+              <a:lnSpc>
+                <a:spcPct val="108000"/>
+              </a:lnSpc>
+              <a:spcAft>
+                <a:spcPts val="0"/>
+              </a:spcAft>
+            </a:pPr>
+            <a:r>
+              <a:rPr sz="1200" b="0" i="0">
+                <a:solidFill>
+                  <a:srgbClr val="1B2027"/>
+                </a:solidFill>
+                <a:latin typeface="Calibri"/>
+              </a:rPr>
+              <a:t>Open the tablet — it's already there.</a:t>
+            </a:r>
+          </a:p>
+        </p:txBody>
+      </p:sp>
+      <p:sp>
+        <p:nvSpPr>
+          <p:cNvPr id="28" name="Chevron 27"/>
+          <p:cNvSpPr/>
+          <p:nvPr/>
+        </p:nvSpPr>
+        <p:spPr>
+          <a:xfrm>
+            <a:off x="8875623" y="3982212"/>
+            <a:ext cx="292608" cy="310896"/>
+          </a:xfrm>
+          <a:prstGeom prst="chevron">
+            <a:avLst/>
+          </a:prstGeom>
+          <a:solidFill>
+            <a:srgbClr val="E1DDD2"/>
+          </a:solidFill>
+          <a:ln>
+            <a:noFill/>
+          </a:ln>
+          <a:effectLst/>
+        </p:spPr>
+        <p:style>
+          <a:lnRef idx="1">
+            <a:schemeClr val="accent1"/>
+          </a:lnRef>
+          <a:fillRef idx="3">
+            <a:schemeClr val="accent1"/>
+          </a:fillRef>
+          <a:effectRef idx="2">
+            <a:schemeClr val="accent1"/>
+          </a:effectRef>
+          <a:fontRef idx="minor">
+            <a:schemeClr val="lt1"/>
+          </a:fontRef>
+        </p:style>
+        <p:txBody>
+          <a:bodyPr rtlCol="0" anchor="ctr"/>
+          <a:lstStyle/>
+          <a:p>
+            <a:pPr algn="ctr"/>
+          </a:p>
+        </p:txBody>
+      </p:sp>
+      <p:sp>
+        <p:nvSpPr>
+          <p:cNvPr id="29" name="Rounded Rectangle 28"/>
+          <p:cNvSpPr/>
+          <p:nvPr/>
+        </p:nvSpPr>
+        <p:spPr>
+          <a:xfrm>
+            <a:off x="9213951" y="2880360"/>
+            <a:ext cx="2542032" cy="2514600"/>
+          </a:xfrm>
+          <a:prstGeom prst="roundRect">
+            <a:avLst>
+              <a:gd name="adj" fmla="val 6000"/>
+            </a:avLst>
+          </a:prstGeom>
+          <a:solidFill>
+            <a:srgbClr val="FFFFFF"/>
+          </a:solidFill>
+          <a:ln w="12700">
+            <a:solidFill>
+              <a:srgbClr val="E1DDD2"/>
+            </a:solidFill>
+          </a:ln>
+          <a:effectLst/>
+        </p:spPr>
+        <p:style>
+          <a:lnRef idx="1">
+            <a:schemeClr val="accent1"/>
+          </a:lnRef>
+          <a:fillRef idx="3">
+            <a:schemeClr val="accent1"/>
+          </a:fillRef>
+          <a:effectRef idx="2">
+            <a:schemeClr val="accent1"/>
+          </a:effectRef>
+          <a:fontRef idx="minor">
+            <a:schemeClr val="lt1"/>
+          </a:fontRef>
+        </p:style>
+        <p:txBody>
+          <a:bodyPr rtlCol="0" anchor="ctr"/>
+          <a:lstStyle/>
+          <a:p>
+            <a:pPr algn="ctr"/>
+          </a:p>
+        </p:txBody>
+      </p:sp>
+      <p:sp>
+        <p:nvSpPr>
+          <p:cNvPr id="30" name="Rounded Rectangle 29"/>
+          <p:cNvSpPr/>
+          <p:nvPr/>
+        </p:nvSpPr>
+        <p:spPr>
+          <a:xfrm>
+            <a:off x="10096347" y="3172968"/>
+            <a:ext cx="777240" cy="777240"/>
+          </a:xfrm>
+          <a:prstGeom prst="roundRect">
+            <a:avLst>
+              <a:gd name="adj" fmla="val 25000"/>
+            </a:avLst>
+          </a:prstGeom>
+          <a:solidFill>
+            <a:srgbClr val="E6ECF4"/>
+          </a:solidFill>
+          <a:ln w="12700">
+            <a:solidFill>
+              <a:srgbClr val="2E4A6B"/>
+            </a:solidFill>
+          </a:ln>
+          <a:effectLst/>
+        </p:spPr>
+        <p:style>
+          <a:lnRef idx="1">
+            <a:schemeClr val="accent1"/>
+          </a:lnRef>
+          <a:fillRef idx="3">
+            <a:schemeClr val="accent1"/>
+          </a:fillRef>
+          <a:effectRef idx="2">
+            <a:schemeClr val="accent1"/>
+          </a:effectRef>
+          <a:fontRef idx="minor">
+            <a:schemeClr val="lt1"/>
+          </a:fontRef>
+        </p:style>
+        <p:txBody>
+          <a:bodyPr rtlCol="0" anchor="ctr"/>
+          <a:lstStyle/>
+          <a:p>
+            <a:pPr algn="ctr"/>
+          </a:p>
+        </p:txBody>
+      </p:sp>
+      <p:sp>
+        <p:nvSpPr>
+          <p:cNvPr id="31" name="Rounded Rectangle 30"/>
+          <p:cNvSpPr/>
+          <p:nvPr/>
+        </p:nvSpPr>
+        <p:spPr>
+          <a:xfrm>
+            <a:off x="10302087" y="3378708"/>
+            <a:ext cx="365760" cy="274320"/>
+          </a:xfrm>
+          <a:prstGeom prst="roundRect">
+            <a:avLst>
+              <a:gd name="adj" fmla="val 10000"/>
+            </a:avLst>
+          </a:prstGeom>
+          <a:noFill/>
+          <a:ln w="25400">
+            <a:solidFill>
+              <a:srgbClr val="2E4A6B"/>
+            </a:solidFill>
+          </a:ln>
+          <a:effectLst/>
+        </p:spPr>
+        <p:style>
+          <a:lnRef idx="1">
+            <a:schemeClr val="accent1"/>
+          </a:lnRef>
+          <a:fillRef idx="3">
+            <a:schemeClr val="accent1"/>
+          </a:fillRef>
+          <a:effectRef idx="2">
+            <a:schemeClr val="accent1"/>
+          </a:effectRef>
+          <a:fontRef idx="minor">
+            <a:schemeClr val="lt1"/>
+          </a:fontRef>
+        </p:style>
+        <p:txBody>
+          <a:bodyPr rtlCol="0" anchor="ctr"/>
+          <a:lstStyle/>
+          <a:p>
+            <a:pPr algn="ctr"/>
+          </a:p>
+        </p:txBody>
+      </p:sp>
+      <p:sp>
+        <p:nvSpPr>
+          <p:cNvPr id="32" name="Rectangle 31"/>
+          <p:cNvSpPr/>
+          <p:nvPr/>
+        </p:nvSpPr>
+        <p:spPr>
+          <a:xfrm>
+            <a:off x="10238079" y="3653028"/>
+            <a:ext cx="493776" cy="45720"/>
+          </a:xfrm>
+          <a:prstGeom prst="rect">
+            <a:avLst/>
+          </a:prstGeom>
+          <a:solidFill>
+            <a:srgbClr val="2E4A6B"/>
+          </a:solidFill>
+          <a:ln>
+            <a:noFill/>
+          </a:ln>
+          <a:effectLst/>
+        </p:spPr>
+        <p:style>
+          <a:lnRef idx="1">
+            <a:schemeClr val="accent1"/>
+          </a:lnRef>
+          <a:fillRef idx="3">
+            <a:schemeClr val="accent1"/>
+          </a:fillRef>
+          <a:effectRef idx="2">
+            <a:schemeClr val="accent1"/>
+          </a:effectRef>
+          <a:fontRef idx="minor">
+            <a:schemeClr val="lt1"/>
+          </a:fontRef>
+        </p:style>
+        <p:txBody>
+          <a:bodyPr rtlCol="0" anchor="ctr"/>
+          <a:lstStyle/>
+          <a:p>
+            <a:pPr algn="ctr"/>
+          </a:p>
+        </p:txBody>
+      </p:sp>
+      <p:sp>
+        <p:nvSpPr>
+          <p:cNvPr id="33" name="TextBox 32"/>
+          <p:cNvSpPr txBox="1"/>
+          <p:nvPr/>
+        </p:nvSpPr>
+        <p:spPr>
+          <a:xfrm>
+            <a:off x="9396831" y="4160520"/>
+            <a:ext cx="2176272" cy="274320"/>
+          </a:xfrm>
+          <a:prstGeom prst="rect">
+            <a:avLst/>
+          </a:prstGeom>
+          <a:noFill/>
+        </p:spPr>
+        <p:txBody>
+          <a:bodyPr wrap="square" anchor="t" lIns="0" rIns="0" tIns="0" bIns="0">
+            <a:spAutoFit/>
+          </a:bodyPr>
+          <a:lstStyle/>
+          <a:p>
+            <a:pPr algn="ctr">
+              <a:spcAft>
+                <a:spcPts val="0"/>
+              </a:spcAft>
+            </a:pPr>
+            <a:r>
+              <a:rPr sz="1000" b="1" i="0">
+                <a:solidFill>
+                  <a:srgbClr val="2E4A6B"/>
+                </a:solidFill>
+                <a:latin typeface="Consolas"/>
+              </a:rPr>
+              <a:t>LATER</a:t>
+            </a:r>
+          </a:p>
+        </p:txBody>
+      </p:sp>
+      <p:sp>
+        <p:nvSpPr>
+          <p:cNvPr id="34" name="TextBox 33"/>
+          <p:cNvSpPr txBox="1"/>
+          <p:nvPr/>
+        </p:nvSpPr>
+        <p:spPr>
+          <a:xfrm>
+            <a:off x="9469983" y="4480560"/>
+            <a:ext cx="2029967" cy="822960"/>
+          </a:xfrm>
+          <a:prstGeom prst="rect">
+            <a:avLst/>
+          </a:prstGeom>
+          <a:noFill/>
+        </p:spPr>
+        <p:txBody>
+          <a:bodyPr wrap="square" anchor="t" lIns="0" rIns="0" tIns="0" bIns="0">
+            <a:spAutoFit/>
+          </a:bodyPr>
+          <a:lstStyle/>
+          <a:p>
+            <a:pPr algn="ctr">
+              <a:lnSpc>
+                <a:spcPct val="108000"/>
+              </a:lnSpc>
+              <a:spcAft>
+                <a:spcPts val="0"/>
+              </a:spcAft>
+            </a:pPr>
+            <a:r>
+              <a:rPr sz="1200" b="0" i="0">
+                <a:solidFill>
+                  <a:srgbClr val="1B2027"/>
+                </a:solidFill>
+                <a:latin typeface="Calibri"/>
+              </a:rPr>
+              <a:t>Publish from your laptop — now on every device.</a:t>
+            </a:r>
+          </a:p>
+        </p:txBody>
+      </p:sp>
+      <p:sp>
+        <p:nvSpPr>
+          <p:cNvPr id="35" name="TextBox 34"/>
+          <p:cNvSpPr txBox="1"/>
+          <p:nvPr/>
+        </p:nvSpPr>
+        <p:spPr>
+          <a:xfrm>
+            <a:off x="822960" y="5760720"/>
+            <a:ext cx="10515600" cy="365760"/>
+          </a:xfrm>
+          <a:prstGeom prst="rect">
+            <a:avLst/>
+          </a:prstGeom>
+          <a:noFill/>
+        </p:spPr>
+        <p:txBody>
+          <a:bodyPr wrap="square" anchor="t" lIns="0" rIns="0" tIns="0" bIns="0">
+            <a:spAutoFit/>
+          </a:bodyPr>
+          <a:lstStyle/>
+          <a:p>
+            <a:pPr algn="ctr">
+              <a:spcAft>
+                <a:spcPts val="0"/>
+              </a:spcAft>
+            </a:pPr>
+            <a:r>
+              <a:rPr sz="1150" b="0" i="1">
+                <a:solidFill>
+                  <a:srgbClr val="5B6470"/>
+                </a:solidFill>
+                <a:latin typeface="Calibri"/>
+              </a:rPr>
+              <a:t>No copying files around, no “which device has the latest?” — the library is the source of truth.</a:t>
+            </a:r>
+          </a:p>
+        </p:txBody>
+      </p:sp>
+    </p:spTree>
+  </p:cSld>
+  <p:clrMapOvr>
+    <a:masterClrMapping/>
+  </p:clrMapOvr>
+</p:sld>
+</file>
+
+<file path=ppt/slides/slide5.xml><?xml version="1.0" encoding="utf-8"?>
+<p:sld xmlns:a="http://schemas.openxmlformats.org/drawingml/2006/main" xmlns:p="http://schemas.openxmlformats.org/presentationml/2006/main" xmlns:r="http://schemas.openxmlformats.org/officeDocument/2006/relationships">
+  <p:cSld>
+    <p:spTree>
+      <p:nvGrpSpPr>
+        <p:cNvPr id="1" name=""/>
+        <p:cNvGrpSpPr/>
+        <p:nvPr/>
+      </p:nvGrpSpPr>
+      <p:grpSpPr/>
+      <p:sp>
+        <p:nvSpPr>
+          <p:cNvPr id="2" name="Rectangle 1"/>
+          <p:cNvSpPr/>
+          <p:nvPr/>
+        </p:nvSpPr>
+        <p:spPr>
+          <a:xfrm>
+            <a:off x="0" y="0"/>
+            <a:ext cx="12191695" cy="6858000"/>
+          </a:xfrm>
+          <a:prstGeom prst="rect">
+            <a:avLst/>
+          </a:prstGeom>
+          <a:solidFill>
+            <a:srgbClr val="FBFAF7"/>
+          </a:solidFill>
+          <a:ln>
+            <a:noFill/>
+          </a:ln>
+          <a:effectLst/>
+        </p:spPr>
+        <p:style>
+          <a:lnRef idx="1">
+            <a:schemeClr val="accent1"/>
+          </a:lnRef>
+          <a:fillRef idx="3">
+            <a:schemeClr val="accent1"/>
+          </a:fillRef>
+          <a:effectRef idx="2">
+            <a:schemeClr val="accent1"/>
+          </a:effectRef>
+          <a:fontRef idx="minor">
+            <a:schemeClr val="lt1"/>
+          </a:fontRef>
+        </p:style>
+        <p:txBody>
+          <a:bodyPr rtlCol="0" anchor="ctr"/>
+          <a:lstStyle/>
+          <a:p>
+            <a:pPr algn="ctr"/>
+          </a:p>
+        </p:txBody>
+      </p:sp>
+      <p:sp>
+        <p:nvSpPr>
+          <p:cNvPr id="3" name="TextBox 2"/>
+          <p:cNvSpPr txBox="1"/>
+          <p:nvPr/>
+        </p:nvSpPr>
+        <p:spPr>
+          <a:xfrm>
+            <a:off x="822960" y="566928"/>
+            <a:ext cx="10515600" cy="365760"/>
+          </a:xfrm>
+          <a:prstGeom prst="rect">
+            <a:avLst/>
+          </a:prstGeom>
+          <a:noFill/>
+        </p:spPr>
+        <p:txBody>
+          <a:bodyPr wrap="square" anchor="t" lIns="0" rIns="0" tIns="0" bIns="0">
+            <a:spAutoFit/>
+          </a:bodyPr>
+          <a:lstStyle/>
+          <a:p>
+            <a:pPr algn="l">
+              <a:spcAft>
+                <a:spcPts val="0"/>
+              </a:spcAft>
+            </a:pPr>
+            <a:r>
+              <a:rPr sz="1100" b="0" i="0">
+                <a:solidFill>
+                  <a:srgbClr val="5B6470"/>
+                </a:solidFill>
+                <a:latin typeface="Consolas"/>
+              </a:rPr>
+              <a:t>THREE PICTURES TO EXPLAIN IT</a:t>
+            </a:r>
+          </a:p>
+        </p:txBody>
+      </p:sp>
+      <p:sp>
+        <p:nvSpPr>
+          <p:cNvPr id="4" name="TextBox 3"/>
+          <p:cNvSpPr txBox="1"/>
+          <p:nvPr/>
+        </p:nvSpPr>
+        <p:spPr>
+          <a:xfrm>
+            <a:off x="822960" y="914400"/>
+            <a:ext cx="10515600" cy="822960"/>
+          </a:xfrm>
+          <a:prstGeom prst="rect">
+            <a:avLst/>
+          </a:prstGeom>
+          <a:noFill/>
+        </p:spPr>
+        <p:txBody>
+          <a:bodyPr wrap="square" anchor="t" lIns="0" rIns="0" tIns="0" bIns="0">
+            <a:spAutoFit/>
+          </a:bodyPr>
+          <a:lstStyle/>
+          <a:p>
+            <a:pPr algn="l">
+              <a:spcAft>
+                <a:spcPts val="0"/>
+              </a:spcAft>
+            </a:pPr>
+            <a:r>
+              <a:rPr sz="3000" b="1" i="0">
+                <a:solidFill>
+                  <a:srgbClr val="1B2027"/>
+                </a:solidFill>
+                <a:latin typeface="Georgia"/>
+              </a:rPr>
+              <a:t>Three pictures to explain it</a:t>
+            </a:r>
+          </a:p>
+        </p:txBody>
+      </p:sp>
+      <p:sp>
+        <p:nvSpPr>
+          <p:cNvPr id="5" name="TextBox 4"/>
+          <p:cNvSpPr txBox="1"/>
+          <p:nvPr/>
+        </p:nvSpPr>
+        <p:spPr>
+          <a:xfrm>
+            <a:off x="822960" y="1627632"/>
+            <a:ext cx="10058400" cy="457200"/>
+          </a:xfrm>
+          <a:prstGeom prst="rect">
+            <a:avLst/>
+          </a:prstGeom>
+          <a:noFill/>
+        </p:spPr>
+        <p:txBody>
+          <a:bodyPr wrap="square" anchor="t" lIns="0" rIns="0" tIns="0" bIns="0">
+            <a:spAutoFit/>
+          </a:bodyPr>
+          <a:lstStyle/>
+          <a:p>
+            <a:pPr algn="l">
+              <a:spcAft>
+                <a:spcPts val="0"/>
+              </a:spcAft>
+            </a:pPr>
+            <a:r>
+              <a:rPr sz="1400" b="0" i="0">
+                <a:solidFill>
+                  <a:srgbClr val="5B6470"/>
+                </a:solidFill>
+                <a:latin typeface="Calibri"/>
+              </a:rPr>
+              <a:t>Each is a plain-language way to describe the choice.</a:t>
+            </a:r>
+          </a:p>
+        </p:txBody>
+      </p:sp>
+      <p:sp>
+        <p:nvSpPr>
+          <p:cNvPr id="6" name="Rounded Rectangle 5"/>
+          <p:cNvSpPr/>
+          <p:nvPr/>
+        </p:nvSpPr>
+        <p:spPr>
+          <a:xfrm>
+            <a:off x="623163" y="2468880"/>
+            <a:ext cx="3429000" cy="3703320"/>
+          </a:xfrm>
+          <a:prstGeom prst="roundRect">
+            <a:avLst>
+              <a:gd name="adj" fmla="val 5000"/>
+            </a:avLst>
+          </a:prstGeom>
+          <a:solidFill>
+            <a:srgbClr val="FFFFFF"/>
+          </a:solidFill>
+          <a:ln w="12700">
+            <a:solidFill>
+              <a:srgbClr val="E1DDD2"/>
+            </a:solidFill>
+          </a:ln>
+          <a:effectLst/>
+        </p:spPr>
+        <p:style>
+          <a:lnRef idx="1">
+            <a:schemeClr val="accent1"/>
+          </a:lnRef>
+          <a:fillRef idx="3">
+            <a:schemeClr val="accent1"/>
+          </a:fillRef>
+          <a:effectRef idx="2">
+            <a:schemeClr val="accent1"/>
+          </a:effectRef>
+          <a:fontRef idx="minor">
+            <a:schemeClr val="lt1"/>
+          </a:fontRef>
+        </p:style>
+        <p:txBody>
+          <a:bodyPr rtlCol="0" anchor="ctr"/>
+          <a:lstStyle/>
+          <a:p>
+            <a:pPr algn="ctr"/>
+          </a:p>
+        </p:txBody>
+      </p:sp>
+      <p:sp>
+        <p:nvSpPr>
           <p:cNvPr id="7" name="Rounded Rectangle 6"/>
           <p:cNvSpPr/>
           <p:nvPr/>
@@ -8760,7 +11094,7 @@
 </p:sld>
 </file>
 
-<file path=ppt/slides/slide5.xml><?xml version="1.0" encoding="utf-8"?>
+<file path=ppt/slides/slide6.xml><?xml version="1.0" encoding="utf-8"?>
 <p:sld xmlns:a="http://schemas.openxmlformats.org/drawingml/2006/main" xmlns:p="http://schemas.openxmlformats.org/presentationml/2006/main" xmlns:r="http://schemas.openxmlformats.org/officeDocument/2006/relationships">
   <p:cSld>
     <p:spTree>

</xml_diff>

<commit_message>
docs: persona value deck + enrich the tiers deck (graphics) (#309)
New: adr-033-persona-value-deck.pptx (+ .md companion) — how four personas
(doctor, med student, screenwriter, security architect) get value via the
learn → author → carry loop; 6 slides with role-badge glyphs, per-persona
library tags, colour-coded loop steps, and a payoff line each.

Enriched: adr-033-tiers-presentation.pptx now 6 slides — added drawn icons to
every callout, a device motif on the title slide, and a new 'one day, three
devices' journey slide (phone draft → private library → tablet → laptop).

Pointers updated from ADR-033 and the .md companions. Interactive web artifacts
published separately. Both decks rendered + visually verified via LibreOffice.

Co-authored-by: Claude Opus 4.8 (1M context) <noreply@anthropic.com>
</commit_message>
<xml_diff>
--- a/docs/adr-033-tiers-presentation.pptx
+++ b/docs/adr-033-tiers-presentation.pptx
@@ -10,6 +10,7 @@
     <p:sldId id="258" r:id="rId9"/>
     <p:sldId id="259" r:id="rId11"/>
     <p:sldId id="260" r:id="rId12"/>
+    <p:sldId id="261" r:id="rId13"/>
   </p:sldIdLst>
   <p:sldSz cx="12191695" cy="6858000" type="screen4x3"/>
   <p:notesSz cx="6858000" cy="9144000"/>
@@ -4028,7 +4029,416 @@
       </p:sp>
       <p:sp>
         <p:nvSpPr>
-          <p:cNvPr id="14" name="TextBox 13"/>
+          <p:cNvPr id="14" name="Rounded Rectangle 13"/>
+          <p:cNvSpPr/>
+          <p:nvPr/>
+        </p:nvSpPr>
+        <p:spPr>
+          <a:xfrm>
+            <a:off x="7936992" y="4315968"/>
+            <a:ext cx="950976" cy="950976"/>
+          </a:xfrm>
+          <a:prstGeom prst="roundRect">
+            <a:avLst>
+              <a:gd name="adj" fmla="val 14000"/>
+            </a:avLst>
+          </a:prstGeom>
+          <a:solidFill>
+            <a:srgbClr val="FFFFFF"/>
+          </a:solidFill>
+          <a:ln w="12700">
+            <a:solidFill>
+              <a:srgbClr val="E1DDD2"/>
+            </a:solidFill>
+          </a:ln>
+          <a:effectLst/>
+        </p:spPr>
+        <p:style>
+          <a:lnRef idx="1">
+            <a:schemeClr val="accent1"/>
+          </a:lnRef>
+          <a:fillRef idx="3">
+            <a:schemeClr val="accent1"/>
+          </a:fillRef>
+          <a:effectRef idx="2">
+            <a:schemeClr val="accent1"/>
+          </a:effectRef>
+          <a:fontRef idx="minor">
+            <a:schemeClr val="lt1"/>
+          </a:fontRef>
+        </p:style>
+        <p:txBody>
+          <a:bodyPr rtlCol="0" anchor="ctr"/>
+          <a:lstStyle/>
+          <a:p>
+            <a:pPr algn="ctr"/>
+          </a:p>
+        </p:txBody>
+      </p:sp>
+      <p:sp>
+        <p:nvSpPr>
+          <p:cNvPr id="15" name="Rounded Rectangle 14"/>
+          <p:cNvSpPr/>
+          <p:nvPr/>
+        </p:nvSpPr>
+        <p:spPr>
+          <a:xfrm>
+            <a:off x="8293607" y="4608576"/>
+            <a:ext cx="237744" cy="365760"/>
+          </a:xfrm>
+          <a:prstGeom prst="roundRect">
+            <a:avLst>
+              <a:gd name="adj" fmla="val 20000"/>
+            </a:avLst>
+          </a:prstGeom>
+          <a:noFill/>
+          <a:ln w="25400">
+            <a:solidFill>
+              <a:srgbClr val="2E4A6B"/>
+            </a:solidFill>
+          </a:ln>
+          <a:effectLst/>
+        </p:spPr>
+        <p:style>
+          <a:lnRef idx="1">
+            <a:schemeClr val="accent1"/>
+          </a:lnRef>
+          <a:fillRef idx="3">
+            <a:schemeClr val="accent1"/>
+          </a:fillRef>
+          <a:effectRef idx="2">
+            <a:schemeClr val="accent1"/>
+          </a:effectRef>
+          <a:fontRef idx="minor">
+            <a:schemeClr val="lt1"/>
+          </a:fontRef>
+        </p:style>
+        <p:txBody>
+          <a:bodyPr rtlCol="0" anchor="ctr"/>
+          <a:lstStyle/>
+          <a:p>
+            <a:pPr algn="ctr"/>
+          </a:p>
+        </p:txBody>
+      </p:sp>
+      <p:sp>
+        <p:nvSpPr>
+          <p:cNvPr id="16" name="Rectangle 15"/>
+          <p:cNvSpPr/>
+          <p:nvPr/>
+        </p:nvSpPr>
+        <p:spPr>
+          <a:xfrm>
+            <a:off x="8371331" y="4892040"/>
+            <a:ext cx="82296" cy="22860"/>
+          </a:xfrm>
+          <a:prstGeom prst="rect">
+            <a:avLst/>
+          </a:prstGeom>
+          <a:solidFill>
+            <a:srgbClr val="2E4A6B"/>
+          </a:solidFill>
+          <a:ln>
+            <a:noFill/>
+          </a:ln>
+          <a:effectLst/>
+        </p:spPr>
+        <p:style>
+          <a:lnRef idx="1">
+            <a:schemeClr val="accent1"/>
+          </a:lnRef>
+          <a:fillRef idx="3">
+            <a:schemeClr val="accent1"/>
+          </a:fillRef>
+          <a:effectRef idx="2">
+            <a:schemeClr val="accent1"/>
+          </a:effectRef>
+          <a:fontRef idx="minor">
+            <a:schemeClr val="lt1"/>
+          </a:fontRef>
+        </p:style>
+        <p:txBody>
+          <a:bodyPr rtlCol="0" anchor="ctr"/>
+          <a:lstStyle/>
+          <a:p>
+            <a:pPr algn="ctr"/>
+          </a:p>
+        </p:txBody>
+      </p:sp>
+      <p:sp>
+        <p:nvSpPr>
+          <p:cNvPr id="17" name="Rounded Rectangle 16"/>
+          <p:cNvSpPr/>
+          <p:nvPr/>
+        </p:nvSpPr>
+        <p:spPr>
+          <a:xfrm>
+            <a:off x="9015984" y="4315968"/>
+            <a:ext cx="950976" cy="950976"/>
+          </a:xfrm>
+          <a:prstGeom prst="roundRect">
+            <a:avLst>
+              <a:gd name="adj" fmla="val 14000"/>
+            </a:avLst>
+          </a:prstGeom>
+          <a:solidFill>
+            <a:srgbClr val="FFFFFF"/>
+          </a:solidFill>
+          <a:ln w="12700">
+            <a:solidFill>
+              <a:srgbClr val="E1DDD2"/>
+            </a:solidFill>
+          </a:ln>
+          <a:effectLst/>
+        </p:spPr>
+        <p:style>
+          <a:lnRef idx="1">
+            <a:schemeClr val="accent1"/>
+          </a:lnRef>
+          <a:fillRef idx="3">
+            <a:schemeClr val="accent1"/>
+          </a:fillRef>
+          <a:effectRef idx="2">
+            <a:schemeClr val="accent1"/>
+          </a:effectRef>
+          <a:fontRef idx="minor">
+            <a:schemeClr val="lt1"/>
+          </a:fontRef>
+        </p:style>
+        <p:txBody>
+          <a:bodyPr rtlCol="0" anchor="ctr"/>
+          <a:lstStyle/>
+          <a:p>
+            <a:pPr algn="ctr"/>
+          </a:p>
+        </p:txBody>
+      </p:sp>
+      <p:sp>
+        <p:nvSpPr>
+          <p:cNvPr id="18" name="Rounded Rectangle 17"/>
+          <p:cNvSpPr/>
+          <p:nvPr/>
+        </p:nvSpPr>
+        <p:spPr>
+          <a:xfrm>
+            <a:off x="9308592" y="4645152"/>
+            <a:ext cx="365760" cy="292608"/>
+          </a:xfrm>
+          <a:prstGeom prst="roundRect">
+            <a:avLst>
+              <a:gd name="adj" fmla="val 12000"/>
+            </a:avLst>
+          </a:prstGeom>
+          <a:noFill/>
+          <a:ln w="25400">
+            <a:solidFill>
+              <a:srgbClr val="2E4A6B"/>
+            </a:solidFill>
+          </a:ln>
+          <a:effectLst/>
+        </p:spPr>
+        <p:style>
+          <a:lnRef idx="1">
+            <a:schemeClr val="accent1"/>
+          </a:lnRef>
+          <a:fillRef idx="3">
+            <a:schemeClr val="accent1"/>
+          </a:fillRef>
+          <a:effectRef idx="2">
+            <a:schemeClr val="accent1"/>
+          </a:effectRef>
+          <a:fontRef idx="minor">
+            <a:schemeClr val="lt1"/>
+          </a:fontRef>
+        </p:style>
+        <p:txBody>
+          <a:bodyPr rtlCol="0" anchor="ctr"/>
+          <a:lstStyle/>
+          <a:p>
+            <a:pPr algn="ctr"/>
+          </a:p>
+        </p:txBody>
+      </p:sp>
+      <p:sp>
+        <p:nvSpPr>
+          <p:cNvPr id="19" name="Rounded Rectangle 18"/>
+          <p:cNvSpPr/>
+          <p:nvPr/>
+        </p:nvSpPr>
+        <p:spPr>
+          <a:xfrm>
+            <a:off x="10094976" y="4315968"/>
+            <a:ext cx="950976" cy="950976"/>
+          </a:xfrm>
+          <a:prstGeom prst="roundRect">
+            <a:avLst>
+              <a:gd name="adj" fmla="val 14000"/>
+            </a:avLst>
+          </a:prstGeom>
+          <a:solidFill>
+            <a:srgbClr val="FFFFFF"/>
+          </a:solidFill>
+          <a:ln w="12700">
+            <a:solidFill>
+              <a:srgbClr val="E1DDD2"/>
+            </a:solidFill>
+          </a:ln>
+          <a:effectLst/>
+        </p:spPr>
+        <p:style>
+          <a:lnRef idx="1">
+            <a:schemeClr val="accent1"/>
+          </a:lnRef>
+          <a:fillRef idx="3">
+            <a:schemeClr val="accent1"/>
+          </a:fillRef>
+          <a:effectRef idx="2">
+            <a:schemeClr val="accent1"/>
+          </a:effectRef>
+          <a:fontRef idx="minor">
+            <a:schemeClr val="lt1"/>
+          </a:fontRef>
+        </p:style>
+        <p:txBody>
+          <a:bodyPr rtlCol="0" anchor="ctr"/>
+          <a:lstStyle/>
+          <a:p>
+            <a:pPr algn="ctr"/>
+          </a:p>
+        </p:txBody>
+      </p:sp>
+      <p:sp>
+        <p:nvSpPr>
+          <p:cNvPr id="20" name="Rounded Rectangle 19"/>
+          <p:cNvSpPr/>
+          <p:nvPr/>
+        </p:nvSpPr>
+        <p:spPr>
+          <a:xfrm>
+            <a:off x="10387584" y="4608576"/>
+            <a:ext cx="365760" cy="274320"/>
+          </a:xfrm>
+          <a:prstGeom prst="roundRect">
+            <a:avLst>
+              <a:gd name="adj" fmla="val 10000"/>
+            </a:avLst>
+          </a:prstGeom>
+          <a:noFill/>
+          <a:ln w="25400">
+            <a:solidFill>
+              <a:srgbClr val="2E4A6B"/>
+            </a:solidFill>
+          </a:ln>
+          <a:effectLst/>
+        </p:spPr>
+        <p:style>
+          <a:lnRef idx="1">
+            <a:schemeClr val="accent1"/>
+          </a:lnRef>
+          <a:fillRef idx="3">
+            <a:schemeClr val="accent1"/>
+          </a:fillRef>
+          <a:effectRef idx="2">
+            <a:schemeClr val="accent1"/>
+          </a:effectRef>
+          <a:fontRef idx="minor">
+            <a:schemeClr val="lt1"/>
+          </a:fontRef>
+        </p:style>
+        <p:txBody>
+          <a:bodyPr rtlCol="0" anchor="ctr"/>
+          <a:lstStyle/>
+          <a:p>
+            <a:pPr algn="ctr"/>
+          </a:p>
+        </p:txBody>
+      </p:sp>
+      <p:sp>
+        <p:nvSpPr>
+          <p:cNvPr id="21" name="Rectangle 20"/>
+          <p:cNvSpPr/>
+          <p:nvPr/>
+        </p:nvSpPr>
+        <p:spPr>
+          <a:xfrm>
+            <a:off x="10323576" y="4882896"/>
+            <a:ext cx="493776" cy="45720"/>
+          </a:xfrm>
+          <a:prstGeom prst="rect">
+            <a:avLst/>
+          </a:prstGeom>
+          <a:solidFill>
+            <a:srgbClr val="2E4A6B"/>
+          </a:solidFill>
+          <a:ln>
+            <a:noFill/>
+          </a:ln>
+          <a:effectLst/>
+        </p:spPr>
+        <p:style>
+          <a:lnRef idx="1">
+            <a:schemeClr val="accent1"/>
+          </a:lnRef>
+          <a:fillRef idx="3">
+            <a:schemeClr val="accent1"/>
+          </a:fillRef>
+          <a:effectRef idx="2">
+            <a:schemeClr val="accent1"/>
+          </a:effectRef>
+          <a:fontRef idx="minor">
+            <a:schemeClr val="lt1"/>
+          </a:fontRef>
+        </p:style>
+        <p:txBody>
+          <a:bodyPr rtlCol="0" anchor="ctr"/>
+          <a:lstStyle/>
+          <a:p>
+            <a:pPr algn="ctr"/>
+          </a:p>
+        </p:txBody>
+      </p:sp>
+      <p:sp>
+        <p:nvSpPr>
+          <p:cNvPr id="22" name="TextBox 21"/>
+          <p:cNvSpPr txBox="1"/>
+          <p:nvPr/>
+        </p:nvSpPr>
+        <p:spPr>
+          <a:xfrm>
+            <a:off x="7863840" y="5413248"/>
+            <a:ext cx="3566160" cy="320040"/>
+          </a:xfrm>
+          <a:prstGeom prst="rect">
+            <a:avLst/>
+          </a:prstGeom>
+          <a:noFill/>
+        </p:spPr>
+        <p:txBody>
+          <a:bodyPr wrap="square" anchor="t" lIns="0" rIns="0" tIns="0" bIns="0">
+            <a:spAutoFit/>
+          </a:bodyPr>
+          <a:lstStyle/>
+          <a:p>
+            <a:pPr algn="ctr">
+              <a:spcAft>
+                <a:spcPts val="0"/>
+              </a:spcAft>
+            </a:pPr>
+            <a:r>
+              <a:rPr sz="1050" b="0" i="1">
+                <a:solidFill>
+                  <a:srgbClr val="5B6470"/>
+                </a:solidFill>
+                <a:latin typeface="Calibri"/>
+              </a:rPr>
+              <a:t>your library, on every device</a:t>
+            </a:r>
+          </a:p>
+        </p:txBody>
+      </p:sp>
+      <p:sp>
+        <p:nvSpPr>
+          <p:cNvPr id="23" name="TextBox 22"/>
           <p:cNvSpPr txBox="1"/>
           <p:nvPr/>
         </p:nvSpPr>
@@ -4877,16 +5287,62 @@
       </p:sp>
       <p:sp>
         <p:nvSpPr>
-          <p:cNvPr id="20" name="Oval 19"/>
+          <p:cNvPr id="20" name="Rounded Rectangle 19"/>
           <p:cNvSpPr/>
           <p:nvPr/>
         </p:nvSpPr>
         <p:spPr>
           <a:xfrm>
-            <a:off x="4178808" y="2761488"/>
-            <a:ext cx="146304" cy="146304"/>
-          </a:xfrm>
-          <a:prstGeom prst="ellipse">
+            <a:off x="4133088" y="2651760"/>
+            <a:ext cx="237744" cy="365760"/>
+          </a:xfrm>
+          <a:prstGeom prst="roundRect">
+            <a:avLst>
+              <a:gd name="adj" fmla="val 20000"/>
+            </a:avLst>
+          </a:prstGeom>
+          <a:noFill/>
+          <a:ln w="25400">
+            <a:solidFill>
+              <a:srgbClr val="2F8F83"/>
+            </a:solidFill>
+          </a:ln>
+          <a:effectLst/>
+        </p:spPr>
+        <p:style>
+          <a:lnRef idx="1">
+            <a:schemeClr val="accent1"/>
+          </a:lnRef>
+          <a:fillRef idx="3">
+            <a:schemeClr val="accent1"/>
+          </a:fillRef>
+          <a:effectRef idx="2">
+            <a:schemeClr val="accent1"/>
+          </a:effectRef>
+          <a:fontRef idx="minor">
+            <a:schemeClr val="lt1"/>
+          </a:fontRef>
+        </p:style>
+        <p:txBody>
+          <a:bodyPr rtlCol="0" anchor="ctr"/>
+          <a:lstStyle/>
+          <a:p>
+            <a:pPr algn="ctr"/>
+          </a:p>
+        </p:txBody>
+      </p:sp>
+      <p:sp>
+        <p:nvSpPr>
+          <p:cNvPr id="21" name="Rectangle 20"/>
+          <p:cNvSpPr/>
+          <p:nvPr/>
+        </p:nvSpPr>
+        <p:spPr>
+          <a:xfrm>
+            <a:off x="4210812" y="2935224"/>
+            <a:ext cx="82296" cy="22860"/>
+          </a:xfrm>
+          <a:prstGeom prst="rect">
             <a:avLst/>
           </a:prstGeom>
           <a:solidFill>
@@ -4921,7 +5377,7 @@
       </p:sp>
       <p:sp>
         <p:nvSpPr>
-          <p:cNvPr id="21" name="TextBox 20"/>
+          <p:cNvPr id="22" name="TextBox 21"/>
           <p:cNvSpPr txBox="1"/>
           <p:nvPr/>
         </p:nvSpPr>
@@ -4979,7 +5435,7 @@
       </p:sp>
       <p:sp>
         <p:nvSpPr>
-          <p:cNvPr id="22" name="Rounded Rectangle 21"/>
+          <p:cNvPr id="23" name="Rounded Rectangle 22"/>
           <p:cNvSpPr/>
           <p:nvPr/>
         </p:nvSpPr>
@@ -5027,16 +5483,16 @@
       </p:sp>
       <p:sp>
         <p:nvSpPr>
-          <p:cNvPr id="23" name="Oval 22"/>
+          <p:cNvPr id="24" name="Block Arc 23"/>
           <p:cNvSpPr/>
           <p:nvPr/>
         </p:nvSpPr>
         <p:spPr>
           <a:xfrm>
-            <a:off x="4178808" y="3749040"/>
-            <a:ext cx="146304" cy="146304"/>
-          </a:xfrm>
-          <a:prstGeom prst="ellipse">
+            <a:off x="4069080" y="3675887"/>
+            <a:ext cx="365760" cy="365760"/>
+          </a:xfrm>
+          <a:prstGeom prst="blockArc">
             <a:avLst/>
           </a:prstGeom>
           <a:solidFill>
@@ -5071,7 +5527,97 @@
       </p:sp>
       <p:sp>
         <p:nvSpPr>
-          <p:cNvPr id="24" name="TextBox 23"/>
+          <p:cNvPr id="25" name="Oval 24"/>
+          <p:cNvSpPr/>
+          <p:nvPr/>
+        </p:nvSpPr>
+        <p:spPr>
+          <a:xfrm>
+            <a:off x="4206240" y="3895344"/>
+            <a:ext cx="91440" cy="91440"/>
+          </a:xfrm>
+          <a:prstGeom prst="ellipse">
+            <a:avLst/>
+          </a:prstGeom>
+          <a:solidFill>
+            <a:srgbClr val="2F8F83"/>
+          </a:solidFill>
+          <a:ln>
+            <a:noFill/>
+          </a:ln>
+          <a:effectLst/>
+        </p:spPr>
+        <p:style>
+          <a:lnRef idx="1">
+            <a:schemeClr val="accent1"/>
+          </a:lnRef>
+          <a:fillRef idx="3">
+            <a:schemeClr val="accent1"/>
+          </a:fillRef>
+          <a:effectRef idx="2">
+            <a:schemeClr val="accent1"/>
+          </a:effectRef>
+          <a:fontRef idx="minor">
+            <a:schemeClr val="lt1"/>
+          </a:fontRef>
+        </p:style>
+        <p:txBody>
+          <a:bodyPr rtlCol="0" anchor="ctr"/>
+          <a:lstStyle/>
+          <a:p>
+            <a:pPr algn="ctr"/>
+          </a:p>
+        </p:txBody>
+      </p:sp>
+      <p:sp>
+        <p:nvSpPr>
+          <p:cNvPr id="26" name="Rectangle 25"/>
+          <p:cNvSpPr/>
+          <p:nvPr/>
+        </p:nvSpPr>
+        <p:spPr>
+          <a:xfrm rot="2700000">
+            <a:off x="4233672" y="3584448"/>
+            <a:ext cx="41148" cy="457200"/>
+          </a:xfrm>
+          <a:prstGeom prst="rect">
+            <a:avLst/>
+          </a:prstGeom>
+          <a:solidFill>
+            <a:srgbClr val="FFFFFF"/>
+          </a:solidFill>
+          <a:ln w="9525">
+            <a:solidFill>
+              <a:srgbClr val="2F8F83"/>
+            </a:solidFill>
+          </a:ln>
+          <a:effectLst/>
+        </p:spPr>
+        <p:style>
+          <a:lnRef idx="1">
+            <a:schemeClr val="accent1"/>
+          </a:lnRef>
+          <a:fillRef idx="3">
+            <a:schemeClr val="accent1"/>
+          </a:fillRef>
+          <a:effectRef idx="2">
+            <a:schemeClr val="accent1"/>
+          </a:effectRef>
+          <a:fontRef idx="minor">
+            <a:schemeClr val="lt1"/>
+          </a:fontRef>
+        </p:style>
+        <p:txBody>
+          <a:bodyPr rtlCol="0" anchor="ctr"/>
+          <a:lstStyle/>
+          <a:p>
+            <a:pPr algn="ctr"/>
+          </a:p>
+        </p:txBody>
+      </p:sp>
+      <p:sp>
+        <p:nvSpPr>
+          <p:cNvPr id="27" name="TextBox 26"/>
           <p:cNvSpPr txBox="1"/>
           <p:nvPr/>
         </p:nvSpPr>
@@ -5129,7 +5675,7 @@
       </p:sp>
       <p:sp>
         <p:nvSpPr>
-          <p:cNvPr id="25" name="Rounded Rectangle 24"/>
+          <p:cNvPr id="28" name="Rounded Rectangle 27"/>
           <p:cNvSpPr/>
           <p:nvPr/>
         </p:nvSpPr>
@@ -5177,17 +5723,63 @@
       </p:sp>
       <p:sp>
         <p:nvSpPr>
-          <p:cNvPr id="26" name="Oval 25"/>
+          <p:cNvPr id="29" name="Oval 28"/>
           <p:cNvSpPr/>
           <p:nvPr/>
         </p:nvSpPr>
         <p:spPr>
           <a:xfrm>
-            <a:off x="4178808" y="4736592"/>
-            <a:ext cx="146304" cy="146304"/>
+            <a:off x="4142232" y="4608576"/>
+            <a:ext cx="219456" cy="219456"/>
           </a:xfrm>
           <a:prstGeom prst="ellipse">
             <a:avLst/>
+          </a:prstGeom>
+          <a:noFill/>
+          <a:ln w="25400">
+            <a:solidFill>
+              <a:srgbClr val="2F8F83"/>
+            </a:solidFill>
+          </a:ln>
+          <a:effectLst/>
+        </p:spPr>
+        <p:style>
+          <a:lnRef idx="1">
+            <a:schemeClr val="accent1"/>
+          </a:lnRef>
+          <a:fillRef idx="3">
+            <a:schemeClr val="accent1"/>
+          </a:fillRef>
+          <a:effectRef idx="2">
+            <a:schemeClr val="accent1"/>
+          </a:effectRef>
+          <a:fontRef idx="minor">
+            <a:schemeClr val="lt1"/>
+          </a:fontRef>
+        </p:style>
+        <p:txBody>
+          <a:bodyPr rtlCol="0" anchor="ctr"/>
+          <a:lstStyle/>
+          <a:p>
+            <a:pPr algn="ctr"/>
+          </a:p>
+        </p:txBody>
+      </p:sp>
+      <p:sp>
+        <p:nvSpPr>
+          <p:cNvPr id="30" name="Rounded Rectangle 29"/>
+          <p:cNvSpPr/>
+          <p:nvPr/>
+        </p:nvSpPr>
+        <p:spPr>
+          <a:xfrm>
+            <a:off x="4105656" y="4754880"/>
+            <a:ext cx="292608" cy="256032"/>
+          </a:xfrm>
+          <a:prstGeom prst="roundRect">
+            <a:avLst>
+              <a:gd name="adj" fmla="val 18000"/>
+            </a:avLst>
           </a:prstGeom>
           <a:solidFill>
             <a:srgbClr val="2F8F83"/>
@@ -5221,7 +5813,51 @@
       </p:sp>
       <p:sp>
         <p:nvSpPr>
-          <p:cNvPr id="27" name="TextBox 26"/>
+          <p:cNvPr id="31" name="Oval 30"/>
+          <p:cNvSpPr/>
+          <p:nvPr/>
+        </p:nvSpPr>
+        <p:spPr>
+          <a:xfrm>
+            <a:off x="4219956" y="4837176"/>
+            <a:ext cx="64008" cy="64008"/>
+          </a:xfrm>
+          <a:prstGeom prst="ellipse">
+            <a:avLst/>
+          </a:prstGeom>
+          <a:solidFill>
+            <a:srgbClr val="FFFFFF"/>
+          </a:solidFill>
+          <a:ln>
+            <a:noFill/>
+          </a:ln>
+          <a:effectLst/>
+        </p:spPr>
+        <p:style>
+          <a:lnRef idx="1">
+            <a:schemeClr val="accent1"/>
+          </a:lnRef>
+          <a:fillRef idx="3">
+            <a:schemeClr val="accent1"/>
+          </a:fillRef>
+          <a:effectRef idx="2">
+            <a:schemeClr val="accent1"/>
+          </a:effectRef>
+          <a:fontRef idx="minor">
+            <a:schemeClr val="lt1"/>
+          </a:fontRef>
+        </p:style>
+        <p:txBody>
+          <a:bodyPr rtlCol="0" anchor="ctr"/>
+          <a:lstStyle/>
+          <a:p>
+            <a:pPr algn="ctr"/>
+          </a:p>
+        </p:txBody>
+      </p:sp>
+      <p:sp>
+        <p:nvSpPr>
+          <p:cNvPr id="32" name="TextBox 31"/>
           <p:cNvSpPr txBox="1"/>
           <p:nvPr/>
         </p:nvSpPr>
@@ -5279,7 +5915,7 @@
       </p:sp>
       <p:sp>
         <p:nvSpPr>
-          <p:cNvPr id="28" name="Rounded Rectangle 27"/>
+          <p:cNvPr id="33" name="Rounded Rectangle 32"/>
           <p:cNvSpPr/>
           <p:nvPr/>
         </p:nvSpPr>
@@ -5327,16 +5963,16 @@
       </p:sp>
       <p:sp>
         <p:nvSpPr>
-          <p:cNvPr id="29" name="Oval 28"/>
+          <p:cNvPr id="34" name="5-Point Star 33"/>
           <p:cNvSpPr/>
           <p:nvPr/>
         </p:nvSpPr>
         <p:spPr>
           <a:xfrm>
-            <a:off x="4178808" y="5724144"/>
-            <a:ext cx="146304" cy="146304"/>
-          </a:xfrm>
-          <a:prstGeom prst="ellipse">
+            <a:off x="4069080" y="5614416"/>
+            <a:ext cx="365760" cy="365760"/>
+          </a:xfrm>
+          <a:prstGeom prst="star5">
             <a:avLst/>
           </a:prstGeom>
           <a:solidFill>
@@ -5371,7 +6007,7 @@
       </p:sp>
       <p:sp>
         <p:nvSpPr>
-          <p:cNvPr id="30" name="TextBox 29"/>
+          <p:cNvPr id="35" name="TextBox 34"/>
           <p:cNvSpPr txBox="1"/>
           <p:nvPr/>
         </p:nvSpPr>
@@ -5748,23 +6384,27 @@
       </p:sp>
       <p:sp>
         <p:nvSpPr>
-          <p:cNvPr id="9" name="Oval 8"/>
+          <p:cNvPr id="9" name="Rounded Rectangle 8"/>
           <p:cNvSpPr/>
           <p:nvPr/>
         </p:nvSpPr>
         <p:spPr>
           <a:xfrm>
-            <a:off x="978408" y="2670048"/>
-            <a:ext cx="146304" cy="146304"/>
-          </a:xfrm>
-          <a:prstGeom prst="ellipse">
-            <a:avLst/>
+            <a:off x="1033271" y="2569464"/>
+            <a:ext cx="201168" cy="329184"/>
+          </a:xfrm>
+          <a:prstGeom prst="roundRect">
+            <a:avLst>
+              <a:gd name="adj" fmla="val 15000"/>
+            </a:avLst>
           </a:prstGeom>
           <a:solidFill>
-            <a:srgbClr val="B5822E"/>
+            <a:srgbClr val="FFFFFF"/>
           </a:solidFill>
-          <a:ln>
-            <a:noFill/>
+          <a:ln w="25400">
+            <a:solidFill>
+              <a:srgbClr val="B5822E"/>
+            </a:solidFill>
           </a:ln>
           <a:effectLst/>
         </p:spPr>
@@ -5792,7 +6432,55 @@
       </p:sp>
       <p:sp>
         <p:nvSpPr>
-          <p:cNvPr id="10" name="TextBox 9"/>
+          <p:cNvPr id="10" name="Rounded Rectangle 9"/>
+          <p:cNvSpPr/>
+          <p:nvPr/>
+        </p:nvSpPr>
+        <p:spPr>
+          <a:xfrm>
+            <a:off x="868680" y="2688336"/>
+            <a:ext cx="146304" cy="237744"/>
+          </a:xfrm>
+          <a:prstGeom prst="roundRect">
+            <a:avLst>
+              <a:gd name="adj" fmla="val 18000"/>
+            </a:avLst>
+          </a:prstGeom>
+          <a:solidFill>
+            <a:srgbClr val="FFFFFF"/>
+          </a:solidFill>
+          <a:ln w="25400">
+            <a:solidFill>
+              <a:srgbClr val="B5822E"/>
+            </a:solidFill>
+          </a:ln>
+          <a:effectLst/>
+        </p:spPr>
+        <p:style>
+          <a:lnRef idx="1">
+            <a:schemeClr val="accent1"/>
+          </a:lnRef>
+          <a:fillRef idx="3">
+            <a:schemeClr val="accent1"/>
+          </a:fillRef>
+          <a:effectRef idx="2">
+            <a:schemeClr val="accent1"/>
+          </a:effectRef>
+          <a:fontRef idx="minor">
+            <a:schemeClr val="lt1"/>
+          </a:fontRef>
+        </p:style>
+        <p:txBody>
+          <a:bodyPr rtlCol="0" anchor="ctr"/>
+          <a:lstStyle/>
+          <a:p>
+            <a:pPr algn="ctr"/>
+          </a:p>
+        </p:txBody>
+      </p:sp>
+      <p:sp>
+        <p:nvSpPr>
+          <p:cNvPr id="11" name="TextBox 10"/>
           <p:cNvSpPr txBox="1"/>
           <p:nvPr/>
         </p:nvSpPr>
@@ -5850,7 +6538,7 @@
       </p:sp>
       <p:sp>
         <p:nvSpPr>
-          <p:cNvPr id="11" name="Rounded Rectangle 10"/>
+          <p:cNvPr id="12" name="Rounded Rectangle 11"/>
           <p:cNvSpPr/>
           <p:nvPr/>
         </p:nvSpPr>
@@ -5898,17 +6586,63 @@
       </p:sp>
       <p:sp>
         <p:nvSpPr>
-          <p:cNvPr id="12" name="Oval 11"/>
+          <p:cNvPr id="13" name="Oval 12"/>
           <p:cNvSpPr/>
           <p:nvPr/>
         </p:nvSpPr>
         <p:spPr>
           <a:xfrm>
-            <a:off x="978408" y="3630168"/>
-            <a:ext cx="146304" cy="146304"/>
+            <a:off x="896111" y="3529584"/>
+            <a:ext cx="256032" cy="256032"/>
           </a:xfrm>
           <a:prstGeom prst="ellipse">
             <a:avLst/>
+          </a:prstGeom>
+          <a:noFill/>
+          <a:ln w="25400">
+            <a:solidFill>
+              <a:srgbClr val="B5822E"/>
+            </a:solidFill>
+          </a:ln>
+          <a:effectLst/>
+        </p:spPr>
+        <p:style>
+          <a:lnRef idx="1">
+            <a:schemeClr val="accent1"/>
+          </a:lnRef>
+          <a:fillRef idx="3">
+            <a:schemeClr val="accent1"/>
+          </a:fillRef>
+          <a:effectRef idx="2">
+            <a:schemeClr val="accent1"/>
+          </a:effectRef>
+          <a:fontRef idx="minor">
+            <a:schemeClr val="lt1"/>
+          </a:fontRef>
+        </p:style>
+        <p:txBody>
+          <a:bodyPr rtlCol="0" anchor="ctr"/>
+          <a:lstStyle/>
+          <a:p>
+            <a:pPr algn="ctr"/>
+          </a:p>
+        </p:txBody>
+      </p:sp>
+      <p:sp>
+        <p:nvSpPr>
+          <p:cNvPr id="14" name="Rounded Rectangle 13"/>
+          <p:cNvSpPr/>
+          <p:nvPr/>
+        </p:nvSpPr>
+        <p:spPr>
+          <a:xfrm rot="18900000">
+            <a:off x="1115568" y="3767328"/>
+            <a:ext cx="36576" cy="146304"/>
+          </a:xfrm>
+          <a:prstGeom prst="roundRect">
+            <a:avLst>
+              <a:gd name="adj" fmla="val 50000"/>
+            </a:avLst>
           </a:prstGeom>
           <a:solidFill>
             <a:srgbClr val="B5822E"/>
@@ -5942,7 +6676,7 @@
       </p:sp>
       <p:sp>
         <p:nvSpPr>
-          <p:cNvPr id="13" name="TextBox 12"/>
+          <p:cNvPr id="15" name="TextBox 14"/>
           <p:cNvSpPr txBox="1"/>
           <p:nvPr/>
         </p:nvSpPr>
@@ -6000,7 +6734,7 @@
       </p:sp>
       <p:sp>
         <p:nvSpPr>
-          <p:cNvPr id="14" name="Rounded Rectangle 13"/>
+          <p:cNvPr id="16" name="Rounded Rectangle 15"/>
           <p:cNvSpPr/>
           <p:nvPr/>
         </p:nvSpPr>
@@ -6048,17 +6782,63 @@
       </p:sp>
       <p:sp>
         <p:nvSpPr>
-          <p:cNvPr id="15" name="Oval 14"/>
+          <p:cNvPr id="17" name="Oval 16"/>
           <p:cNvSpPr/>
           <p:nvPr/>
         </p:nvSpPr>
         <p:spPr>
           <a:xfrm>
-            <a:off x="978408" y="4590288"/>
-            <a:ext cx="146304" cy="146304"/>
+            <a:off x="941831" y="4462272"/>
+            <a:ext cx="219456" cy="219456"/>
           </a:xfrm>
           <a:prstGeom prst="ellipse">
             <a:avLst/>
+          </a:prstGeom>
+          <a:noFill/>
+          <a:ln w="25400">
+            <a:solidFill>
+              <a:srgbClr val="B5822E"/>
+            </a:solidFill>
+          </a:ln>
+          <a:effectLst/>
+        </p:spPr>
+        <p:style>
+          <a:lnRef idx="1">
+            <a:schemeClr val="accent1"/>
+          </a:lnRef>
+          <a:fillRef idx="3">
+            <a:schemeClr val="accent1"/>
+          </a:fillRef>
+          <a:effectRef idx="2">
+            <a:schemeClr val="accent1"/>
+          </a:effectRef>
+          <a:fontRef idx="minor">
+            <a:schemeClr val="lt1"/>
+          </a:fontRef>
+        </p:style>
+        <p:txBody>
+          <a:bodyPr rtlCol="0" anchor="ctr"/>
+          <a:lstStyle/>
+          <a:p>
+            <a:pPr algn="ctr"/>
+          </a:p>
+        </p:txBody>
+      </p:sp>
+      <p:sp>
+        <p:nvSpPr>
+          <p:cNvPr id="18" name="Rounded Rectangle 17"/>
+          <p:cNvSpPr/>
+          <p:nvPr/>
+        </p:nvSpPr>
+        <p:spPr>
+          <a:xfrm>
+            <a:off x="905255" y="4608576"/>
+            <a:ext cx="292608" cy="256032"/>
+          </a:xfrm>
+          <a:prstGeom prst="roundRect">
+            <a:avLst>
+              <a:gd name="adj" fmla="val 18000"/>
+            </a:avLst>
           </a:prstGeom>
           <a:solidFill>
             <a:srgbClr val="B5822E"/>
@@ -6092,7 +6872,51 @@
       </p:sp>
       <p:sp>
         <p:nvSpPr>
-          <p:cNvPr id="16" name="TextBox 15"/>
+          <p:cNvPr id="19" name="Oval 18"/>
+          <p:cNvSpPr/>
+          <p:nvPr/>
+        </p:nvSpPr>
+        <p:spPr>
+          <a:xfrm>
+            <a:off x="1019556" y="4690872"/>
+            <a:ext cx="64008" cy="64008"/>
+          </a:xfrm>
+          <a:prstGeom prst="ellipse">
+            <a:avLst/>
+          </a:prstGeom>
+          <a:solidFill>
+            <a:srgbClr val="FFFFFF"/>
+          </a:solidFill>
+          <a:ln>
+            <a:noFill/>
+          </a:ln>
+          <a:effectLst/>
+        </p:spPr>
+        <p:style>
+          <a:lnRef idx="1">
+            <a:schemeClr val="accent1"/>
+          </a:lnRef>
+          <a:fillRef idx="3">
+            <a:schemeClr val="accent1"/>
+          </a:fillRef>
+          <a:effectRef idx="2">
+            <a:schemeClr val="accent1"/>
+          </a:effectRef>
+          <a:fontRef idx="minor">
+            <a:schemeClr val="lt1"/>
+          </a:fontRef>
+        </p:style>
+        <p:txBody>
+          <a:bodyPr rtlCol="0" anchor="ctr"/>
+          <a:lstStyle/>
+          <a:p>
+            <a:pPr algn="ctr"/>
+          </a:p>
+        </p:txBody>
+      </p:sp>
+      <p:sp>
+        <p:nvSpPr>
+          <p:cNvPr id="20" name="TextBox 19"/>
           <p:cNvSpPr txBox="1"/>
           <p:nvPr/>
         </p:nvSpPr>
@@ -6150,7 +6974,7 @@
       </p:sp>
       <p:sp>
         <p:nvSpPr>
-          <p:cNvPr id="17" name="Rounded Rectangle 16"/>
+          <p:cNvPr id="21" name="Rounded Rectangle 20"/>
           <p:cNvSpPr/>
           <p:nvPr/>
         </p:nvSpPr>
@@ -6198,16 +7022,16 @@
       </p:sp>
       <p:sp>
         <p:nvSpPr>
-          <p:cNvPr id="18" name="Oval 17"/>
+          <p:cNvPr id="22" name="Up Arrow 21"/>
           <p:cNvSpPr/>
           <p:nvPr/>
         </p:nvSpPr>
         <p:spPr>
           <a:xfrm>
-            <a:off x="978408" y="5550408"/>
-            <a:ext cx="146304" cy="146304"/>
-          </a:xfrm>
-          <a:prstGeom prst="ellipse">
+            <a:off x="914399" y="5440680"/>
+            <a:ext cx="274320" cy="365760"/>
+          </a:xfrm>
+          <a:prstGeom prst="upArrow">
             <a:avLst/>
           </a:prstGeom>
           <a:solidFill>
@@ -6242,7 +7066,7 @@
       </p:sp>
       <p:sp>
         <p:nvSpPr>
-          <p:cNvPr id="19" name="TextBox 18"/>
+          <p:cNvPr id="23" name="TextBox 22"/>
           <p:cNvSpPr txBox="1"/>
           <p:nvPr/>
         </p:nvSpPr>
@@ -6300,7 +7124,7 @@
       </p:sp>
       <p:sp>
         <p:nvSpPr>
-          <p:cNvPr id="20" name="Rounded Rectangle 19"/>
+          <p:cNvPr id="24" name="Rounded Rectangle 23"/>
           <p:cNvSpPr/>
           <p:nvPr/>
         </p:nvSpPr>
@@ -6348,7 +7172,7 @@
       </p:sp>
       <p:sp>
         <p:nvSpPr>
-          <p:cNvPr id="21" name="TextBox 20"/>
+          <p:cNvPr id="25" name="TextBox 24"/>
           <p:cNvSpPr txBox="1"/>
           <p:nvPr/>
         </p:nvSpPr>
@@ -6403,7 +7227,7 @@
       </p:sp>
       <p:sp>
         <p:nvSpPr>
-          <p:cNvPr id="22" name="Rounded Rectangle 21"/>
+          <p:cNvPr id="26" name="Rounded Rectangle 25"/>
           <p:cNvSpPr/>
           <p:nvPr/>
         </p:nvSpPr>
@@ -6449,7 +7273,7 @@
       </p:sp>
       <p:sp>
         <p:nvSpPr>
-          <p:cNvPr id="23" name="TextBox 22"/>
+          <p:cNvPr id="27" name="TextBox 26"/>
           <p:cNvSpPr txBox="1"/>
           <p:nvPr/>
         </p:nvSpPr>
@@ -6488,7 +7312,7 @@
       </p:sp>
       <p:sp>
         <p:nvSpPr>
-          <p:cNvPr id="24" name="Rounded Rectangle 23"/>
+          <p:cNvPr id="28" name="Rounded Rectangle 27"/>
           <p:cNvSpPr/>
           <p:nvPr/>
         </p:nvSpPr>
@@ -6534,7 +7358,7 @@
       </p:sp>
       <p:sp>
         <p:nvSpPr>
-          <p:cNvPr id="25" name="TextBox 24"/>
+          <p:cNvPr id="29" name="TextBox 28"/>
           <p:cNvSpPr txBox="1"/>
           <p:nvPr/>
         </p:nvSpPr>
@@ -6573,7 +7397,7 @@
       </p:sp>
       <p:sp>
         <p:nvSpPr>
-          <p:cNvPr id="26" name="Rounded Rectangle 25"/>
+          <p:cNvPr id="30" name="Rounded Rectangle 29"/>
           <p:cNvSpPr/>
           <p:nvPr/>
         </p:nvSpPr>
@@ -6619,7 +7443,7 @@
       </p:sp>
       <p:sp>
         <p:nvSpPr>
-          <p:cNvPr id="27" name="TextBox 26"/>
+          <p:cNvPr id="31" name="TextBox 30"/>
           <p:cNvSpPr txBox="1"/>
           <p:nvPr/>
         </p:nvSpPr>
@@ -6658,7 +7482,7 @@
       </p:sp>
       <p:sp>
         <p:nvSpPr>
-          <p:cNvPr id="28" name="Rounded Rectangle 27"/>
+          <p:cNvPr id="32" name="Rounded Rectangle 31"/>
           <p:cNvSpPr/>
           <p:nvPr/>
         </p:nvSpPr>
@@ -6704,7 +7528,7 @@
       </p:sp>
       <p:sp>
         <p:nvSpPr>
-          <p:cNvPr id="29" name="TextBox 28"/>
+          <p:cNvPr id="33" name="TextBox 32"/>
           <p:cNvSpPr txBox="1"/>
           <p:nvPr/>
         </p:nvSpPr>
@@ -6743,7 +7567,7 @@
       </p:sp>
       <p:sp>
         <p:nvSpPr>
-          <p:cNvPr id="30" name="Rounded Rectangle 29"/>
+          <p:cNvPr id="34" name="Rounded Rectangle 33"/>
           <p:cNvSpPr/>
           <p:nvPr/>
         </p:nvSpPr>
@@ -6791,7 +7615,7 @@
       </p:sp>
       <p:sp>
         <p:nvSpPr>
-          <p:cNvPr id="31" name="TextBox 30"/>
+          <p:cNvPr id="35" name="TextBox 34"/>
           <p:cNvSpPr txBox="1"/>
           <p:nvPr/>
         </p:nvSpPr>
@@ -6846,7 +7670,7 @@
       </p:sp>
       <p:sp>
         <p:nvSpPr>
-          <p:cNvPr id="32" name="Rounded Rectangle 31"/>
+          <p:cNvPr id="36" name="Rounded Rectangle 35"/>
           <p:cNvSpPr/>
           <p:nvPr/>
         </p:nvSpPr>
@@ -6892,7 +7716,7 @@
       </p:sp>
       <p:sp>
         <p:nvSpPr>
-          <p:cNvPr id="33" name="TextBox 32"/>
+          <p:cNvPr id="37" name="TextBox 36"/>
           <p:cNvSpPr txBox="1"/>
           <p:nvPr/>
         </p:nvSpPr>
@@ -6931,7 +7755,7 @@
       </p:sp>
       <p:sp>
         <p:nvSpPr>
-          <p:cNvPr id="34" name="Rounded Rectangle 33"/>
+          <p:cNvPr id="38" name="Rounded Rectangle 37"/>
           <p:cNvSpPr/>
           <p:nvPr/>
         </p:nvSpPr>
@@ -6977,7 +7801,7 @@
       </p:sp>
       <p:sp>
         <p:nvSpPr>
-          <p:cNvPr id="35" name="TextBox 34"/>
+          <p:cNvPr id="39" name="TextBox 38"/>
           <p:cNvSpPr txBox="1"/>
           <p:nvPr/>
         </p:nvSpPr>
@@ -7016,7 +7840,7 @@
       </p:sp>
       <p:sp>
         <p:nvSpPr>
-          <p:cNvPr id="36" name="Rounded Rectangle 35"/>
+          <p:cNvPr id="40" name="Rounded Rectangle 39"/>
           <p:cNvSpPr/>
           <p:nvPr/>
         </p:nvSpPr>
@@ -7064,7 +7888,7 @@
       </p:sp>
       <p:sp>
         <p:nvSpPr>
-          <p:cNvPr id="37" name="TextBox 36"/>
+          <p:cNvPr id="41" name="TextBox 40"/>
           <p:cNvSpPr txBox="1"/>
           <p:nvPr/>
         </p:nvSpPr>
@@ -7119,7 +7943,7 @@
       </p:sp>
       <p:sp>
         <p:nvSpPr>
-          <p:cNvPr id="38" name="Rounded Rectangle 37"/>
+          <p:cNvPr id="42" name="Rounded Rectangle 41"/>
           <p:cNvSpPr/>
           <p:nvPr/>
         </p:nvSpPr>
@@ -7165,7 +7989,7 @@
       </p:sp>
       <p:sp>
         <p:nvSpPr>
-          <p:cNvPr id="39" name="TextBox 38"/>
+          <p:cNvPr id="43" name="TextBox 42"/>
           <p:cNvSpPr txBox="1"/>
           <p:nvPr/>
         </p:nvSpPr>
@@ -7204,7 +8028,7 @@
       </p:sp>
       <p:sp>
         <p:nvSpPr>
-          <p:cNvPr id="40" name="Rounded Rectangle 39"/>
+          <p:cNvPr id="44" name="Rounded Rectangle 43"/>
           <p:cNvSpPr/>
           <p:nvPr/>
         </p:nvSpPr>
@@ -7250,7 +8074,7 @@
       </p:sp>
       <p:sp>
         <p:nvSpPr>
-          <p:cNvPr id="41" name="TextBox 40"/>
+          <p:cNvPr id="45" name="TextBox 44"/>
           <p:cNvSpPr txBox="1"/>
           <p:nvPr/>
         </p:nvSpPr>
@@ -7351,14 +8175,62 @@
       </p:sp>
       <p:sp>
         <p:nvSpPr>
-          <p:cNvPr id="3" name="TextBox 2"/>
+          <p:cNvPr id="3" name="Rounded Rectangle 2"/>
+          <p:cNvSpPr/>
+          <p:nvPr/>
+        </p:nvSpPr>
+        <p:spPr>
+          <a:xfrm>
+            <a:off x="822960" y="548640"/>
+            <a:ext cx="2176272" cy="384048"/>
+          </a:xfrm>
+          <a:prstGeom prst="roundRect">
+            <a:avLst>
+              <a:gd name="adj" fmla="val 50000"/>
+            </a:avLst>
+          </a:prstGeom>
+          <a:solidFill>
+            <a:srgbClr val="F6EEDD"/>
+          </a:solidFill>
+          <a:ln w="12700">
+            <a:solidFill>
+              <a:srgbClr val="B5822E"/>
+            </a:solidFill>
+          </a:ln>
+          <a:effectLst/>
+        </p:spPr>
+        <p:style>
+          <a:lnRef idx="1">
+            <a:schemeClr val="accent1"/>
+          </a:lnRef>
+          <a:fillRef idx="3">
+            <a:schemeClr val="accent1"/>
+          </a:fillRef>
+          <a:effectRef idx="2">
+            <a:schemeClr val="accent1"/>
+          </a:effectRef>
+          <a:fontRef idx="minor">
+            <a:schemeClr val="lt1"/>
+          </a:fontRef>
+        </p:style>
+        <p:txBody>
+          <a:bodyPr rtlCol="0" anchor="ctr"/>
+          <a:lstStyle/>
+          <a:p>
+            <a:pPr algn="ctr"/>
+          </a:p>
+        </p:txBody>
+      </p:sp>
+      <p:sp>
+        <p:nvSpPr>
+          <p:cNvPr id="4" name="TextBox 3"/>
           <p:cNvSpPr txBox="1"/>
           <p:nvPr/>
         </p:nvSpPr>
         <p:spPr>
           <a:xfrm>
-            <a:off x="822960" y="566928"/>
-            <a:ext cx="10515600" cy="365760"/>
+            <a:off x="822960" y="548640"/>
+            <a:ext cx="2176272" cy="384048"/>
           </a:xfrm>
           <a:prstGeom prst="rect">
             <a:avLst/>
@@ -7366,38 +8238,82 @@
           <a:noFill/>
         </p:spPr>
         <p:txBody>
-          <a:bodyPr wrap="square" anchor="t" lIns="0" rIns="0" tIns="0" bIns="0">
+          <a:bodyPr wrap="square" anchor="ctr" lIns="0" rIns="0" tIns="0" bIns="0">
             <a:spAutoFit/>
           </a:bodyPr>
           <a:lstStyle/>
           <a:p>
-            <a:pPr algn="l">
+            <a:pPr algn="ctr">
               <a:spcAft>
                 <a:spcPts val="0"/>
               </a:spcAft>
             </a:pPr>
             <a:r>
-              <a:rPr sz="1100" b="0" i="0">
+              <a:rPr sz="1200" b="1" i="0">
                 <a:solidFill>
-                  <a:srgbClr val="5B6470"/>
+                  <a:srgbClr val="B5822E"/>
                 </a:solidFill>
-                <a:latin typeface="Consolas"/>
+                <a:latin typeface="Calibri"/>
               </a:rPr>
-              <a:t>THREE PICTURES TO EXPLAIN IT</a:t>
-            </a:r>
-          </a:p>
-        </p:txBody>
-      </p:sp>
-      <p:sp>
-        <p:nvSpPr>
-          <p:cNvPr id="4" name="TextBox 3"/>
+              <a:t>  PAID · IN PRACTICE</a:t>
+            </a:r>
+          </a:p>
+        </p:txBody>
+      </p:sp>
+      <p:sp>
+        <p:nvSpPr>
+          <p:cNvPr id="5" name="Oval 4"/>
+          <p:cNvSpPr/>
+          <p:nvPr/>
+        </p:nvSpPr>
+        <p:spPr>
+          <a:xfrm>
+            <a:off x="950976" y="667512"/>
+            <a:ext cx="146304" cy="146304"/>
+          </a:xfrm>
+          <a:prstGeom prst="ellipse">
+            <a:avLst/>
+          </a:prstGeom>
+          <a:solidFill>
+            <a:srgbClr val="B5822E"/>
+          </a:solidFill>
+          <a:ln>
+            <a:noFill/>
+          </a:ln>
+          <a:effectLst/>
+        </p:spPr>
+        <p:style>
+          <a:lnRef idx="1">
+            <a:schemeClr val="accent1"/>
+          </a:lnRef>
+          <a:fillRef idx="3">
+            <a:schemeClr val="accent1"/>
+          </a:fillRef>
+          <a:effectRef idx="2">
+            <a:schemeClr val="accent1"/>
+          </a:effectRef>
+          <a:fontRef idx="minor">
+            <a:schemeClr val="lt1"/>
+          </a:fontRef>
+        </p:style>
+        <p:txBody>
+          <a:bodyPr rtlCol="0" anchor="ctr"/>
+          <a:lstStyle/>
+          <a:p>
+            <a:pPr algn="ctr"/>
+          </a:p>
+        </p:txBody>
+      </p:sp>
+      <p:sp>
+        <p:nvSpPr>
+          <p:cNvPr id="6" name="TextBox 5"/>
           <p:cNvSpPr txBox="1"/>
           <p:nvPr/>
         </p:nvSpPr>
         <p:spPr>
           <a:xfrm>
-            <a:off x="822960" y="914400"/>
-            <a:ext cx="10515600" cy="822960"/>
+            <a:off x="822960" y="1051560"/>
+            <a:ext cx="10515600" cy="640080"/>
           </a:xfrm>
           <a:prstGeom prst="rect">
             <a:avLst/>
@@ -7422,20 +8338,20 @@
                 </a:solidFill>
                 <a:latin typeface="Georgia"/>
               </a:rPr>
-              <a:t>Three pictures to explain it</a:t>
-            </a:r>
-          </a:p>
-        </p:txBody>
-      </p:sp>
-      <p:sp>
-        <p:nvSpPr>
-          <p:cNvPr id="5" name="TextBox 4"/>
+              <a:t>One day, three devices</a:t>
+            </a:r>
+          </a:p>
+        </p:txBody>
+      </p:sp>
+      <p:sp>
+        <p:nvSpPr>
+          <p:cNvPr id="7" name="TextBox 6"/>
           <p:cNvSpPr txBox="1"/>
           <p:nvPr/>
         </p:nvSpPr>
         <p:spPr>
           <a:xfrm>
-            <a:off x="822960" y="1627632"/>
+            <a:off x="822960" y="1737360"/>
             <a:ext cx="10058400" cy="457200"/>
           </a:xfrm>
           <a:prstGeom prst="rect">
@@ -7455,31 +8371,31 @@
               </a:spcAft>
             </a:pPr>
             <a:r>
-              <a:rPr sz="1400" b="0" i="0">
+              <a:rPr sz="1350" b="0" i="0">
                 <a:solidFill>
                   <a:srgbClr val="5B6470"/>
                 </a:solidFill>
                 <a:latin typeface="Calibri"/>
               </a:rPr>
-              <a:t>Each is a plain-language way to describe the choice.</a:t>
-            </a:r>
-          </a:p>
-        </p:txBody>
-      </p:sp>
-      <p:sp>
-        <p:nvSpPr>
-          <p:cNvPr id="6" name="Rounded Rectangle 5"/>
+              <a:t>Start on one device, finish on another — your library is simply there.</a:t>
+            </a:r>
+          </a:p>
+        </p:txBody>
+      </p:sp>
+      <p:sp>
+        <p:nvSpPr>
+          <p:cNvPr id="8" name="Rounded Rectangle 7"/>
           <p:cNvSpPr/>
           <p:nvPr/>
         </p:nvSpPr>
         <p:spPr>
           <a:xfrm>
-            <a:off x="623163" y="2468880"/>
-            <a:ext cx="3429000" cy="3703320"/>
+            <a:off x="435711" y="2880360"/>
+            <a:ext cx="2542032" cy="2514600"/>
           </a:xfrm>
           <a:prstGeom prst="roundRect">
             <a:avLst>
-              <a:gd name="adj" fmla="val 5000"/>
+              <a:gd name="adj" fmla="val 6000"/>
             </a:avLst>
           </a:prstGeom>
           <a:solidFill>
@@ -7516,6 +8432,1424 @@
       </p:sp>
       <p:sp>
         <p:nvSpPr>
+          <p:cNvPr id="9" name="Rounded Rectangle 8"/>
+          <p:cNvSpPr/>
+          <p:nvPr/>
+        </p:nvSpPr>
+        <p:spPr>
+          <a:xfrm>
+            <a:off x="1318107" y="3172968"/>
+            <a:ext cx="777240" cy="777240"/>
+          </a:xfrm>
+          <a:prstGeom prst="roundRect">
+            <a:avLst>
+              <a:gd name="adj" fmla="val 25000"/>
+            </a:avLst>
+          </a:prstGeom>
+          <a:solidFill>
+            <a:srgbClr val="E6ECF4"/>
+          </a:solidFill>
+          <a:ln w="12700">
+            <a:solidFill>
+              <a:srgbClr val="2E4A6B"/>
+            </a:solidFill>
+          </a:ln>
+          <a:effectLst/>
+        </p:spPr>
+        <p:style>
+          <a:lnRef idx="1">
+            <a:schemeClr val="accent1"/>
+          </a:lnRef>
+          <a:fillRef idx="3">
+            <a:schemeClr val="accent1"/>
+          </a:fillRef>
+          <a:effectRef idx="2">
+            <a:schemeClr val="accent1"/>
+          </a:effectRef>
+          <a:fontRef idx="minor">
+            <a:schemeClr val="lt1"/>
+          </a:fontRef>
+        </p:style>
+        <p:txBody>
+          <a:bodyPr rtlCol="0" anchor="ctr"/>
+          <a:lstStyle/>
+          <a:p>
+            <a:pPr algn="ctr"/>
+          </a:p>
+        </p:txBody>
+      </p:sp>
+      <p:sp>
+        <p:nvSpPr>
+          <p:cNvPr id="10" name="Rounded Rectangle 9"/>
+          <p:cNvSpPr/>
+          <p:nvPr/>
+        </p:nvSpPr>
+        <p:spPr>
+          <a:xfrm>
+            <a:off x="1587855" y="3378708"/>
+            <a:ext cx="237744" cy="365760"/>
+          </a:xfrm>
+          <a:prstGeom prst="roundRect">
+            <a:avLst>
+              <a:gd name="adj" fmla="val 20000"/>
+            </a:avLst>
+          </a:prstGeom>
+          <a:noFill/>
+          <a:ln w="25400">
+            <a:solidFill>
+              <a:srgbClr val="2E4A6B"/>
+            </a:solidFill>
+          </a:ln>
+          <a:effectLst/>
+        </p:spPr>
+        <p:style>
+          <a:lnRef idx="1">
+            <a:schemeClr val="accent1"/>
+          </a:lnRef>
+          <a:fillRef idx="3">
+            <a:schemeClr val="accent1"/>
+          </a:fillRef>
+          <a:effectRef idx="2">
+            <a:schemeClr val="accent1"/>
+          </a:effectRef>
+          <a:fontRef idx="minor">
+            <a:schemeClr val="lt1"/>
+          </a:fontRef>
+        </p:style>
+        <p:txBody>
+          <a:bodyPr rtlCol="0" anchor="ctr"/>
+          <a:lstStyle/>
+          <a:p>
+            <a:pPr algn="ctr"/>
+          </a:p>
+        </p:txBody>
+      </p:sp>
+      <p:sp>
+        <p:nvSpPr>
+          <p:cNvPr id="11" name="Rectangle 10"/>
+          <p:cNvSpPr/>
+          <p:nvPr/>
+        </p:nvSpPr>
+        <p:spPr>
+          <a:xfrm>
+            <a:off x="1665579" y="3662172"/>
+            <a:ext cx="82296" cy="22860"/>
+          </a:xfrm>
+          <a:prstGeom prst="rect">
+            <a:avLst/>
+          </a:prstGeom>
+          <a:solidFill>
+            <a:srgbClr val="2E4A6B"/>
+          </a:solidFill>
+          <a:ln>
+            <a:noFill/>
+          </a:ln>
+          <a:effectLst/>
+        </p:spPr>
+        <p:style>
+          <a:lnRef idx="1">
+            <a:schemeClr val="accent1"/>
+          </a:lnRef>
+          <a:fillRef idx="3">
+            <a:schemeClr val="accent1"/>
+          </a:fillRef>
+          <a:effectRef idx="2">
+            <a:schemeClr val="accent1"/>
+          </a:effectRef>
+          <a:fontRef idx="minor">
+            <a:schemeClr val="lt1"/>
+          </a:fontRef>
+        </p:style>
+        <p:txBody>
+          <a:bodyPr rtlCol="0" anchor="ctr"/>
+          <a:lstStyle/>
+          <a:p>
+            <a:pPr algn="ctr"/>
+          </a:p>
+        </p:txBody>
+      </p:sp>
+      <p:sp>
+        <p:nvSpPr>
+          <p:cNvPr id="12" name="TextBox 11"/>
+          <p:cNvSpPr txBox="1"/>
+          <p:nvPr/>
+        </p:nvSpPr>
+        <p:spPr>
+          <a:xfrm>
+            <a:off x="618591" y="4160520"/>
+            <a:ext cx="2176272" cy="274320"/>
+          </a:xfrm>
+          <a:prstGeom prst="rect">
+            <a:avLst/>
+          </a:prstGeom>
+          <a:noFill/>
+        </p:spPr>
+        <p:txBody>
+          <a:bodyPr wrap="square" anchor="t" lIns="0" rIns="0" tIns="0" bIns="0">
+            <a:spAutoFit/>
+          </a:bodyPr>
+          <a:lstStyle/>
+          <a:p>
+            <a:pPr algn="ctr">
+              <a:spcAft>
+                <a:spcPts val="0"/>
+              </a:spcAft>
+            </a:pPr>
+            <a:r>
+              <a:rPr sz="1000" b="1" i="0">
+                <a:solidFill>
+                  <a:srgbClr val="2E4A6B"/>
+                </a:solidFill>
+                <a:latin typeface="Consolas"/>
+              </a:rPr>
+              <a:t>ON THE TRAIN</a:t>
+            </a:r>
+          </a:p>
+        </p:txBody>
+      </p:sp>
+      <p:sp>
+        <p:nvSpPr>
+          <p:cNvPr id="13" name="TextBox 12"/>
+          <p:cNvSpPr txBox="1"/>
+          <p:nvPr/>
+        </p:nvSpPr>
+        <p:spPr>
+          <a:xfrm>
+            <a:off x="691743" y="4480560"/>
+            <a:ext cx="2029967" cy="822960"/>
+          </a:xfrm>
+          <a:prstGeom prst="rect">
+            <a:avLst/>
+          </a:prstGeom>
+          <a:noFill/>
+        </p:spPr>
+        <p:txBody>
+          <a:bodyPr wrap="square" anchor="t" lIns="0" rIns="0" tIns="0" bIns="0">
+            <a:spAutoFit/>
+          </a:bodyPr>
+          <a:lstStyle/>
+          <a:p>
+            <a:pPr algn="ctr">
+              <a:lnSpc>
+                <a:spcPct val="108000"/>
+              </a:lnSpc>
+              <a:spcAft>
+                <a:spcPts val="0"/>
+              </a:spcAft>
+            </a:pPr>
+            <a:r>
+              <a:rPr sz="1200" b="0" i="0">
+                <a:solidFill>
+                  <a:srgbClr val="1B2027"/>
+                </a:solidFill>
+                <a:latin typeface="Calibri"/>
+              </a:rPr>
+              <a:t>Draft a chapter on your phone.</a:t>
+            </a:r>
+          </a:p>
+        </p:txBody>
+      </p:sp>
+      <p:sp>
+        <p:nvSpPr>
+          <p:cNvPr id="14" name="Chevron 13"/>
+          <p:cNvSpPr/>
+          <p:nvPr/>
+        </p:nvSpPr>
+        <p:spPr>
+          <a:xfrm>
+            <a:off x="3023463" y="3982212"/>
+            <a:ext cx="292608" cy="310896"/>
+          </a:xfrm>
+          <a:prstGeom prst="chevron">
+            <a:avLst/>
+          </a:prstGeom>
+          <a:solidFill>
+            <a:srgbClr val="E1DDD2"/>
+          </a:solidFill>
+          <a:ln>
+            <a:noFill/>
+          </a:ln>
+          <a:effectLst/>
+        </p:spPr>
+        <p:style>
+          <a:lnRef idx="1">
+            <a:schemeClr val="accent1"/>
+          </a:lnRef>
+          <a:fillRef idx="3">
+            <a:schemeClr val="accent1"/>
+          </a:fillRef>
+          <a:effectRef idx="2">
+            <a:schemeClr val="accent1"/>
+          </a:effectRef>
+          <a:fontRef idx="minor">
+            <a:schemeClr val="lt1"/>
+          </a:fontRef>
+        </p:style>
+        <p:txBody>
+          <a:bodyPr rtlCol="0" anchor="ctr"/>
+          <a:lstStyle/>
+          <a:p>
+            <a:pPr algn="ctr"/>
+          </a:p>
+        </p:txBody>
+      </p:sp>
+      <p:sp>
+        <p:nvSpPr>
+          <p:cNvPr id="15" name="Rounded Rectangle 14"/>
+          <p:cNvSpPr/>
+          <p:nvPr/>
+        </p:nvSpPr>
+        <p:spPr>
+          <a:xfrm>
+            <a:off x="3361791" y="2880360"/>
+            <a:ext cx="2542032" cy="2514600"/>
+          </a:xfrm>
+          <a:prstGeom prst="roundRect">
+            <a:avLst>
+              <a:gd name="adj" fmla="val 6000"/>
+            </a:avLst>
+          </a:prstGeom>
+          <a:solidFill>
+            <a:srgbClr val="FFFFFF"/>
+          </a:solidFill>
+          <a:ln w="22225">
+            <a:solidFill>
+              <a:srgbClr val="B5822E"/>
+            </a:solidFill>
+          </a:ln>
+          <a:effectLst/>
+        </p:spPr>
+        <p:style>
+          <a:lnRef idx="1">
+            <a:schemeClr val="accent1"/>
+          </a:lnRef>
+          <a:fillRef idx="3">
+            <a:schemeClr val="accent1"/>
+          </a:fillRef>
+          <a:effectRef idx="2">
+            <a:schemeClr val="accent1"/>
+          </a:effectRef>
+          <a:fontRef idx="minor">
+            <a:schemeClr val="lt1"/>
+          </a:fontRef>
+        </p:style>
+        <p:txBody>
+          <a:bodyPr rtlCol="0" anchor="ctr"/>
+          <a:lstStyle/>
+          <a:p>
+            <a:pPr algn="ctr"/>
+          </a:p>
+        </p:txBody>
+      </p:sp>
+      <p:sp>
+        <p:nvSpPr>
+          <p:cNvPr id="16" name="Rounded Rectangle 15"/>
+          <p:cNvSpPr/>
+          <p:nvPr/>
+        </p:nvSpPr>
+        <p:spPr>
+          <a:xfrm>
+            <a:off x="4244187" y="3172968"/>
+            <a:ext cx="777240" cy="777240"/>
+          </a:xfrm>
+          <a:prstGeom prst="roundRect">
+            <a:avLst>
+              <a:gd name="adj" fmla="val 25000"/>
+            </a:avLst>
+          </a:prstGeom>
+          <a:solidFill>
+            <a:srgbClr val="F6EEDD"/>
+          </a:solidFill>
+          <a:ln w="12700">
+            <a:solidFill>
+              <a:srgbClr val="B5822E"/>
+            </a:solidFill>
+          </a:ln>
+          <a:effectLst/>
+        </p:spPr>
+        <p:style>
+          <a:lnRef idx="1">
+            <a:schemeClr val="accent1"/>
+          </a:lnRef>
+          <a:fillRef idx="3">
+            <a:schemeClr val="accent1"/>
+          </a:fillRef>
+          <a:effectRef idx="2">
+            <a:schemeClr val="accent1"/>
+          </a:effectRef>
+          <a:fontRef idx="minor">
+            <a:schemeClr val="lt1"/>
+          </a:fontRef>
+        </p:style>
+        <p:txBody>
+          <a:bodyPr rtlCol="0" anchor="ctr"/>
+          <a:lstStyle/>
+          <a:p>
+            <a:pPr algn="ctr"/>
+          </a:p>
+        </p:txBody>
+      </p:sp>
+      <p:sp>
+        <p:nvSpPr>
+          <p:cNvPr id="17" name="Oval 16"/>
+          <p:cNvSpPr/>
+          <p:nvPr/>
+        </p:nvSpPr>
+        <p:spPr>
+          <a:xfrm>
+            <a:off x="4523079" y="3360420"/>
+            <a:ext cx="219456" cy="219456"/>
+          </a:xfrm>
+          <a:prstGeom prst="ellipse">
+            <a:avLst/>
+          </a:prstGeom>
+          <a:noFill/>
+          <a:ln w="25400">
+            <a:solidFill>
+              <a:srgbClr val="B5822E"/>
+            </a:solidFill>
+          </a:ln>
+          <a:effectLst/>
+        </p:spPr>
+        <p:style>
+          <a:lnRef idx="1">
+            <a:schemeClr val="accent1"/>
+          </a:lnRef>
+          <a:fillRef idx="3">
+            <a:schemeClr val="accent1"/>
+          </a:fillRef>
+          <a:effectRef idx="2">
+            <a:schemeClr val="accent1"/>
+          </a:effectRef>
+          <a:fontRef idx="minor">
+            <a:schemeClr val="lt1"/>
+          </a:fontRef>
+        </p:style>
+        <p:txBody>
+          <a:bodyPr rtlCol="0" anchor="ctr"/>
+          <a:lstStyle/>
+          <a:p>
+            <a:pPr algn="ctr"/>
+          </a:p>
+        </p:txBody>
+      </p:sp>
+      <p:sp>
+        <p:nvSpPr>
+          <p:cNvPr id="18" name="Rounded Rectangle 17"/>
+          <p:cNvSpPr/>
+          <p:nvPr/>
+        </p:nvSpPr>
+        <p:spPr>
+          <a:xfrm>
+            <a:off x="4486503" y="3506724"/>
+            <a:ext cx="292608" cy="256032"/>
+          </a:xfrm>
+          <a:prstGeom prst="roundRect">
+            <a:avLst>
+              <a:gd name="adj" fmla="val 18000"/>
+            </a:avLst>
+          </a:prstGeom>
+          <a:solidFill>
+            <a:srgbClr val="B5822E"/>
+          </a:solidFill>
+          <a:ln>
+            <a:noFill/>
+          </a:ln>
+          <a:effectLst/>
+        </p:spPr>
+        <p:style>
+          <a:lnRef idx="1">
+            <a:schemeClr val="accent1"/>
+          </a:lnRef>
+          <a:fillRef idx="3">
+            <a:schemeClr val="accent1"/>
+          </a:fillRef>
+          <a:effectRef idx="2">
+            <a:schemeClr val="accent1"/>
+          </a:effectRef>
+          <a:fontRef idx="minor">
+            <a:schemeClr val="lt1"/>
+          </a:fontRef>
+        </p:style>
+        <p:txBody>
+          <a:bodyPr rtlCol="0" anchor="ctr"/>
+          <a:lstStyle/>
+          <a:p>
+            <a:pPr algn="ctr"/>
+          </a:p>
+        </p:txBody>
+      </p:sp>
+      <p:sp>
+        <p:nvSpPr>
+          <p:cNvPr id="19" name="Oval 18"/>
+          <p:cNvSpPr/>
+          <p:nvPr/>
+        </p:nvSpPr>
+        <p:spPr>
+          <a:xfrm>
+            <a:off x="4600803" y="3589020"/>
+            <a:ext cx="64008" cy="64008"/>
+          </a:xfrm>
+          <a:prstGeom prst="ellipse">
+            <a:avLst/>
+          </a:prstGeom>
+          <a:solidFill>
+            <a:srgbClr val="FFFFFF"/>
+          </a:solidFill>
+          <a:ln>
+            <a:noFill/>
+          </a:ln>
+          <a:effectLst/>
+        </p:spPr>
+        <p:style>
+          <a:lnRef idx="1">
+            <a:schemeClr val="accent1"/>
+          </a:lnRef>
+          <a:fillRef idx="3">
+            <a:schemeClr val="accent1"/>
+          </a:fillRef>
+          <a:effectRef idx="2">
+            <a:schemeClr val="accent1"/>
+          </a:effectRef>
+          <a:fontRef idx="minor">
+            <a:schemeClr val="lt1"/>
+          </a:fontRef>
+        </p:style>
+        <p:txBody>
+          <a:bodyPr rtlCol="0" anchor="ctr"/>
+          <a:lstStyle/>
+          <a:p>
+            <a:pPr algn="ctr"/>
+          </a:p>
+        </p:txBody>
+      </p:sp>
+      <p:sp>
+        <p:nvSpPr>
+          <p:cNvPr id="20" name="TextBox 19"/>
+          <p:cNvSpPr txBox="1"/>
+          <p:nvPr/>
+        </p:nvSpPr>
+        <p:spPr>
+          <a:xfrm>
+            <a:off x="3544671" y="4160520"/>
+            <a:ext cx="2176272" cy="274320"/>
+          </a:xfrm>
+          <a:prstGeom prst="rect">
+            <a:avLst/>
+          </a:prstGeom>
+          <a:noFill/>
+        </p:spPr>
+        <p:txBody>
+          <a:bodyPr wrap="square" anchor="t" lIns="0" rIns="0" tIns="0" bIns="0">
+            <a:spAutoFit/>
+          </a:bodyPr>
+          <a:lstStyle/>
+          <a:p>
+            <a:pPr algn="ctr">
+              <a:spcAft>
+                <a:spcPts val="0"/>
+              </a:spcAft>
+            </a:pPr>
+            <a:r>
+              <a:rPr sz="1000" b="1" i="0">
+                <a:solidFill>
+                  <a:srgbClr val="B5822E"/>
+                </a:solidFill>
+                <a:latin typeface="Consolas"/>
+              </a:rPr>
+              <a:t>INSTANTLY</a:t>
+            </a:r>
+          </a:p>
+        </p:txBody>
+      </p:sp>
+      <p:sp>
+        <p:nvSpPr>
+          <p:cNvPr id="21" name="TextBox 20"/>
+          <p:cNvSpPr txBox="1"/>
+          <p:nvPr/>
+        </p:nvSpPr>
+        <p:spPr>
+          <a:xfrm>
+            <a:off x="3617823" y="4480560"/>
+            <a:ext cx="2029967" cy="822960"/>
+          </a:xfrm>
+          <a:prstGeom prst="rect">
+            <a:avLst/>
+          </a:prstGeom>
+          <a:noFill/>
+        </p:spPr>
+        <p:txBody>
+          <a:bodyPr wrap="square" anchor="t" lIns="0" rIns="0" tIns="0" bIns="0">
+            <a:spAutoFit/>
+          </a:bodyPr>
+          <a:lstStyle/>
+          <a:p>
+            <a:pPr algn="ctr">
+              <a:lnSpc>
+                <a:spcPct val="108000"/>
+              </a:lnSpc>
+              <a:spcAft>
+                <a:spcPts val="0"/>
+              </a:spcAft>
+            </a:pPr>
+            <a:r>
+              <a:rPr sz="1200" b="0" i="0">
+                <a:solidFill>
+                  <a:srgbClr val="1B2027"/>
+                </a:solidFill>
+                <a:latin typeface="Calibri"/>
+              </a:rPr>
+              <a:t>Saved to your private library — encrypted.</a:t>
+            </a:r>
+          </a:p>
+        </p:txBody>
+      </p:sp>
+      <p:sp>
+        <p:nvSpPr>
+          <p:cNvPr id="22" name="Chevron 21"/>
+          <p:cNvSpPr/>
+          <p:nvPr/>
+        </p:nvSpPr>
+        <p:spPr>
+          <a:xfrm>
+            <a:off x="5949543" y="3982212"/>
+            <a:ext cx="292608" cy="310896"/>
+          </a:xfrm>
+          <a:prstGeom prst="chevron">
+            <a:avLst/>
+          </a:prstGeom>
+          <a:solidFill>
+            <a:srgbClr val="E1DDD2"/>
+          </a:solidFill>
+          <a:ln>
+            <a:noFill/>
+          </a:ln>
+          <a:effectLst/>
+        </p:spPr>
+        <p:style>
+          <a:lnRef idx="1">
+            <a:schemeClr val="accent1"/>
+          </a:lnRef>
+          <a:fillRef idx="3">
+            <a:schemeClr val="accent1"/>
+          </a:fillRef>
+          <a:effectRef idx="2">
+            <a:schemeClr val="accent1"/>
+          </a:effectRef>
+          <a:fontRef idx="minor">
+            <a:schemeClr val="lt1"/>
+          </a:fontRef>
+        </p:style>
+        <p:txBody>
+          <a:bodyPr rtlCol="0" anchor="ctr"/>
+          <a:lstStyle/>
+          <a:p>
+            <a:pPr algn="ctr"/>
+          </a:p>
+        </p:txBody>
+      </p:sp>
+      <p:sp>
+        <p:nvSpPr>
+          <p:cNvPr id="23" name="Rounded Rectangle 22"/>
+          <p:cNvSpPr/>
+          <p:nvPr/>
+        </p:nvSpPr>
+        <p:spPr>
+          <a:xfrm>
+            <a:off x="6287871" y="2880360"/>
+            <a:ext cx="2542032" cy="2514600"/>
+          </a:xfrm>
+          <a:prstGeom prst="roundRect">
+            <a:avLst>
+              <a:gd name="adj" fmla="val 6000"/>
+            </a:avLst>
+          </a:prstGeom>
+          <a:solidFill>
+            <a:srgbClr val="FFFFFF"/>
+          </a:solidFill>
+          <a:ln w="12700">
+            <a:solidFill>
+              <a:srgbClr val="E1DDD2"/>
+            </a:solidFill>
+          </a:ln>
+          <a:effectLst/>
+        </p:spPr>
+        <p:style>
+          <a:lnRef idx="1">
+            <a:schemeClr val="accent1"/>
+          </a:lnRef>
+          <a:fillRef idx="3">
+            <a:schemeClr val="accent1"/>
+          </a:fillRef>
+          <a:effectRef idx="2">
+            <a:schemeClr val="accent1"/>
+          </a:effectRef>
+          <a:fontRef idx="minor">
+            <a:schemeClr val="lt1"/>
+          </a:fontRef>
+        </p:style>
+        <p:txBody>
+          <a:bodyPr rtlCol="0" anchor="ctr"/>
+          <a:lstStyle/>
+          <a:p>
+            <a:pPr algn="ctr"/>
+          </a:p>
+        </p:txBody>
+      </p:sp>
+      <p:sp>
+        <p:nvSpPr>
+          <p:cNvPr id="24" name="Rounded Rectangle 23"/>
+          <p:cNvSpPr/>
+          <p:nvPr/>
+        </p:nvSpPr>
+        <p:spPr>
+          <a:xfrm>
+            <a:off x="7170267" y="3172968"/>
+            <a:ext cx="777240" cy="777240"/>
+          </a:xfrm>
+          <a:prstGeom prst="roundRect">
+            <a:avLst>
+              <a:gd name="adj" fmla="val 25000"/>
+            </a:avLst>
+          </a:prstGeom>
+          <a:solidFill>
+            <a:srgbClr val="E6ECF4"/>
+          </a:solidFill>
+          <a:ln w="12700">
+            <a:solidFill>
+              <a:srgbClr val="2E4A6B"/>
+            </a:solidFill>
+          </a:ln>
+          <a:effectLst/>
+        </p:spPr>
+        <p:style>
+          <a:lnRef idx="1">
+            <a:schemeClr val="accent1"/>
+          </a:lnRef>
+          <a:fillRef idx="3">
+            <a:schemeClr val="accent1"/>
+          </a:fillRef>
+          <a:effectRef idx="2">
+            <a:schemeClr val="accent1"/>
+          </a:effectRef>
+          <a:fontRef idx="minor">
+            <a:schemeClr val="lt1"/>
+          </a:fontRef>
+        </p:style>
+        <p:txBody>
+          <a:bodyPr rtlCol="0" anchor="ctr"/>
+          <a:lstStyle/>
+          <a:p>
+            <a:pPr algn="ctr"/>
+          </a:p>
+        </p:txBody>
+      </p:sp>
+      <p:sp>
+        <p:nvSpPr>
+          <p:cNvPr id="25" name="Rounded Rectangle 24"/>
+          <p:cNvSpPr/>
+          <p:nvPr/>
+        </p:nvSpPr>
+        <p:spPr>
+          <a:xfrm>
+            <a:off x="7376007" y="3415284"/>
+            <a:ext cx="365760" cy="292608"/>
+          </a:xfrm>
+          <a:prstGeom prst="roundRect">
+            <a:avLst>
+              <a:gd name="adj" fmla="val 12000"/>
+            </a:avLst>
+          </a:prstGeom>
+          <a:noFill/>
+          <a:ln w="25400">
+            <a:solidFill>
+              <a:srgbClr val="2E4A6B"/>
+            </a:solidFill>
+          </a:ln>
+          <a:effectLst/>
+        </p:spPr>
+        <p:style>
+          <a:lnRef idx="1">
+            <a:schemeClr val="accent1"/>
+          </a:lnRef>
+          <a:fillRef idx="3">
+            <a:schemeClr val="accent1"/>
+          </a:fillRef>
+          <a:effectRef idx="2">
+            <a:schemeClr val="accent1"/>
+          </a:effectRef>
+          <a:fontRef idx="minor">
+            <a:schemeClr val="lt1"/>
+          </a:fontRef>
+        </p:style>
+        <p:txBody>
+          <a:bodyPr rtlCol="0" anchor="ctr"/>
+          <a:lstStyle/>
+          <a:p>
+            <a:pPr algn="ctr"/>
+          </a:p>
+        </p:txBody>
+      </p:sp>
+      <p:sp>
+        <p:nvSpPr>
+          <p:cNvPr id="26" name="TextBox 25"/>
+          <p:cNvSpPr txBox="1"/>
+          <p:nvPr/>
+        </p:nvSpPr>
+        <p:spPr>
+          <a:xfrm>
+            <a:off x="6470751" y="4160520"/>
+            <a:ext cx="2176272" cy="274320"/>
+          </a:xfrm>
+          <a:prstGeom prst="rect">
+            <a:avLst/>
+          </a:prstGeom>
+          <a:noFill/>
+        </p:spPr>
+        <p:txBody>
+          <a:bodyPr wrap="square" anchor="t" lIns="0" rIns="0" tIns="0" bIns="0">
+            <a:spAutoFit/>
+          </a:bodyPr>
+          <a:lstStyle/>
+          <a:p>
+            <a:pPr algn="ctr">
+              <a:spcAft>
+                <a:spcPts val="0"/>
+              </a:spcAft>
+            </a:pPr>
+            <a:r>
+              <a:rPr sz="1000" b="1" i="0">
+                <a:solidFill>
+                  <a:srgbClr val="2E4A6B"/>
+                </a:solidFill>
+                <a:latin typeface="Consolas"/>
+              </a:rPr>
+              <a:t>AT HOME</a:t>
+            </a:r>
+          </a:p>
+        </p:txBody>
+      </p:sp>
+      <p:sp>
+        <p:nvSpPr>
+          <p:cNvPr id="27" name="TextBox 26"/>
+          <p:cNvSpPr txBox="1"/>
+          <p:nvPr/>
+        </p:nvSpPr>
+        <p:spPr>
+          <a:xfrm>
+            <a:off x="6543903" y="4480560"/>
+            <a:ext cx="2029967" cy="822960"/>
+          </a:xfrm>
+          <a:prstGeom prst="rect">
+            <a:avLst/>
+          </a:prstGeom>
+          <a:noFill/>
+        </p:spPr>
+        <p:txBody>
+          <a:bodyPr wrap="square" anchor="t" lIns="0" rIns="0" tIns="0" bIns="0">
+            <a:spAutoFit/>
+          </a:bodyPr>
+          <a:lstStyle/>
+          <a:p>
+            <a:pPr algn="ctr">
+              <a:lnSpc>
+                <a:spcPct val="108000"/>
+              </a:lnSpc>
+              <a:spcAft>
+                <a:spcPts val="0"/>
+              </a:spcAft>
+            </a:pPr>
+            <a:r>
+              <a:rPr sz="1200" b="0" i="0">
+                <a:solidFill>
+                  <a:srgbClr val="1B2027"/>
+                </a:solidFill>
+                <a:latin typeface="Calibri"/>
+              </a:rPr>
+              <a:t>Open the tablet — it's already there.</a:t>
+            </a:r>
+          </a:p>
+        </p:txBody>
+      </p:sp>
+      <p:sp>
+        <p:nvSpPr>
+          <p:cNvPr id="28" name="Chevron 27"/>
+          <p:cNvSpPr/>
+          <p:nvPr/>
+        </p:nvSpPr>
+        <p:spPr>
+          <a:xfrm>
+            <a:off x="8875623" y="3982212"/>
+            <a:ext cx="292608" cy="310896"/>
+          </a:xfrm>
+          <a:prstGeom prst="chevron">
+            <a:avLst/>
+          </a:prstGeom>
+          <a:solidFill>
+            <a:srgbClr val="E1DDD2"/>
+          </a:solidFill>
+          <a:ln>
+            <a:noFill/>
+          </a:ln>
+          <a:effectLst/>
+        </p:spPr>
+        <p:style>
+          <a:lnRef idx="1">
+            <a:schemeClr val="accent1"/>
+          </a:lnRef>
+          <a:fillRef idx="3">
+            <a:schemeClr val="accent1"/>
+          </a:fillRef>
+          <a:effectRef idx="2">
+            <a:schemeClr val="accent1"/>
+          </a:effectRef>
+          <a:fontRef idx="minor">
+            <a:schemeClr val="lt1"/>
+          </a:fontRef>
+        </p:style>
+        <p:txBody>
+          <a:bodyPr rtlCol="0" anchor="ctr"/>
+          <a:lstStyle/>
+          <a:p>
+            <a:pPr algn="ctr"/>
+          </a:p>
+        </p:txBody>
+      </p:sp>
+      <p:sp>
+        <p:nvSpPr>
+          <p:cNvPr id="29" name="Rounded Rectangle 28"/>
+          <p:cNvSpPr/>
+          <p:nvPr/>
+        </p:nvSpPr>
+        <p:spPr>
+          <a:xfrm>
+            <a:off x="9213951" y="2880360"/>
+            <a:ext cx="2542032" cy="2514600"/>
+          </a:xfrm>
+          <a:prstGeom prst="roundRect">
+            <a:avLst>
+              <a:gd name="adj" fmla="val 6000"/>
+            </a:avLst>
+          </a:prstGeom>
+          <a:solidFill>
+            <a:srgbClr val="FFFFFF"/>
+          </a:solidFill>
+          <a:ln w="12700">
+            <a:solidFill>
+              <a:srgbClr val="E1DDD2"/>
+            </a:solidFill>
+          </a:ln>
+          <a:effectLst/>
+        </p:spPr>
+        <p:style>
+          <a:lnRef idx="1">
+            <a:schemeClr val="accent1"/>
+          </a:lnRef>
+          <a:fillRef idx="3">
+            <a:schemeClr val="accent1"/>
+          </a:fillRef>
+          <a:effectRef idx="2">
+            <a:schemeClr val="accent1"/>
+          </a:effectRef>
+          <a:fontRef idx="minor">
+            <a:schemeClr val="lt1"/>
+          </a:fontRef>
+        </p:style>
+        <p:txBody>
+          <a:bodyPr rtlCol="0" anchor="ctr"/>
+          <a:lstStyle/>
+          <a:p>
+            <a:pPr algn="ctr"/>
+          </a:p>
+        </p:txBody>
+      </p:sp>
+      <p:sp>
+        <p:nvSpPr>
+          <p:cNvPr id="30" name="Rounded Rectangle 29"/>
+          <p:cNvSpPr/>
+          <p:nvPr/>
+        </p:nvSpPr>
+        <p:spPr>
+          <a:xfrm>
+            <a:off x="10096347" y="3172968"/>
+            <a:ext cx="777240" cy="777240"/>
+          </a:xfrm>
+          <a:prstGeom prst="roundRect">
+            <a:avLst>
+              <a:gd name="adj" fmla="val 25000"/>
+            </a:avLst>
+          </a:prstGeom>
+          <a:solidFill>
+            <a:srgbClr val="E6ECF4"/>
+          </a:solidFill>
+          <a:ln w="12700">
+            <a:solidFill>
+              <a:srgbClr val="2E4A6B"/>
+            </a:solidFill>
+          </a:ln>
+          <a:effectLst/>
+        </p:spPr>
+        <p:style>
+          <a:lnRef idx="1">
+            <a:schemeClr val="accent1"/>
+          </a:lnRef>
+          <a:fillRef idx="3">
+            <a:schemeClr val="accent1"/>
+          </a:fillRef>
+          <a:effectRef idx="2">
+            <a:schemeClr val="accent1"/>
+          </a:effectRef>
+          <a:fontRef idx="minor">
+            <a:schemeClr val="lt1"/>
+          </a:fontRef>
+        </p:style>
+        <p:txBody>
+          <a:bodyPr rtlCol="0" anchor="ctr"/>
+          <a:lstStyle/>
+          <a:p>
+            <a:pPr algn="ctr"/>
+          </a:p>
+        </p:txBody>
+      </p:sp>
+      <p:sp>
+        <p:nvSpPr>
+          <p:cNvPr id="31" name="Rounded Rectangle 30"/>
+          <p:cNvSpPr/>
+          <p:nvPr/>
+        </p:nvSpPr>
+        <p:spPr>
+          <a:xfrm>
+            <a:off x="10302087" y="3378708"/>
+            <a:ext cx="365760" cy="274320"/>
+          </a:xfrm>
+          <a:prstGeom prst="roundRect">
+            <a:avLst>
+              <a:gd name="adj" fmla="val 10000"/>
+            </a:avLst>
+          </a:prstGeom>
+          <a:noFill/>
+          <a:ln w="25400">
+            <a:solidFill>
+              <a:srgbClr val="2E4A6B"/>
+            </a:solidFill>
+          </a:ln>
+          <a:effectLst/>
+        </p:spPr>
+        <p:style>
+          <a:lnRef idx="1">
+            <a:schemeClr val="accent1"/>
+          </a:lnRef>
+          <a:fillRef idx="3">
+            <a:schemeClr val="accent1"/>
+          </a:fillRef>
+          <a:effectRef idx="2">
+            <a:schemeClr val="accent1"/>
+          </a:effectRef>
+          <a:fontRef idx="minor">
+            <a:schemeClr val="lt1"/>
+          </a:fontRef>
+        </p:style>
+        <p:txBody>
+          <a:bodyPr rtlCol="0" anchor="ctr"/>
+          <a:lstStyle/>
+          <a:p>
+            <a:pPr algn="ctr"/>
+          </a:p>
+        </p:txBody>
+      </p:sp>
+      <p:sp>
+        <p:nvSpPr>
+          <p:cNvPr id="32" name="Rectangle 31"/>
+          <p:cNvSpPr/>
+          <p:nvPr/>
+        </p:nvSpPr>
+        <p:spPr>
+          <a:xfrm>
+            <a:off x="10238079" y="3653028"/>
+            <a:ext cx="493776" cy="45720"/>
+          </a:xfrm>
+          <a:prstGeom prst="rect">
+            <a:avLst/>
+          </a:prstGeom>
+          <a:solidFill>
+            <a:srgbClr val="2E4A6B"/>
+          </a:solidFill>
+          <a:ln>
+            <a:noFill/>
+          </a:ln>
+          <a:effectLst/>
+        </p:spPr>
+        <p:style>
+          <a:lnRef idx="1">
+            <a:schemeClr val="accent1"/>
+          </a:lnRef>
+          <a:fillRef idx="3">
+            <a:schemeClr val="accent1"/>
+          </a:fillRef>
+          <a:effectRef idx="2">
+            <a:schemeClr val="accent1"/>
+          </a:effectRef>
+          <a:fontRef idx="minor">
+            <a:schemeClr val="lt1"/>
+          </a:fontRef>
+        </p:style>
+        <p:txBody>
+          <a:bodyPr rtlCol="0" anchor="ctr"/>
+          <a:lstStyle/>
+          <a:p>
+            <a:pPr algn="ctr"/>
+          </a:p>
+        </p:txBody>
+      </p:sp>
+      <p:sp>
+        <p:nvSpPr>
+          <p:cNvPr id="33" name="TextBox 32"/>
+          <p:cNvSpPr txBox="1"/>
+          <p:nvPr/>
+        </p:nvSpPr>
+        <p:spPr>
+          <a:xfrm>
+            <a:off x="9396831" y="4160520"/>
+            <a:ext cx="2176272" cy="274320"/>
+          </a:xfrm>
+          <a:prstGeom prst="rect">
+            <a:avLst/>
+          </a:prstGeom>
+          <a:noFill/>
+        </p:spPr>
+        <p:txBody>
+          <a:bodyPr wrap="square" anchor="t" lIns="0" rIns="0" tIns="0" bIns="0">
+            <a:spAutoFit/>
+          </a:bodyPr>
+          <a:lstStyle/>
+          <a:p>
+            <a:pPr algn="ctr">
+              <a:spcAft>
+                <a:spcPts val="0"/>
+              </a:spcAft>
+            </a:pPr>
+            <a:r>
+              <a:rPr sz="1000" b="1" i="0">
+                <a:solidFill>
+                  <a:srgbClr val="2E4A6B"/>
+                </a:solidFill>
+                <a:latin typeface="Consolas"/>
+              </a:rPr>
+              <a:t>LATER</a:t>
+            </a:r>
+          </a:p>
+        </p:txBody>
+      </p:sp>
+      <p:sp>
+        <p:nvSpPr>
+          <p:cNvPr id="34" name="TextBox 33"/>
+          <p:cNvSpPr txBox="1"/>
+          <p:nvPr/>
+        </p:nvSpPr>
+        <p:spPr>
+          <a:xfrm>
+            <a:off x="9469983" y="4480560"/>
+            <a:ext cx="2029967" cy="822960"/>
+          </a:xfrm>
+          <a:prstGeom prst="rect">
+            <a:avLst/>
+          </a:prstGeom>
+          <a:noFill/>
+        </p:spPr>
+        <p:txBody>
+          <a:bodyPr wrap="square" anchor="t" lIns="0" rIns="0" tIns="0" bIns="0">
+            <a:spAutoFit/>
+          </a:bodyPr>
+          <a:lstStyle/>
+          <a:p>
+            <a:pPr algn="ctr">
+              <a:lnSpc>
+                <a:spcPct val="108000"/>
+              </a:lnSpc>
+              <a:spcAft>
+                <a:spcPts val="0"/>
+              </a:spcAft>
+            </a:pPr>
+            <a:r>
+              <a:rPr sz="1200" b="0" i="0">
+                <a:solidFill>
+                  <a:srgbClr val="1B2027"/>
+                </a:solidFill>
+                <a:latin typeface="Calibri"/>
+              </a:rPr>
+              <a:t>Publish from your laptop — now on every device.</a:t>
+            </a:r>
+          </a:p>
+        </p:txBody>
+      </p:sp>
+      <p:sp>
+        <p:nvSpPr>
+          <p:cNvPr id="35" name="TextBox 34"/>
+          <p:cNvSpPr txBox="1"/>
+          <p:nvPr/>
+        </p:nvSpPr>
+        <p:spPr>
+          <a:xfrm>
+            <a:off x="822960" y="5760720"/>
+            <a:ext cx="10515600" cy="365760"/>
+          </a:xfrm>
+          <a:prstGeom prst="rect">
+            <a:avLst/>
+          </a:prstGeom>
+          <a:noFill/>
+        </p:spPr>
+        <p:txBody>
+          <a:bodyPr wrap="square" anchor="t" lIns="0" rIns="0" tIns="0" bIns="0">
+            <a:spAutoFit/>
+          </a:bodyPr>
+          <a:lstStyle/>
+          <a:p>
+            <a:pPr algn="ctr">
+              <a:spcAft>
+                <a:spcPts val="0"/>
+              </a:spcAft>
+            </a:pPr>
+            <a:r>
+              <a:rPr sz="1150" b="0" i="1">
+                <a:solidFill>
+                  <a:srgbClr val="5B6470"/>
+                </a:solidFill>
+                <a:latin typeface="Calibri"/>
+              </a:rPr>
+              <a:t>No copying files around, no “which device has the latest?” — the library is the source of truth.</a:t>
+            </a:r>
+          </a:p>
+        </p:txBody>
+      </p:sp>
+    </p:spTree>
+  </p:cSld>
+  <p:clrMapOvr>
+    <a:masterClrMapping/>
+  </p:clrMapOvr>
+</p:sld>
+</file>
+
+<file path=ppt/slides/slide5.xml><?xml version="1.0" encoding="utf-8"?>
+<p:sld xmlns:a="http://schemas.openxmlformats.org/drawingml/2006/main" xmlns:p="http://schemas.openxmlformats.org/presentationml/2006/main" xmlns:r="http://schemas.openxmlformats.org/officeDocument/2006/relationships">
+  <p:cSld>
+    <p:spTree>
+      <p:nvGrpSpPr>
+        <p:cNvPr id="1" name=""/>
+        <p:cNvGrpSpPr/>
+        <p:nvPr/>
+      </p:nvGrpSpPr>
+      <p:grpSpPr/>
+      <p:sp>
+        <p:nvSpPr>
+          <p:cNvPr id="2" name="Rectangle 1"/>
+          <p:cNvSpPr/>
+          <p:nvPr/>
+        </p:nvSpPr>
+        <p:spPr>
+          <a:xfrm>
+            <a:off x="0" y="0"/>
+            <a:ext cx="12191695" cy="6858000"/>
+          </a:xfrm>
+          <a:prstGeom prst="rect">
+            <a:avLst/>
+          </a:prstGeom>
+          <a:solidFill>
+            <a:srgbClr val="FBFAF7"/>
+          </a:solidFill>
+          <a:ln>
+            <a:noFill/>
+          </a:ln>
+          <a:effectLst/>
+        </p:spPr>
+        <p:style>
+          <a:lnRef idx="1">
+            <a:schemeClr val="accent1"/>
+          </a:lnRef>
+          <a:fillRef idx="3">
+            <a:schemeClr val="accent1"/>
+          </a:fillRef>
+          <a:effectRef idx="2">
+            <a:schemeClr val="accent1"/>
+          </a:effectRef>
+          <a:fontRef idx="minor">
+            <a:schemeClr val="lt1"/>
+          </a:fontRef>
+        </p:style>
+        <p:txBody>
+          <a:bodyPr rtlCol="0" anchor="ctr"/>
+          <a:lstStyle/>
+          <a:p>
+            <a:pPr algn="ctr"/>
+          </a:p>
+        </p:txBody>
+      </p:sp>
+      <p:sp>
+        <p:nvSpPr>
+          <p:cNvPr id="3" name="TextBox 2"/>
+          <p:cNvSpPr txBox="1"/>
+          <p:nvPr/>
+        </p:nvSpPr>
+        <p:spPr>
+          <a:xfrm>
+            <a:off x="822960" y="566928"/>
+            <a:ext cx="10515600" cy="365760"/>
+          </a:xfrm>
+          <a:prstGeom prst="rect">
+            <a:avLst/>
+          </a:prstGeom>
+          <a:noFill/>
+        </p:spPr>
+        <p:txBody>
+          <a:bodyPr wrap="square" anchor="t" lIns="0" rIns="0" tIns="0" bIns="0">
+            <a:spAutoFit/>
+          </a:bodyPr>
+          <a:lstStyle/>
+          <a:p>
+            <a:pPr algn="l">
+              <a:spcAft>
+                <a:spcPts val="0"/>
+              </a:spcAft>
+            </a:pPr>
+            <a:r>
+              <a:rPr sz="1100" b="0" i="0">
+                <a:solidFill>
+                  <a:srgbClr val="5B6470"/>
+                </a:solidFill>
+                <a:latin typeface="Consolas"/>
+              </a:rPr>
+              <a:t>THREE PICTURES TO EXPLAIN IT</a:t>
+            </a:r>
+          </a:p>
+        </p:txBody>
+      </p:sp>
+      <p:sp>
+        <p:nvSpPr>
+          <p:cNvPr id="4" name="TextBox 3"/>
+          <p:cNvSpPr txBox="1"/>
+          <p:nvPr/>
+        </p:nvSpPr>
+        <p:spPr>
+          <a:xfrm>
+            <a:off x="822960" y="914400"/>
+            <a:ext cx="10515600" cy="822960"/>
+          </a:xfrm>
+          <a:prstGeom prst="rect">
+            <a:avLst/>
+          </a:prstGeom>
+          <a:noFill/>
+        </p:spPr>
+        <p:txBody>
+          <a:bodyPr wrap="square" anchor="t" lIns="0" rIns="0" tIns="0" bIns="0">
+            <a:spAutoFit/>
+          </a:bodyPr>
+          <a:lstStyle/>
+          <a:p>
+            <a:pPr algn="l">
+              <a:spcAft>
+                <a:spcPts val="0"/>
+              </a:spcAft>
+            </a:pPr>
+            <a:r>
+              <a:rPr sz="3000" b="1" i="0">
+                <a:solidFill>
+                  <a:srgbClr val="1B2027"/>
+                </a:solidFill>
+                <a:latin typeface="Georgia"/>
+              </a:rPr>
+              <a:t>Three pictures to explain it</a:t>
+            </a:r>
+          </a:p>
+        </p:txBody>
+      </p:sp>
+      <p:sp>
+        <p:nvSpPr>
+          <p:cNvPr id="5" name="TextBox 4"/>
+          <p:cNvSpPr txBox="1"/>
+          <p:nvPr/>
+        </p:nvSpPr>
+        <p:spPr>
+          <a:xfrm>
+            <a:off x="822960" y="1627632"/>
+            <a:ext cx="10058400" cy="457200"/>
+          </a:xfrm>
+          <a:prstGeom prst="rect">
+            <a:avLst/>
+          </a:prstGeom>
+          <a:noFill/>
+        </p:spPr>
+        <p:txBody>
+          <a:bodyPr wrap="square" anchor="t" lIns="0" rIns="0" tIns="0" bIns="0">
+            <a:spAutoFit/>
+          </a:bodyPr>
+          <a:lstStyle/>
+          <a:p>
+            <a:pPr algn="l">
+              <a:spcAft>
+                <a:spcPts val="0"/>
+              </a:spcAft>
+            </a:pPr>
+            <a:r>
+              <a:rPr sz="1400" b="0" i="0">
+                <a:solidFill>
+                  <a:srgbClr val="5B6470"/>
+                </a:solidFill>
+                <a:latin typeface="Calibri"/>
+              </a:rPr>
+              <a:t>Each is a plain-language way to describe the choice.</a:t>
+            </a:r>
+          </a:p>
+        </p:txBody>
+      </p:sp>
+      <p:sp>
+        <p:nvSpPr>
+          <p:cNvPr id="6" name="Rounded Rectangle 5"/>
+          <p:cNvSpPr/>
+          <p:nvPr/>
+        </p:nvSpPr>
+        <p:spPr>
+          <a:xfrm>
+            <a:off x="623163" y="2468880"/>
+            <a:ext cx="3429000" cy="3703320"/>
+          </a:xfrm>
+          <a:prstGeom prst="roundRect">
+            <a:avLst>
+              <a:gd name="adj" fmla="val 5000"/>
+            </a:avLst>
+          </a:prstGeom>
+          <a:solidFill>
+            <a:srgbClr val="FFFFFF"/>
+          </a:solidFill>
+          <a:ln w="12700">
+            <a:solidFill>
+              <a:srgbClr val="E1DDD2"/>
+            </a:solidFill>
+          </a:ln>
+          <a:effectLst/>
+        </p:spPr>
+        <p:style>
+          <a:lnRef idx="1">
+            <a:schemeClr val="accent1"/>
+          </a:lnRef>
+          <a:fillRef idx="3">
+            <a:schemeClr val="accent1"/>
+          </a:fillRef>
+          <a:effectRef idx="2">
+            <a:schemeClr val="accent1"/>
+          </a:effectRef>
+          <a:fontRef idx="minor">
+            <a:schemeClr val="lt1"/>
+          </a:fontRef>
+        </p:style>
+        <p:txBody>
+          <a:bodyPr rtlCol="0" anchor="ctr"/>
+          <a:lstStyle/>
+          <a:p>
+            <a:pPr algn="ctr"/>
+          </a:p>
+        </p:txBody>
+      </p:sp>
+      <p:sp>
+        <p:nvSpPr>
           <p:cNvPr id="7" name="Rounded Rectangle 6"/>
           <p:cNvSpPr/>
           <p:nvPr/>
@@ -8760,7 +11094,7 @@
 </p:sld>
 </file>
 
-<file path=ppt/slides/slide5.xml><?xml version="1.0" encoding="utf-8"?>
+<file path=ppt/slides/slide6.xml><?xml version="1.0" encoding="utf-8"?>
 <p:sld xmlns:a="http://schemas.openxmlformats.org/drawingml/2006/main" xmlns:p="http://schemas.openxmlformats.org/presentationml/2006/main" xmlns:r="http://schemas.openxmlformats.org/officeDocument/2006/relationships">
   <p:cSld>
     <p:spTree>

</xml_diff>